<commit_message>
Atualiza pacote mensal da indústria CVM em 10/10/2026
</commit_message>
<xml_diff>
--- a/data/industry_study/generated_revision/industry_executive_revised.pptx
+++ b/data/industry_study/generated_revision/industry_executive_revised.pptx
@@ -2,27 +2,27 @@
 <file path=ppt/presentation.xml><?xml version="1.0" encoding="utf-8"?>
 <p:presentation xmlns:p="http://schemas.openxmlformats.org/presentationml/2006/main">
   <p:sldMasterIdLst>
-    <p:sldMasterId xmlns:r="http://schemas.openxmlformats.org/officeDocument/2006/relationships" id="2147483648" r:id="Raad13d51834a4685"/>
+    <p:sldMasterId xmlns:r="http://schemas.openxmlformats.org/officeDocument/2006/relationships" id="2147483648" r:id="R06935124f1734c89"/>
   </p:sldMasterIdLst>
   <p:notesMasterIdLst>
-    <p:notesMasterId xmlns:r="http://schemas.openxmlformats.org/officeDocument/2006/relationships" r:id="Raa1c4c60ce134dcd"/>
+    <p:notesMasterId xmlns:r="http://schemas.openxmlformats.org/officeDocument/2006/relationships" r:id="R55797e2bd1124519"/>
   </p:notesMasterIdLst>
   <p:sldIdLst>
-    <p:sldId xmlns:r="http://schemas.openxmlformats.org/officeDocument/2006/relationships" id="256" r:id="Rbf5021fb0532461d"/>
-    <p:sldId xmlns:r="http://schemas.openxmlformats.org/officeDocument/2006/relationships" id="257" r:id="R0558bcf38eab47bb"/>
-    <p:sldId xmlns:r="http://schemas.openxmlformats.org/officeDocument/2006/relationships" id="258" r:id="R9b10faccc3414146"/>
-    <p:sldId xmlns:r="http://schemas.openxmlformats.org/officeDocument/2006/relationships" id="259" r:id="Rf5d0102e97d04327"/>
-    <p:sldId xmlns:r="http://schemas.openxmlformats.org/officeDocument/2006/relationships" id="260" r:id="R76d8a544e44b4ba0"/>
-    <p:sldId xmlns:r="http://schemas.openxmlformats.org/officeDocument/2006/relationships" id="261" r:id="R01917175baf74115"/>
-    <p:sldId xmlns:r="http://schemas.openxmlformats.org/officeDocument/2006/relationships" id="262" r:id="R2f1ea658ff3c46b6"/>
-    <p:sldId xmlns:r="http://schemas.openxmlformats.org/officeDocument/2006/relationships" id="263" r:id="R85aaffa18e4b4f12"/>
-    <p:sldId xmlns:r="http://schemas.openxmlformats.org/officeDocument/2006/relationships" id="264" r:id="R39fce78dd9ee4e14"/>
-    <p:sldId xmlns:r="http://schemas.openxmlformats.org/officeDocument/2006/relationships" id="265" r:id="R37a0ffe1a45e4fd5"/>
-    <p:sldId xmlns:r="http://schemas.openxmlformats.org/officeDocument/2006/relationships" id="266" r:id="Rc6da3a34983d4797"/>
-    <p:sldId xmlns:r="http://schemas.openxmlformats.org/officeDocument/2006/relationships" id="267" r:id="R69b313ed2a9c484c"/>
-    <p:sldId xmlns:r="http://schemas.openxmlformats.org/officeDocument/2006/relationships" id="268" r:id="R3fdd2398c4454568"/>
-    <p:sldId xmlns:r="http://schemas.openxmlformats.org/officeDocument/2006/relationships" id="269" r:id="R1a9b7e2ca5ca4d47"/>
-    <p:sldId xmlns:r="http://schemas.openxmlformats.org/officeDocument/2006/relationships" id="270" r:id="Rd31a8632ee214091"/>
+    <p:sldId xmlns:r="http://schemas.openxmlformats.org/officeDocument/2006/relationships" id="256" r:id="R9e67a04cb5eb4a7f"/>
+    <p:sldId xmlns:r="http://schemas.openxmlformats.org/officeDocument/2006/relationships" id="257" r:id="R0227e9142e224aa6"/>
+    <p:sldId xmlns:r="http://schemas.openxmlformats.org/officeDocument/2006/relationships" id="258" r:id="Rd88275e384e64181"/>
+    <p:sldId xmlns:r="http://schemas.openxmlformats.org/officeDocument/2006/relationships" id="259" r:id="R24ed9d5d654a4c71"/>
+    <p:sldId xmlns:r="http://schemas.openxmlformats.org/officeDocument/2006/relationships" id="260" r:id="R5f4e9b8f8e7d4f55"/>
+    <p:sldId xmlns:r="http://schemas.openxmlformats.org/officeDocument/2006/relationships" id="261" r:id="Ra62af334ff03499d"/>
+    <p:sldId xmlns:r="http://schemas.openxmlformats.org/officeDocument/2006/relationships" id="262" r:id="Rbf1855ebd8874999"/>
+    <p:sldId xmlns:r="http://schemas.openxmlformats.org/officeDocument/2006/relationships" id="263" r:id="R710086995abc4aaa"/>
+    <p:sldId xmlns:r="http://schemas.openxmlformats.org/officeDocument/2006/relationships" id="264" r:id="R4ed9b98148574f7e"/>
+    <p:sldId xmlns:r="http://schemas.openxmlformats.org/officeDocument/2006/relationships" id="265" r:id="R96f9378dd5d24832"/>
+    <p:sldId xmlns:r="http://schemas.openxmlformats.org/officeDocument/2006/relationships" id="266" r:id="Rc46aa4764d964b5e"/>
+    <p:sldId xmlns:r="http://schemas.openxmlformats.org/officeDocument/2006/relationships" id="267" r:id="R834e0f2047e144ed"/>
+    <p:sldId xmlns:r="http://schemas.openxmlformats.org/officeDocument/2006/relationships" id="268" r:id="R84d286cde60f46be"/>
+    <p:sldId xmlns:r="http://schemas.openxmlformats.org/officeDocument/2006/relationships" id="269" r:id="Rbb2e8ac0f4dd4a80"/>
+    <p:sldId xmlns:r="http://schemas.openxmlformats.org/officeDocument/2006/relationships" id="270" r:id="Rf3dfcdd5ebc74d97"/>
   </p:sldIdLst>
   <p:sldSz cx="12192000" cy="6858000"/>
   <p:notesSz cx="6858000" cy="9144000"/>
@@ -481,7 +481,7 @@
           </a:p>
           <a:p xmlns:a="http://schemas.openxmlformats.org/drawingml/2006/main">
             <a:r>
-              <a:t>[Industry contract] {"id":"cover","latest_complete":"2026-08","offers_as_of":"2026-08-31","executive_conclusions":5,"source_signature":"c4c868a5e5924b391ec6b611ee7484f13bf36737f0991d1d518c8985263aa45c"}</a:t>
+              <a:t>[Industry contract] {"id":"cover","latest_complete":"2026-08","offers_as_of":"2026-08-31","executive_conclusions":5,"source_signature":"bb4e976173eaad01107647a7305e770e2018fa6a22fbbb5ae19b05948b59652a"}</a:t>
             </a:r>
           </a:p>
         </p:txBody>
@@ -556,7 +556,7 @@
           </a:p>
           <a:p xmlns:a="http://schemas.openxmlformats.org/drawingml/2006/main">
             <a:r>
-              <a:t>Fonte: CVM/SRE, dois arquivos de ofertas, snapshot 8/out/26. jan–ago/26; regime declarado; campo ausente = Não informado.</a:t>
+              <a:t>Fonte: CVM/SRE, dois arquivos de ofertas, snapshot 10/out/26. jan–ago/26; regime declarado; campo ausente = Não informado.</a:t>
             </a:r>
           </a:p>
           <a:p xmlns:a="http://schemas.openxmlformats.org/drawingml/2006/main">
@@ -601,7 +601,7 @@
           </a:p>
           <a:p xmlns:a="http://schemas.openxmlformats.org/drawingml/2006/main">
             <a:r>
-              <a:t>[Industry contract] {"id":"offers_placement_regime","latest_complete":"2026-08","offers_as_of":"2026-08-31","executive_conclusions":5,"source_signature":"c4c868a5e5924b391ec6b611ee7484f13bf36737f0991d1d518c8985263aa45c"}</a:t>
+              <a:t>[Industry contract] {"id":"offers_placement_regime","latest_complete":"2026-08","offers_as_of":"2026-08-31","executive_conclusions":5,"source_signature":"bb4e976173eaad01107647a7305e770e2018fa6a22fbbb5ae19b05948b59652a"}</a:t>
             </a:r>
           </a:p>
         </p:txBody>
@@ -736,7 +736,7 @@
           </a:p>
           <a:p xmlns:a="http://schemas.openxmlformats.org/drawingml/2006/main">
             <a:r>
-              <a:t>[Industry contract] {"id":"conclusions","latest_complete":"2026-08","offers_as_of":"2026-08-31","executive_conclusions":5,"source_signature":"c4c868a5e5924b391ec6b611ee7484f13bf36737f0991d1d518c8985263aa45c"}</a:t>
+              <a:t>[Industry contract] {"id":"conclusions","latest_complete":"2026-08","offers_as_of":"2026-08-31","executive_conclusions":5,"source_signature":"bb4e976173eaad01107647a7305e770e2018fa6a22fbbb5ae19b05948b59652a"}</a:t>
             </a:r>
           </a:p>
         </p:txBody>
@@ -821,7 +821,7 @@
           </a:p>
           <a:p xmlns:a="http://schemas.openxmlformats.org/drawingml/2006/main">
             <a:r>
-              <a:t>[Industry contract] {"id":"provider_history","latest_complete":"2026-08","offers_as_of":"2026-08-31","executive_conclusions":5,"source_signature":"c4c868a5e5924b391ec6b611ee7484f13bf36737f0991d1d518c8985263aa45c"}</a:t>
+              <a:t>[Industry contract] {"id":"provider_history","latest_complete":"2026-08","offers_as_of":"2026-08-31","executive_conclusions":5,"source_signature":"bb4e976173eaad01107647a7305e770e2018fa6a22fbbb5ae19b05948b59652a"}</a:t>
             </a:r>
           </a:p>
         </p:txBody>
@@ -906,7 +906,7 @@
           </a:p>
           <a:p xmlns:a="http://schemas.openxmlformats.org/drawingml/2006/main">
             <a:r>
-              <a:t>[Industry contract] {"id":"provider_ranking","latest_complete":"2026-08","offers_as_of":"2026-08-31","executive_conclusions":5,"source_signature":"c4c868a5e5924b391ec6b611ee7484f13bf36737f0991d1d518c8985263aa45c"}</a:t>
+              <a:t>[Industry contract] {"id":"provider_ranking","latest_complete":"2026-08","offers_as_of":"2026-08-31","executive_conclusions":5,"source_signature":"bb4e976173eaad01107647a7305e770e2018fa6a22fbbb5ae19b05948b59652a"}</a:t>
             </a:r>
           </a:p>
         </p:txBody>
@@ -981,7 +981,7 @@
           </a:p>
           <a:p xmlns:a="http://schemas.openxmlformats.org/drawingml/2006/main">
             <a:r>
-              <a:t>Fonte: CVM/SRE, snapshot 8/out/26. Primárias encerradas, volume registrado. Público-alvo mede elegibilidade. Contas podem repetir investidores.</a:t>
+              <a:t>Fonte: CVM/SRE, snapshot 10/out/26. Primárias encerradas, volume registrado. Público-alvo mede elegibilidade. Contas podem repetir investidores.</a:t>
             </a:r>
           </a:p>
           <a:p xmlns:a="http://schemas.openxmlformats.org/drawingml/2006/main">
@@ -1021,7 +1021,7 @@
           </a:p>
           <a:p xmlns:a="http://schemas.openxmlformats.org/drawingml/2006/main">
             <a:r>
-              <a:t>[Industry contract] {"id":"investor_base","latest_complete":"2026-08","offers_as_of":"2026-08-31","executive_conclusions":5,"source_signature":"c4c868a5e5924b391ec6b611ee7484f13bf36737f0991d1d518c8985263aa45c"}</a:t>
+              <a:t>[Industry contract] {"id":"investor_base","latest_complete":"2026-08","offers_as_of":"2026-08-31","executive_conclusions":5,"source_signature":"bb4e976173eaad01107647a7305e770e2018fa6a22fbbb5ae19b05948b59652a"}</a:t>
             </a:r>
           </a:p>
         </p:txBody>
@@ -1106,7 +1106,7 @@
           </a:p>
           <a:p xmlns:a="http://schemas.openxmlformats.org/drawingml/2006/main">
             <a:r>
-              <a:t>[Industry contract] {"id":"holder_distribution","latest_complete":"2026-08","offers_as_of":"2026-08-31","executive_conclusions":5,"source_signature":"c4c868a5e5924b391ec6b611ee7484f13bf36737f0991d1d518c8985263aa45c"}</a:t>
+              <a:t>[Industry contract] {"id":"holder_distribution","latest_complete":"2026-08","offers_as_of":"2026-08-31","executive_conclusions":5,"source_signature":"bb4e976173eaad01107647a7305e770e2018fa6a22fbbb5ae19b05948b59652a"}</a:t>
             </a:r>
           </a:p>
         </p:txBody>
@@ -1191,7 +1191,7 @@
           </a:p>
           <a:p xmlns:a="http://schemas.openxmlformats.org/drawingml/2006/main">
             <a:r>
-              <a:t>[Industry contract] {"id":"industry_scale","latest_complete":"2026-08","offers_as_of":"2026-08-31","executive_conclusions":5,"source_signature":"c4c868a5e5924b391ec6b611ee7484f13bf36737f0991d1d518c8985263aa45c"}</a:t>
+              <a:t>[Industry contract] {"id":"industry_scale","latest_complete":"2026-08","offers_as_of":"2026-08-31","executive_conclusions":5,"source_signature":"bb4e976173eaad01107647a7305e770e2018fa6a22fbbb5ae19b05948b59652a"}</a:t>
             </a:r>
           </a:p>
         </p:txBody>
@@ -1306,7 +1306,7 @@
           </a:p>
           <a:p xmlns:a="http://schemas.openxmlformats.org/drawingml/2006/main">
             <a:r>
-              <a:t>[Industry contract] {"id":"annual_issuance","latest_complete":"2026-08","offers_as_of":"2026-08-31","executive_conclusions":5,"source_signature":"c4c868a5e5924b391ec6b611ee7484f13bf36737f0991d1d518c8985263aa45c"}</a:t>
+              <a:t>[Industry contract] {"id":"annual_issuance","latest_complete":"2026-08","offers_as_of":"2026-08-31","executive_conclusions":5,"source_signature":"bb4e976173eaad01107647a7305e770e2018fa6a22fbbb5ae19b05948b59652a"}</a:t>
             </a:r>
           </a:p>
         </p:txBody>
@@ -1381,7 +1381,7 @@
           </a:p>
           <a:p xmlns:a="http://schemas.openxmlformats.org/drawingml/2006/main">
             <a:r>
-              <a:t>Fontes: CVM/SRE, ofertas encerradas até 2026-08-31, snapshot 8/out/26; ANBIMA para 2023. Volume registrado, tipos ANBIMA e reconciliação no XLSX.</a:t>
+              <a:t>Fontes: CVM/SRE, ofertas encerradas até 2026-08-31, snapshot 10/out/26; ANBIMA para 2023. Volume registrado, tipos ANBIMA e reconciliação no XLSX.</a:t>
             </a:r>
           </a:p>
           <a:p xmlns:a="http://schemas.openxmlformats.org/drawingml/2006/main">
@@ -1411,7 +1411,7 @@
           </a:p>
           <a:p xmlns:a="http://schemas.openxmlformats.org/drawingml/2006/main">
             <a:r>
-              <a:t>[Industry contract] {"id":"issuance_taxonomy_summary","latest_complete":"2026-08","offers_as_of":"2026-08-31","executive_conclusions":5,"source_signature":"c4c868a5e5924b391ec6b611ee7484f13bf36737f0991d1d518c8985263aa45c"}</a:t>
+              <a:t>[Industry contract] {"id":"issuance_taxonomy_summary","latest_complete":"2026-08","offers_as_of":"2026-08-31","executive_conclusions":5,"source_signature":"bb4e976173eaad01107647a7305e770e2018fa6a22fbbb5ae19b05948b59652a"}</a:t>
             </a:r>
           </a:p>
         </p:txBody>
@@ -1516,7 +1516,7 @@
           </a:p>
           <a:p xmlns:a="http://schemas.openxmlformats.org/drawingml/2006/main">
             <a:r>
-              <a:t>[Industry contract] {"id":"analytical_taxonomy","latest_complete":"2026-08","offers_as_of":"2026-08-31","executive_conclusions":5,"source_signature":"c4c868a5e5924b391ec6b611ee7484f13bf36737f0991d1d518c8985263aa45c"}</a:t>
+              <a:t>[Industry contract] {"id":"analytical_taxonomy","latest_complete":"2026-08","offers_as_of":"2026-08-31","executive_conclusions":5,"source_signature":"bb4e976173eaad01107647a7305e770e2018fa6a22fbbb5ae19b05948b59652a"}</a:t>
             </a:r>
           </a:p>
         </p:txBody>
@@ -1601,7 +1601,7 @@
           </a:p>
           <a:p xmlns:a="http://schemas.openxmlformats.org/drawingml/2006/main">
             <a:r>
-              <a:t>[Industry contract] {"id":"acquiring","latest_complete":"2026-08","offers_as_of":"2026-08-31","executive_conclusions":5,"source_signature":"c4c868a5e5924b391ec6b611ee7484f13bf36737f0991d1d518c8985263aa45c"}</a:t>
+              <a:t>[Industry contract] {"id":"acquiring","latest_complete":"2026-08","offers_as_of":"2026-08-31","executive_conclusions":5,"source_signature":"bb4e976173eaad01107647a7305e770e2018fa6a22fbbb5ae19b05948b59652a"}</a:t>
             </a:r>
           </a:p>
         </p:txBody>
@@ -1686,7 +1686,7 @@
           </a:p>
           <a:p xmlns:a="http://schemas.openxmlformats.org/drawingml/2006/main">
             <a:r>
-              <a:t>[Industry contract] {"id":"receivables","latest_complete":"2026-08","offers_as_of":"2026-08-31","executive_conclusions":5,"source_signature":"c4c868a5e5924b391ec6b611ee7484f13bf36737f0991d1d518c8985263aa45c"}</a:t>
+              <a:t>[Industry contract] {"id":"receivables","latest_complete":"2026-08","offers_as_of":"2026-08-31","executive_conclusions":5,"source_signature":"bb4e976173eaad01107647a7305e770e2018fa6a22fbbb5ae19b05948b59652a"}</a:t>
             </a:r>
           </a:p>
         </p:txBody>
@@ -1761,7 +1761,7 @@
           </a:p>
           <a:p xmlns:a="http://schemas.openxmlformats.org/drawingml/2006/main">
             <a:r>
-              <a:t>Fonte: CVM/SRE, dois arquivos de ofertas, snapshot 8/out/26. Primárias encerradas, todos os ritos; volume registrado.</a:t>
+              <a:t>Fonte: CVM/SRE, dois arquivos de ofertas, snapshot 10/out/26. Primárias encerradas, todos os ritos; volume registrado.</a:t>
             </a:r>
           </a:p>
           <a:p xmlns:a="http://schemas.openxmlformats.org/drawingml/2006/main">
@@ -1801,7 +1801,7 @@
           </a:p>
           <a:p xmlns:a="http://schemas.openxmlformats.org/drawingml/2006/main">
             <a:r>
-              <a:t>[Industry contract] {"id":"offers_volume_ticket","latest_complete":"2026-08","offers_as_of":"2026-08-31","executive_conclusions":5,"source_signature":"c4c868a5e5924b391ec6b611ee7484f13bf36737f0991d1d518c8985263aa45c"}</a:t>
+              <a:t>[Industry contract] {"id":"offers_volume_ticket","latest_complete":"2026-08","offers_as_of":"2026-08-31","executive_conclusions":5,"source_signature":"bb4e976173eaad01107647a7305e770e2018fa6a22fbbb5ae19b05948b59652a"}</a:t>
             </a:r>
           </a:p>
         </p:txBody>
@@ -1911,7 +1911,7 @@
           </a:p>
           <a:p xmlns:a="http://schemas.openxmlformats.org/drawingml/2006/main">
             <a:r>
-              <a:t>[Industry contract] {"id":"offers_ticket_distribution","latest_complete":"2026-08","offers_as_of":"2026-08-31","executive_conclusions":5,"source_signature":"c4c868a5e5924b391ec6b611ee7484f13bf36737f0991d1d518c8985263aa45c"}</a:t>
+              <a:t>[Industry contract] {"id":"offers_ticket_distribution","latest_complete":"2026-08","offers_as_of":"2026-08-31","executive_conclusions":5,"source_signature":"bb4e976173eaad01107647a7305e770e2018fa6a22fbbb5ae19b05948b59652a"}</a:t>
             </a:r>
           </a:p>
         </p:txBody>
@@ -1958,7 +1958,7 @@
           <p:cNvPr id="3" name="Title">
             <a:extLst xmlns:a="http://schemas.openxmlformats.org/drawingml/2006/main">
               <a:ext uri="{FF2B5EF4-FFF2-40B4-BE49-F238E27FC236}">
-                <a16:creationId xmlns:a16="http://schemas.microsoft.com/office/drawing/2014/main" id="{42FD5BAC-5B11-4E3E-97F8-15BF36B66797}"/>
+                <a16:creationId xmlns:a16="http://schemas.microsoft.com/office/drawing/2014/main" id="{A58002AA-49B5-40AA-9375-FB4D8EA9B5D0}"/>
               </a:ext>
             </a:extLst>
           </p:cNvPr>
@@ -2115,7 +2115,7 @@
           <p:cNvPr id="2" name="Subtitle">
             <a:extLst xmlns:a="http://schemas.openxmlformats.org/drawingml/2006/main">
               <a:ext uri="{FF2B5EF4-FFF2-40B4-BE49-F238E27FC236}">
-                <a16:creationId xmlns:a16="http://schemas.microsoft.com/office/drawing/2014/main" id="{01E9755C-18E6-4F97-9F08-EFB3439B6140}"/>
+                <a16:creationId xmlns:a16="http://schemas.microsoft.com/office/drawing/2014/main" id="{2435AE56-9D26-4AC7-81D6-57FCC02A93F6}"/>
               </a:ext>
             </a:extLst>
           </p:cNvPr>
@@ -2289,7 +2289,7 @@
           <p:cNvPr id="2" name="Section title">
             <a:extLst xmlns:a="http://schemas.openxmlformats.org/drawingml/2006/main">
               <a:ext uri="{FF2B5EF4-FFF2-40B4-BE49-F238E27FC236}">
-                <a16:creationId xmlns:a16="http://schemas.microsoft.com/office/drawing/2014/main" id="{4499B74A-F24D-4E4B-8E9A-06634BE6CA5D}"/>
+                <a16:creationId xmlns:a16="http://schemas.microsoft.com/office/drawing/2014/main" id="{FE6CEE74-317B-46B6-859B-28AE66E86922}"/>
               </a:ext>
             </a:extLst>
           </p:cNvPr>
@@ -2463,7 +2463,7 @@
           <p:cNvPr id="3" name="Title">
             <a:extLst xmlns:a="http://schemas.openxmlformats.org/drawingml/2006/main">
               <a:ext uri="{FF2B5EF4-FFF2-40B4-BE49-F238E27FC236}">
-                <a16:creationId xmlns:a16="http://schemas.microsoft.com/office/drawing/2014/main" id="{808D5CE6-C38F-4A7F-9463-E52381B98665}"/>
+                <a16:creationId xmlns:a16="http://schemas.microsoft.com/office/drawing/2014/main" id="{E1BA1DCC-8BA7-4BD4-B0FB-33736BDD638C}"/>
               </a:ext>
             </a:extLst>
           </p:cNvPr>
@@ -2620,7 +2620,7 @@
           <p:cNvPr id="2" name="Body">
             <a:extLst xmlns:a="http://schemas.openxmlformats.org/drawingml/2006/main">
               <a:ext uri="{FF2B5EF4-FFF2-40B4-BE49-F238E27FC236}">
-                <a16:creationId xmlns:a16="http://schemas.microsoft.com/office/drawing/2014/main" id="{F99C731E-53F0-46DE-BFC5-A7CCB263FB8F}"/>
+                <a16:creationId xmlns:a16="http://schemas.microsoft.com/office/drawing/2014/main" id="{AF6869E3-256A-4405-86AA-314C2F61603E}"/>
               </a:ext>
             </a:extLst>
           </p:cNvPr>
@@ -2794,7 +2794,7 @@
           <p:cNvPr id="4" name="Title">
             <a:extLst xmlns:a="http://schemas.openxmlformats.org/drawingml/2006/main">
               <a:ext uri="{FF2B5EF4-FFF2-40B4-BE49-F238E27FC236}">
-                <a16:creationId xmlns:a16="http://schemas.microsoft.com/office/drawing/2014/main" id="{60958610-9D76-4544-990D-CABCADA3642B}"/>
+                <a16:creationId xmlns:a16="http://schemas.microsoft.com/office/drawing/2014/main" id="{9EB37EA9-D83C-4957-A94E-9F690A687902}"/>
               </a:ext>
             </a:extLst>
           </p:cNvPr>
@@ -2951,7 +2951,7 @@
           <p:cNvPr id="2" name="Left column">
             <a:extLst xmlns:a="http://schemas.openxmlformats.org/drawingml/2006/main">
               <a:ext uri="{FF2B5EF4-FFF2-40B4-BE49-F238E27FC236}">
-                <a16:creationId xmlns:a16="http://schemas.microsoft.com/office/drawing/2014/main" id="{11242370-61B1-40BD-86DD-BF4854525B2C}"/>
+                <a16:creationId xmlns:a16="http://schemas.microsoft.com/office/drawing/2014/main" id="{AE11DB23-69F2-4FB2-B44C-4FF17DD857C5}"/>
               </a:ext>
             </a:extLst>
           </p:cNvPr>
@@ -3108,7 +3108,7 @@
           <p:cNvPr id="3" name="Right column">
             <a:extLst xmlns:a="http://schemas.openxmlformats.org/drawingml/2006/main">
               <a:ext uri="{FF2B5EF4-FFF2-40B4-BE49-F238E27FC236}">
-                <a16:creationId xmlns:a16="http://schemas.microsoft.com/office/drawing/2014/main" id="{4EFF55E9-44C8-4434-9D48-6AF4F221D95D}"/>
+                <a16:creationId xmlns:a16="http://schemas.microsoft.com/office/drawing/2014/main" id="{21E6DF20-AD85-4100-A3F2-4E28B4FECDB9}"/>
               </a:ext>
             </a:extLst>
           </p:cNvPr>
@@ -3282,7 +3282,7 @@
           <p:cNvPr id="3" name="Title">
             <a:extLst xmlns:a="http://schemas.openxmlformats.org/drawingml/2006/main">
               <a:ext uri="{FF2B5EF4-FFF2-40B4-BE49-F238E27FC236}">
-                <a16:creationId xmlns:a16="http://schemas.microsoft.com/office/drawing/2014/main" id="{DAF96963-9730-4B22-BF68-4A8F83CE5F1D}"/>
+                <a16:creationId xmlns:a16="http://schemas.microsoft.com/office/drawing/2014/main" id="{01366D6E-F3DC-476C-8362-0B924ED8AC71}"/>
               </a:ext>
             </a:extLst>
           </p:cNvPr>
@@ -3439,7 +3439,7 @@
           <p:cNvPr id="2" name="Left column">
             <a:extLst xmlns:a="http://schemas.openxmlformats.org/drawingml/2006/main">
               <a:ext uri="{FF2B5EF4-FFF2-40B4-BE49-F238E27FC236}">
-                <a16:creationId xmlns:a16="http://schemas.microsoft.com/office/drawing/2014/main" id="{ECB17756-A4FE-41DE-98E9-A96DE94C6E43}"/>
+                <a16:creationId xmlns:a16="http://schemas.microsoft.com/office/drawing/2014/main" id="{BBEE275B-6212-4460-9A2F-DE91F95BF852}"/>
               </a:ext>
             </a:extLst>
           </p:cNvPr>
@@ -3634,12 +3634,12 @@
   </p:cSld>
   <p:clrMap bg1="lt1" tx1="dk1" bg2="lt2" tx2="dk2" accent1="accent1" accent2="accent2" accent3="accent3" accent4="accent4" accent5="accent5" accent6="accent6" hlink="hlink" folHlink="folHlink"/>
   <p:sldLayoutIdLst>
-    <p:sldLayoutId xmlns:r="http://schemas.openxmlformats.org/officeDocument/2006/relationships" id="2147483649" r:id="Rd136bd3491c944f0"/>
-    <p:sldLayoutId xmlns:r="http://schemas.openxmlformats.org/officeDocument/2006/relationships" id="2147483650" r:id="R96369e20fda840de"/>
-    <p:sldLayoutId xmlns:r="http://schemas.openxmlformats.org/officeDocument/2006/relationships" id="2147483651" r:id="R712aa2d83b624fc2"/>
-    <p:sldLayoutId xmlns:r="http://schemas.openxmlformats.org/officeDocument/2006/relationships" id="2147483652" r:id="R627463bfdfa14909"/>
-    <p:sldLayoutId xmlns:r="http://schemas.openxmlformats.org/officeDocument/2006/relationships" id="2147483653" r:id="R8e75f7e659094070"/>
-    <p:sldLayoutId xmlns:r="http://schemas.openxmlformats.org/officeDocument/2006/relationships" id="2147483654" r:id="R586d1644875c4a27"/>
+    <p:sldLayoutId xmlns:r="http://schemas.openxmlformats.org/officeDocument/2006/relationships" id="2147483649" r:id="R0c24dad0500e469a"/>
+    <p:sldLayoutId xmlns:r="http://schemas.openxmlformats.org/officeDocument/2006/relationships" id="2147483650" r:id="R970d072217804e91"/>
+    <p:sldLayoutId xmlns:r="http://schemas.openxmlformats.org/officeDocument/2006/relationships" id="2147483651" r:id="R5b1dcfd35cb140d6"/>
+    <p:sldLayoutId xmlns:r="http://schemas.openxmlformats.org/officeDocument/2006/relationships" id="2147483652" r:id="Ref48627848714224"/>
+    <p:sldLayoutId xmlns:r="http://schemas.openxmlformats.org/officeDocument/2006/relationships" id="2147483653" r:id="Rcd4caee3f4f849c5"/>
+    <p:sldLayoutId xmlns:r="http://schemas.openxmlformats.org/officeDocument/2006/relationships" id="2147483654" r:id="Rca66fda45c754716"/>
   </p:sldLayoutIdLst>
   <p:txStyles>
     <p:titleStyle>
@@ -4558,40 +4558,40 @@
               <c:formatCode>0.0%</c:formatCode>
               <c:ptCount val="12"/>
               <c:pt idx="0">
-                <c:v>0.408484330052702</c:v>
+                <c:v>0.4084829369793356</c:v>
               </c:pt>
               <c:pt idx="1">
-                <c:v>0.1710507281282967</c:v>
+                <c:v>0.1710501447859353</c:v>
               </c:pt>
               <c:pt idx="2">
-                <c:v>0.1072378380391524</c:v>
+                <c:v>0.1072374723208982</c:v>
               </c:pt>
               <c:pt idx="3">
-                <c:v>0.0997605883706192</c:v>
+                <c:v>0.099760248152382</c:v>
               </c:pt>
               <c:pt idx="4">
-                <c:v>0.0677571980156043</c:v>
+                <c:v>0.0677569669400379</c:v>
               </c:pt>
               <c:pt idx="5">
-                <c:v>0.0469527725377876</c:v>
+                <c:v>0.0469526124125341</c:v>
               </c:pt>
               <c:pt idx="6">
-                <c:v>0.0331950773361242</c:v>
+                <c:v>0.0331949641293872</c:v>
               </c:pt>
               <c:pt idx="7">
-                <c:v>0.0280857687060845</c:v>
+                <c:v>0.028089083271003</c:v>
               </c:pt>
               <c:pt idx="8">
-                <c:v>0.0191856967606479</c:v>
+                <c:v>0.0191856313307618</c:v>
               </c:pt>
               <c:pt idx="9">
-                <c:v>0.0131105500737029</c:v>
+                <c:v>0.0131105053621759</c:v>
               </c:pt>
               <c:pt idx="10">
-                <c:v>0.0050329433027298</c:v>
+                <c:v>0.005032926138646</c:v>
               </c:pt>
               <c:pt idx="11">
-                <c:v>0.000146508676548</c:v>
+                <c:v>0.0001465081769025</c:v>
               </c:pt>
             </c:numLit>
           </c:val>
@@ -9162,7 +9162,7 @@
                 <c:v>28.68803190114</c:v>
               </c:pt>
               <c:pt idx="1">
-                <c:v>56.23369816</c:v>
+                <c:v>56.23657788257001</c:v>
               </c:pt>
               <c:pt idx="2">
                 <c:v>63.849729013200005</c:v>
@@ -10513,40 +10513,40 @@
               <c:formatCode>[&gt;=1000]#\.##0;0</c:formatCode>
               <c:ptCount val="12"/>
               <c:pt idx="0">
-                <c:v>70.86095119410001</c:v>
+                <c:v>70.79198172925</c:v>
               </c:pt>
               <c:pt idx="1">
-                <c:v>82.19072984</c:v>
+                <c:v>82.06674826173</c:v>
               </c:pt>
               <c:pt idx="2">
-                <c:v>95.75352406850999</c:v>
+                <c:v>95.71646747935</c:v>
               </c:pt>
               <c:pt idx="3">
-                <c:v>106.12068752539999</c:v>
+                <c:v>106.07816527275</c:v>
               </c:pt>
               <c:pt idx="4">
-                <c:v>182.22866537173002</c:v>
+                <c:v>182.14515826151</c:v>
               </c:pt>
               <c:pt idx="5">
-                <c:v>160.17258675028998</c:v>
+                <c:v>159.9315713704</c:v>
               </c:pt>
               <c:pt idx="6">
-                <c:v>250.02515732651</c:v>
+                <c:v>250.01323870676</c:v>
               </c:pt>
               <c:pt idx="7">
-                <c:v>304.88729907795</c:v>
+                <c:v>304.88387968723</c:v>
               </c:pt>
               <c:pt idx="8">
-                <c:v>387.7969193108501</c:v>
+                <c:v>387.79181786037</c:v>
               </c:pt>
               <c:pt idx="9">
-                <c:v>549.9166688619099</c:v>
+                <c:v>549.9194136491999</c:v>
               </c:pt>
               <c:pt idx="10">
-                <c:v>641.37597886001</c:v>
+                <c:v>641.46819037186</c:v>
               </c:pt>
               <c:pt idx="11">
-                <c:v>702.06274298256</c:v>
+                <c:v>702.02744843628</c:v>
               </c:pt>
             </c:numLit>
           </c:val>
@@ -10928,40 +10928,40 @@
               <c:formatCode>[&gt;=1000]#\.##0;0</c:formatCode>
               <c:ptCount val="12"/>
               <c:pt idx="0">
-                <c:v>72.64204880589999</c:v>
+                <c:v>72.71101827075</c:v>
               </c:pt>
               <c:pt idx="1">
-                <c:v>91.52627016</c:v>
+                <c:v>91.65025173827</c:v>
               </c:pt>
               <c:pt idx="2">
-                <c:v>112.90947593149001</c:v>
+                <c:v>112.94653252065</c:v>
               </c:pt>
               <c:pt idx="3">
-                <c:v>121.5283124746</c:v>
+                <c:v>121.57083472725</c:v>
               </c:pt>
               <c:pt idx="4">
-                <c:v>128.34033462827</c:v>
+                <c:v>128.42384173849</c:v>
               </c:pt>
               <c:pt idx="5">
-                <c:v>127.67341324971002</c:v>
+                <c:v>127.91442862960001</c:v>
               </c:pt>
               <c:pt idx="6">
-                <c:v>183.94284267349</c:v>
+                <c:v>183.95476129323998</c:v>
               </c:pt>
               <c:pt idx="7">
-                <c:v>261.46670092205</c:v>
+                <c:v>261.47012031277</c:v>
               </c:pt>
               <c:pt idx="8">
-                <c:v>334.0110806891499</c:v>
+                <c:v>334.01618213963</c:v>
               </c:pt>
               <c:pt idx="9">
-                <c:v>444.7183311380901</c:v>
+                <c:v>444.7155863508001</c:v>
               </c:pt>
               <c:pt idx="10">
-                <c:v>452.00202113999</c:v>
+                <c:v>451.90980962814</c:v>
               </c:pt>
               <c:pt idx="11">
-                <c:v>517.5192570174399</c:v>
+                <c:v>517.55455156372</c:v>
               </c:pt>
             </c:numLit>
           </c:val>
@@ -12206,7 +12206,7 @@
             <c:invertIfNegative val="0"/>
             <c:spPr>
               <a:solidFill>
-                <a:srgbClr val="73C6A1"/>
+                <a:srgbClr val="2456D6"/>
               </a:solidFill>
             </c:spPr>
           </c:dPt>
@@ -12250,7 +12250,7 @@
             <c:strLit>
               <c:ptCount val="5"/>
               <c:pt idx="0">
-                <c:v>CBSF</c:v>
+                <c:v>QI Tech</c:v>
               </c:pt>
               <c:pt idx="1">
                 <c:v>Integral Investimentos</c:v>
@@ -12271,7 +12271,7 @@
               <c:formatCode>0.0</c:formatCode>
               <c:ptCount val="5"/>
               <c:pt idx="0">
-                <c:v>9.865271274100001</c:v>
+                <c:v>5.075019126889999</c:v>
               </c:pt>
               <c:pt idx="1">
                 <c:v>13.888233018860001</c:v>
@@ -12502,13 +12502,13 @@
                 <c:v>21.81407703156</c:v>
               </c:pt>
               <c:pt idx="1">
-                <c:v>62.59959108251</c:v>
+                <c:v>62.60247080508</c:v>
               </c:pt>
               <c:pt idx="2">
                 <c:v>81.37491463410998</c:v>
               </c:pt>
               <c:pt idx="3">
-                <c:v>116.98319936882001</c:v>
+                <c:v>116.72967363255</c:v>
               </c:pt>
               <c:pt idx="4">
                 <c:v>120.37499667349002</c:v>
@@ -12739,7 +12739,7 @@
                 <c:v>81.37491463410998</c:v>
               </c:pt>
               <c:pt idx="4">
-                <c:v>116.98319936882001</c:v>
+                <c:v>116.72967363255</c:v>
               </c:pt>
             </c:numLit>
           </c:val>
@@ -12910,7 +12910,7 @@
                 <c:v>0.3665235868793718</c:v>
               </c:pt>
               <c:pt idx="2">
-                <c:v>0.7195264286585489</c:v>
+                <c:v>0.7182930658741934</c:v>
               </c:pt>
             </c:numLit>
           </c:val>
@@ -12945,13 +12945,13 @@
               <c:formatCode>0.0%</c:formatCode>
               <c:ptCount val="3"/>
               <c:pt idx="0">
-                <c:v>0.7263739002187518</c:v>
+                <c:v>0.7263749478567149</c:v>
               </c:pt>
               <c:pt idx="1">
-                <c:v>0.3960710403881259</c:v>
+                <c:v>0.3960695239426612</c:v>
               </c:pt>
               <c:pt idx="2">
-                <c:v>0.7450975937718561</c:v>
+                <c:v>0.7447614958345239</c:v>
               </c:pt>
             </c:numLit>
           </c:val>
@@ -13124,7 +13124,7 @@
                 <c:v>0.2517632823317417</c:v>
               </c:pt>
               <c:pt idx="2">
-                <c:v>0.5296946658165912</c:v>
+                <c:v>0.529420790748221</c:v>
               </c:pt>
             </c:numLit>
           </c:val>
@@ -13159,13 +13159,13 @@
               <c:formatCode>0.0%</c:formatCode>
               <c:ptCount val="3"/>
               <c:pt idx="0">
-                <c:v>0.5456612813561854</c:v>
+                <c:v>0.5456630208923268</c:v>
               </c:pt>
               <c:pt idx="1">
-                <c:v>0.2896969513736841</c:v>
+                <c:v>0.28969584220491573</c:v>
               </c:pt>
               <c:pt idx="2">
-                <c:v>0.5748822972479061</c:v>
+                <c:v>0.5745468510174347</c:v>
               </c:pt>
             </c:numLit>
           </c:val>
@@ -13397,7 +13397,7 @@
                 <c:v>390.128</c:v>
               </c:pt>
               <c:pt idx="11">
-                <c:v>501.367</c:v>
+                <c:v>501.394</c:v>
               </c:pt>
             </c:numLit>
           </c:val>
@@ -13975,22 +13975,22 @@
               <c:formatCode>0.0%</c:formatCode>
               <c:ptCount val="6"/>
               <c:pt idx="0">
-                <c:v>0.4421611314665704</c:v>
+                <c:v>0.44216524330167495</c:v>
               </c:pt>
               <c:pt idx="1">
-                <c:v>0.2674587677290288</c:v>
+                <c:v>0.2674702928236078</c:v>
               </c:pt>
               <c:pt idx="2">
-                <c:v>0.20963884739123237</c:v>
+                <c:v>0.20962755836727204</c:v>
               </c:pt>
               <c:pt idx="3">
-                <c:v>0.08006111291728414</c:v>
+                <c:v>0.08005680163703595</c:v>
               </c:pt>
               <c:pt idx="4">
-                <c:v>0.0006582004798879863</c:v>
+                <c:v>0.0006581650358799667</c:v>
               </c:pt>
               <c:pt idx="5">
-                <c:v>2.1940015996266208E-05</c:v>
+                <c:v>2.193883452933222E-05</c:v>
               </c:pt>
             </c:numLit>
           </c:val>
@@ -18550,7 +18550,7 @@
                 <c:v>0.28833289227</c:v>
               </c:pt>
               <c:pt idx="3">
-                <c:v>3.40772504529</c:v>
+                <c:v>3.41060476786</c:v>
               </c:pt>
             </c:numLit>
           </c:val>
@@ -18829,7 +18829,7 @@
                 <c:v>0.10672121470682827</c:v>
               </c:pt>
               <c:pt idx="3">
-                <c:v>0.10440098528219585</c:v>
+                <c:v>0.10440062923859433</c:v>
               </c:pt>
             </c:numLit>
           </c:val>
@@ -18976,7 +18976,7 @@
                 <c:v>0.24903575562554714</c:v>
               </c:pt>
               <c:pt idx="3">
-                <c:v>0.25507959752178494</c:v>
+                <c:v>0.25507872761180916</c:v>
               </c:pt>
             </c:numLit>
           </c:val>
@@ -19123,7 +19123,7 @@
                 <c:v>0.3467987518661887</c:v>
               </c:pt>
               <c:pt idx="3">
-                <c:v>0.38755548969164244</c:v>
+                <c:v>0.3875541679928867</c:v>
               </c:pt>
             </c:numLit>
           </c:val>
@@ -19270,7 +19270,7 @@
                 <c:v>0.1172230031852957</c:v>
               </c:pt>
               <c:pt idx="3">
-                <c:v>0.09880585195643958</c:v>
+                <c:v>0.09880551499418501</c:v>
               </c:pt>
             </c:numLit>
           </c:val>
@@ -19417,7 +19417,7 @@
                 <c:v>0.13680997111290205</c:v>
               </c:pt>
               <c:pt idx="3">
-                <c:v>0.10867965010796464</c:v>
+                <c:v>0.10867927947263079</c:v>
               </c:pt>
             </c:numLit>
           </c:val>
@@ -19564,7 +19564,7 @@
                 <c:v>0.043046031910315107</c:v>
               </c:pt>
               <c:pt idx="3">
-                <c:v>0.041442771063081175</c:v>
+                <c:v>0.04144262972884544</c:v>
               </c:pt>
             </c:numLit>
           </c:val>
@@ -19711,7 +19711,7 @@
                 <c:v>0.0003652715929229945</c:v>
               </c:pt>
               <c:pt idx="3">
-                <c:v>0.004035654376891398</c:v>
+                <c:v>0.004039050961048501</c:v>
               </c:pt>
             </c:numLit>
           </c:val>
@@ -20022,7 +20022,7 @@
                 <c:v>28.030075386630003</c:v>
               </c:pt>
               <c:pt idx="7">
-                <c:v>23.715751771009998</c:v>
+                <c:v>23.718631493580002</c:v>
               </c:pt>
               <c:pt idx="8">
                 <c:v>16.2004902444</c:v>
@@ -20187,7 +20187,7 @@
           <ns0:cNvPr id="7" name="">
             <a:extLst>
               <a:ext uri="{FF2B5EF4-FFF2-40B4-BE49-F238E27FC236}">
-                <ns2:creationId id="{742C05D5-55D6-470C-A4E2-4B8A6C87A7EC}"/>
+                <ns2:creationId id="{805DF0D5-B2D4-42B8-8EA3-61C059010E28}"/>
               </a:ext>
             </a:extLst>
           </ns0:cNvPr>
@@ -20218,7 +20218,7 @@
           <ns0:cNvPr id="2" name="">
             <a:extLst>
               <a:ext uri="{FF2B5EF4-FFF2-40B4-BE49-F238E27FC236}">
-                <ns2:creationId id="{43B13F7B-3E61-45A6-82E4-CCF369C5BC55}"/>
+                <ns2:creationId id="{D78D37C5-5CBD-4467-AACF-1F14BB9A1C1A}"/>
               </a:ext>
             </a:extLst>
           </ns0:cNvPr>
@@ -20291,7 +20291,7 @@
           <ns0:cNvPr id="3" name="">
             <a:extLst>
               <a:ext uri="{FF2B5EF4-FFF2-40B4-BE49-F238E27FC236}">
-                <ns2:creationId id="{F435DE2E-57D2-4205-A783-20D7B5755591}"/>
+                <ns2:creationId id="{588E07E0-A598-4FF9-A778-02E5FEDFAB14}"/>
               </a:ext>
             </a:extLst>
           </ns0:cNvPr>
@@ -20322,7 +20322,7 @@
           <ns0:cNvPr id="4" name="">
             <a:extLst>
               <a:ext uri="{FF2B5EF4-FFF2-40B4-BE49-F238E27FC236}">
-                <ns2:creationId id="{957EDB33-358A-4B5D-B91E-0AB14B75CF37}"/>
+                <ns2:creationId id="{E3AC1A26-8A38-4EC9-898E-4B1D95579F2C}"/>
               </a:ext>
             </a:extLst>
           </ns0:cNvPr>
@@ -20395,7 +20395,7 @@
           <ns0:cNvPr id="5" name="">
             <a:extLst>
               <a:ext uri="{FF2B5EF4-FFF2-40B4-BE49-F238E27FC236}">
-                <ns2:creationId id="{A6BD205E-9ADB-40AB-B225-D3302D65E318}"/>
+                <ns2:creationId id="{56E3C67B-0C5D-408E-8F6C-7011F95F1A5D}"/>
               </a:ext>
             </a:extLst>
           </ns0:cNvPr>
@@ -20458,7 +20458,7 @@
                 <a:ea typeface="Arial"/>
                 <a:cs typeface="Arial"/>
               </a:rPr>
-              <a:t>Ofertas CVM: jan–ago/26; ANBIMA: jan–ago/26. Extração CVM: 8/out/26</a:t>
+              <a:t>Ofertas CVM: jan–ago/26; ANBIMA: jan–ago/26. Extração CVM: 10/out/26</a:t>
             </a:r>
           </a:p>
         </ns0:txBody>
@@ -20468,7 +20468,7 @@
           <ns0:cNvPr id="6" name="">
             <a:extLst>
               <a:ext uri="{FF2B5EF4-FFF2-40B4-BE49-F238E27FC236}">
-                <ns2:creationId id="{790C5746-5049-4111-8022-FF8838B9B569}"/>
+                <ns2:creationId id="{4AE7380F-C582-4244-B650-74BFEA242BB0}"/>
               </a:ext>
             </a:extLst>
           </ns0:cNvPr>
@@ -20539,7 +20539,7 @@
     </ns0:spTree>
     <ns0:extLst>
       <ns0:ext uri="{BB962C8B-B14F-4D97-AF65-F5344CB8AC3E}">
-        <ns3:creationId val="1603135628"/>
+        <ns3:creationId val="2017095849"/>
       </ns0:ext>
     </ns0:extLst>
   </ns0:cSld>
@@ -20570,7 +20570,7 @@
           <ns0:cNvPr id="17" name="">
             <a:extLst>
               <a:ext uri="{FF2B5EF4-FFF2-40B4-BE49-F238E27FC236}">
-                <ns2:creationId id="{793D427C-32A7-43FC-AB33-6E200A4A7C14}"/>
+                <ns2:creationId id="{9CB4D93B-44CC-48F2-951E-0ED63AB3AF49}"/>
               </a:ext>
             </a:extLst>
           </ns0:cNvPr>
@@ -20643,7 +20643,7 @@
           <ns0:cNvPr id="2" name="">
             <a:extLst>
               <a:ext uri="{FF2B5EF4-FFF2-40B4-BE49-F238E27FC236}">
-                <ns2:creationId id="{22067570-41A4-4528-8EC6-5B32B3AAC8B3}"/>
+                <ns2:creationId id="{1A7E10B1-FAE5-459B-AB41-B4CD848C1B16}"/>
               </a:ext>
             </a:extLst>
           </ns0:cNvPr>
@@ -20716,7 +20716,7 @@
           <ns0:cNvPr id="3" name="">
             <a:extLst>
               <a:ext uri="{FF2B5EF4-FFF2-40B4-BE49-F238E27FC236}">
-                <ns2:creationId id="{B88B2410-D459-4E4A-8671-F1C35C506860}"/>
+                <ns2:creationId id="{72A24C9F-D26C-477F-B6BA-85D14D2B8864}"/>
               </a:ext>
             </a:extLst>
           </ns0:cNvPr>
@@ -20747,7 +20747,7 @@
           <ns0:cNvPr id="4" name="">
             <a:extLst>
               <a:ext uri="{FF2B5EF4-FFF2-40B4-BE49-F238E27FC236}">
-                <ns2:creationId id="{42E488D5-3FA6-4DA2-A71B-3A38B145BBB4}"/>
+                <ns2:creationId id="{B54CE960-CFFF-45A7-9690-D2CF97FBD51B}"/>
               </a:ext>
             </a:extLst>
           </ns0:cNvPr>
@@ -20778,7 +20778,7 @@
           <ns0:cNvPr id="5" name="">
             <a:extLst>
               <a:ext uri="{FF2B5EF4-FFF2-40B4-BE49-F238E27FC236}">
-                <ns2:creationId id="{9467E838-4F7A-4B4E-A014-2E0D38BBB971}"/>
+                <ns2:creationId id="{03ED582F-F091-42E5-A31B-5AB1E837B316}"/>
               </a:ext>
             </a:extLst>
           </ns0:cNvPr>
@@ -20841,7 +20841,7 @@
                 <a:ea typeface="Arial"/>
                 <a:cs typeface="Arial"/>
               </a:rPr>
-              <a:t>Fonte: CVM/SRE, snapshot 8/out/26. jan–ago/26; regime declarado. Campo ausente = Não informado.</a:t>
+              <a:t>Fonte: CVM/SRE, snapshot 10/out/26. jan–ago/26; regime declarado. Campo ausente = Não informado.</a:t>
             </a:r>
           </a:p>
         </ns0:txBody>
@@ -20851,7 +20851,7 @@
           <ns0:cNvPr id="6" name="">
             <a:extLst>
               <a:ext uri="{FF2B5EF4-FFF2-40B4-BE49-F238E27FC236}">
-                <ns2:creationId id="{188EF8A7-3A09-40D4-AAEE-A05B8E86B91C}"/>
+                <ns2:creationId id="{C4A9A058-8F2D-4EC7-8718-221A182AF648}"/>
               </a:ext>
             </a:extLst>
           </ns0:cNvPr>
@@ -20924,7 +20924,7 @@
           <ns0:cNvPr id="7" name="">
             <a:extLst>
               <a:ext uri="{FF2B5EF4-FFF2-40B4-BE49-F238E27FC236}">
-                <ns2:creationId id="{B197DD1F-8071-43A7-B753-A8D851E21C78}"/>
+                <ns2:creationId id="{134C8560-D837-4C08-839D-F15607D1D6C7}"/>
               </a:ext>
             </a:extLst>
           </ns0:cNvPr>
@@ -20997,7 +20997,7 @@
           <ns0:cNvPr id="8" name="">
             <a:extLst>
               <a:ext uri="{FF2B5EF4-FFF2-40B4-BE49-F238E27FC236}">
-                <ns2:creationId id="{D4BE6AEF-416D-4712-997C-C07797A68298}"/>
+                <ns2:creationId id="{C507889A-8452-436D-955B-DA480FE9C522}"/>
               </a:ext>
             </a:extLst>
           </ns0:cNvPr>
@@ -21028,7 +21028,7 @@
           <ns0:cNvPr id="9" name="">
             <a:extLst>
               <a:ext uri="{FF2B5EF4-FFF2-40B4-BE49-F238E27FC236}">
-                <ns2:creationId id="{FB7D4DCD-CBDA-4CB0-91EA-0893AAEB868B}"/>
+                <ns2:creationId id="{CABF4330-B917-40B4-80A4-A629E50270A9}"/>
               </a:ext>
             </a:extLst>
           </ns0:cNvPr>
@@ -21101,7 +21101,7 @@
           <ns0:cNvPr id="10" name="">
             <a:extLst>
               <a:ext uri="{FF2B5EF4-FFF2-40B4-BE49-F238E27FC236}">
-                <ns2:creationId id="{D020D78A-40E1-49C5-B8B9-D0392A3752B6}"/>
+                <ns2:creationId id="{19F396C5-F487-4A6D-B6D6-1D2B521D6B64}"/>
               </a:ext>
             </a:extLst>
           </ns0:cNvPr>
@@ -21132,7 +21132,7 @@
           <ns0:cNvPr id="11" name="">
             <a:extLst>
               <a:ext uri="{FF2B5EF4-FFF2-40B4-BE49-F238E27FC236}">
-                <ns2:creationId id="{FB4D075A-9E6F-41E1-A987-5C00A67C2D53}"/>
+                <ns2:creationId id="{C5E0BBF0-8129-4340-A497-1D5144FA0149}"/>
               </a:ext>
             </a:extLst>
           </ns0:cNvPr>
@@ -21205,7 +21205,7 @@
           <ns0:cNvPr id="12" name="">
             <a:extLst>
               <a:ext uri="{FF2B5EF4-FFF2-40B4-BE49-F238E27FC236}">
-                <ns2:creationId id="{6548A076-78F5-41F4-A8A2-62553CAB8641}"/>
+                <ns2:creationId id="{E55A4A28-6355-44F1-A0DA-E8DF75331A76}"/>
               </a:ext>
             </a:extLst>
           </ns0:cNvPr>
@@ -21236,7 +21236,7 @@
           <ns0:cNvPr id="13" name="">
             <a:extLst>
               <a:ext uri="{FF2B5EF4-FFF2-40B4-BE49-F238E27FC236}">
-                <ns2:creationId id="{5EAFB7F4-5D36-4518-9F99-F4DA644A78B0}"/>
+                <ns2:creationId id="{C69E22C5-7E5A-4202-A1B5-D8E2392986F5}"/>
               </a:ext>
             </a:extLst>
           </ns0:cNvPr>
@@ -21309,7 +21309,7 @@
           <ns0:cNvPr id="14" name="">
             <a:extLst>
               <a:ext uri="{FF2B5EF4-FFF2-40B4-BE49-F238E27FC236}">
-                <ns2:creationId id="{239E3560-E23F-4A3D-96B8-36A5F85FC76E}"/>
+                <ns2:creationId id="{592D18FE-DD77-43DA-AD08-079707B8F204}"/>
               </a:ext>
             </a:extLst>
           </ns0:cNvPr>
@@ -21382,7 +21382,7 @@
           <ns0:cNvPr id="15" name="">
             <a:extLst>
               <a:ext uri="{FF2B5EF4-FFF2-40B4-BE49-F238E27FC236}">
-                <ns2:creationId id="{23800B52-28F4-4486-81F4-5D9A7053C501}"/>
+                <ns2:creationId id="{8FB59AF3-B8F2-43B5-BE6D-23984AF0D4A2}"/>
               </a:ext>
             </a:extLst>
           </ns0:cNvPr>
@@ -21413,7 +21413,7 @@
           <ns0:cNvPr id="16" name="Chart">
             <a:extLst>
               <a:ext uri="{FF2B5EF4-FFF2-40B4-BE49-F238E27FC236}">
-                <ns2:creationId id="{EC4A05C0-BB3A-4348-8860-AA73DAF493AC}"/>
+                <ns2:creationId id="{01361F74-CBE3-4479-8E20-D9A2EFD09547}"/>
               </a:ext>
             </a:extLst>
           </ns0:cNvPr>
@@ -21426,14 +21426,14 @@
         </ns0:xfrm>
         <a:graphic>
           <a:graphicData uri="http://schemas.openxmlformats.org/drawingml/2006/chart">
-            <c:chart ns4:id="R003cfc7563f64aa0"/>
+            <c:chart ns4:id="R017c3b75544340d3"/>
           </a:graphicData>
         </a:graphic>
       </ns0:graphicFrame>
     </ns0:spTree>
     <ns0:extLst>
       <ns0:ext uri="{BB962C8B-B14F-4D97-AF65-F5344CB8AC3E}">
-        <ns5:creationId val="318828320"/>
+        <ns5:creationId val="684624793"/>
       </ns0:ext>
     </ns0:extLst>
   </ns0:cSld>
@@ -21464,7 +21464,7 @@
           <ns0:cNvPr id="26" name="">
             <a:extLst>
               <a:ext uri="{FF2B5EF4-FFF2-40B4-BE49-F238E27FC236}">
-                <ns2:creationId id="{628F7F31-AA1C-44EF-B501-E9195DAF24A3}"/>
+                <ns2:creationId id="{2618B0BD-A20E-4428-9F4C-BB6EB657B3E9}"/>
               </a:ext>
             </a:extLst>
           </ns0:cNvPr>
@@ -21537,7 +21537,7 @@
           <ns0:cNvPr id="2" name="">
             <a:extLst>
               <a:ext uri="{FF2B5EF4-FFF2-40B4-BE49-F238E27FC236}">
-                <ns2:creationId id="{04BB0E03-8DEA-4E1C-A7BF-127CBE32307B}"/>
+                <ns2:creationId id="{81B4AA6F-B526-4D5A-8AD3-8022D647C889}"/>
               </a:ext>
             </a:extLst>
           </ns0:cNvPr>
@@ -21610,7 +21610,7 @@
           <ns0:cNvPr id="3" name="">
             <a:extLst>
               <a:ext uri="{FF2B5EF4-FFF2-40B4-BE49-F238E27FC236}">
-                <ns2:creationId id="{B7D16143-2781-4A16-A88D-69B5A37A6BB5}"/>
+                <ns2:creationId id="{ED6591C0-59F3-4B46-B20A-EADEF9EE75D4}"/>
               </a:ext>
             </a:extLst>
           </ns0:cNvPr>
@@ -21641,7 +21641,7 @@
           <ns0:cNvPr id="4" name="">
             <a:extLst>
               <a:ext uri="{FF2B5EF4-FFF2-40B4-BE49-F238E27FC236}">
-                <ns2:creationId id="{7CE009F3-4653-47A1-B939-C61F1612C751}"/>
+                <ns2:creationId id="{9FDBA7CD-C3AF-43DC-A802-1FBFE7B68BA4}"/>
               </a:ext>
             </a:extLst>
           </ns0:cNvPr>
@@ -21672,7 +21672,7 @@
           <ns0:cNvPr id="5" name="">
             <a:extLst>
               <a:ext uri="{FF2B5EF4-FFF2-40B4-BE49-F238E27FC236}">
-                <ns2:creationId id="{71C4E0E4-2C77-469C-8678-D44F760DC8B1}"/>
+                <ns2:creationId id="{CE41D775-03B4-40C8-8AA9-91A0318041E9}"/>
               </a:ext>
             </a:extLst>
           </ns0:cNvPr>
@@ -21745,7 +21745,7 @@
           <ns0:cNvPr id="6" name="">
             <a:extLst>
               <a:ext uri="{FF2B5EF4-FFF2-40B4-BE49-F238E27FC236}">
-                <ns2:creationId id="{A3F7D387-D0D1-493F-8784-3355A12D34A9}"/>
+                <ns2:creationId id="{1D48F45A-648F-44DD-9D02-A2E1AA09B3FF}"/>
               </a:ext>
             </a:extLst>
           </ns0:cNvPr>
@@ -21818,7 +21818,7 @@
           <ns0:cNvPr id="7" name="">
             <a:extLst>
               <a:ext uri="{FF2B5EF4-FFF2-40B4-BE49-F238E27FC236}">
-                <ns2:creationId id="{50CFF464-A597-40F5-8755-1C7CDFB0AF01}"/>
+                <ns2:creationId id="{5B3E19DC-8835-457A-9BCA-FA578E5521C9}"/>
               </a:ext>
             </a:extLst>
           </ns0:cNvPr>
@@ -21891,7 +21891,7 @@
           <ns0:cNvPr id="8" name="">
             <a:extLst>
               <a:ext uri="{FF2B5EF4-FFF2-40B4-BE49-F238E27FC236}">
-                <ns2:creationId id="{D38EA433-3C1A-4079-BD93-7642EBAD7A77}"/>
+                <ns2:creationId id="{60E765DE-E993-40E4-9CAD-825C2B7F267A}"/>
               </a:ext>
             </a:extLst>
           </ns0:cNvPr>
@@ -21964,7 +21964,7 @@
           <ns0:cNvPr id="9" name="">
             <a:extLst>
               <a:ext uri="{FF2B5EF4-FFF2-40B4-BE49-F238E27FC236}">
-                <ns2:creationId id="{A5C0F976-BE60-4A52-94A9-11CDC4972511}"/>
+                <ns2:creationId id="{87DD7A16-9371-42DC-97CA-037C0EBC47DA}"/>
               </a:ext>
             </a:extLst>
           </ns0:cNvPr>
@@ -22037,7 +22037,7 @@
           <ns0:cNvPr id="10" name="">
             <a:extLst>
               <a:ext uri="{FF2B5EF4-FFF2-40B4-BE49-F238E27FC236}">
-                <ns2:creationId id="{2A67B047-3B97-44FD-AE61-4ACF3CF14883}"/>
+                <ns2:creationId id="{1A4A90CE-9CE1-4A0B-91C8-FD41F98D8F24}"/>
               </a:ext>
             </a:extLst>
           </ns0:cNvPr>
@@ -22068,7 +22068,7 @@
           <ns0:cNvPr id="11" name="">
             <a:extLst>
               <a:ext uri="{FF2B5EF4-FFF2-40B4-BE49-F238E27FC236}">
-                <ns2:creationId id="{63B1804A-FD99-4060-8E68-003A01731DBA}"/>
+                <ns2:creationId id="{22043E08-F8EF-4C15-A6DC-01AA918511AD}"/>
               </a:ext>
             </a:extLst>
           </ns0:cNvPr>
@@ -22141,7 +22141,7 @@
           <ns0:cNvPr id="12" name="">
             <a:extLst>
               <a:ext uri="{FF2B5EF4-FFF2-40B4-BE49-F238E27FC236}">
-                <ns2:creationId id="{87B9E44A-F28E-4383-916A-2EB2AD442D7C}"/>
+                <ns2:creationId id="{2143CB4D-33E9-4860-84E6-A516165DC333}"/>
               </a:ext>
             </a:extLst>
           </ns0:cNvPr>
@@ -22214,7 +22214,7 @@
           <ns0:cNvPr id="13" name="">
             <a:extLst>
               <a:ext uri="{FF2B5EF4-FFF2-40B4-BE49-F238E27FC236}">
-                <ns2:creationId id="{5CAFA0B8-5CFD-4E57-9D61-B25AE2A2A628}"/>
+                <ns2:creationId id="{71CAF922-3978-4AFE-B7FA-D1D8DEF0E93E}"/>
               </a:ext>
             </a:extLst>
           </ns0:cNvPr>
@@ -22287,7 +22287,7 @@
           <ns0:cNvPr id="14" name="">
             <a:extLst>
               <a:ext uri="{FF2B5EF4-FFF2-40B4-BE49-F238E27FC236}">
-                <ns2:creationId id="{6D9FB8C1-9724-41C5-AFBF-A2ECA5D0ED53}"/>
+                <ns2:creationId id="{8E0C2DCB-7960-48A6-B004-FAF5E55FC9D9}"/>
               </a:ext>
             </a:extLst>
           </ns0:cNvPr>
@@ -22318,7 +22318,7 @@
           <ns0:cNvPr id="15" name="">
             <a:extLst>
               <a:ext uri="{FF2B5EF4-FFF2-40B4-BE49-F238E27FC236}">
-                <ns2:creationId id="{FDE093B9-1F16-4565-95F5-01D65D374BB0}"/>
+                <ns2:creationId id="{1EFFA033-84C1-4D27-9A1D-C8F6D75E5B78}"/>
               </a:ext>
             </a:extLst>
           </ns0:cNvPr>
@@ -22391,7 +22391,7 @@
           <ns0:cNvPr id="16" name="">
             <a:extLst>
               <a:ext uri="{FF2B5EF4-FFF2-40B4-BE49-F238E27FC236}">
-                <ns2:creationId id="{9D51F1BC-59BB-4EA4-B987-EBF0EE093369}"/>
+                <ns2:creationId id="{6CD6088B-5582-4786-846B-48817BE23DD8}"/>
               </a:ext>
             </a:extLst>
           </ns0:cNvPr>
@@ -22464,7 +22464,7 @@
           <ns0:cNvPr id="17" name="">
             <a:extLst>
               <a:ext uri="{FF2B5EF4-FFF2-40B4-BE49-F238E27FC236}">
-                <ns2:creationId id="{8EBE1988-28A4-4DFF-BC6A-82341DE45E3A}"/>
+                <ns2:creationId id="{AEC612FA-C23C-4FE5-B8CB-CA3343C6F576}"/>
               </a:ext>
             </a:extLst>
           </ns0:cNvPr>
@@ -22537,7 +22537,7 @@
           <ns0:cNvPr id="18" name="">
             <a:extLst>
               <a:ext uri="{FF2B5EF4-FFF2-40B4-BE49-F238E27FC236}">
-                <ns2:creationId id="{64DEA8C9-D903-4D2D-B87D-3D177128E6E9}"/>
+                <ns2:creationId id="{CDC4D4C2-6A18-4929-8DAF-D6B6EF1D0112}"/>
               </a:ext>
             </a:extLst>
           </ns0:cNvPr>
@@ -22568,7 +22568,7 @@
           <ns0:cNvPr id="19" name="">
             <a:extLst>
               <a:ext uri="{FF2B5EF4-FFF2-40B4-BE49-F238E27FC236}">
-                <ns2:creationId id="{747AE52E-04E2-4EB5-A71E-03CA725C6441}"/>
+                <ns2:creationId id="{1C1A1EB4-528E-47F5-B1C1-F7B017317830}"/>
               </a:ext>
             </a:extLst>
           </ns0:cNvPr>
@@ -22641,7 +22641,7 @@
           <ns0:cNvPr id="20" name="">
             <a:extLst>
               <a:ext uri="{FF2B5EF4-FFF2-40B4-BE49-F238E27FC236}">
-                <ns2:creationId id="{33679C27-3562-479D-9B8F-FAFFA472B622}"/>
+                <ns2:creationId id="{305D89E1-9CD5-44CF-BD34-47CB7A6D2491}"/>
               </a:ext>
             </a:extLst>
           </ns0:cNvPr>
@@ -22714,7 +22714,7 @@
           <ns0:cNvPr id="21" name="">
             <a:extLst>
               <a:ext uri="{FF2B5EF4-FFF2-40B4-BE49-F238E27FC236}">
-                <ns2:creationId id="{2EAB43FD-23FD-47EC-9A79-ABC69CBEDD9C}"/>
+                <ns2:creationId id="{D0932169-29B7-4807-86E0-4FC1576F7721}"/>
               </a:ext>
             </a:extLst>
           </ns0:cNvPr>
@@ -22787,7 +22787,7 @@
           <ns0:cNvPr id="22" name="">
             <a:extLst>
               <a:ext uri="{FF2B5EF4-FFF2-40B4-BE49-F238E27FC236}">
-                <ns2:creationId id="{E650021C-8B7E-4FDF-931E-7C003178FAA5}"/>
+                <ns2:creationId id="{4E5F3CE6-5496-4331-8133-0616B27015C1}"/>
               </a:ext>
             </a:extLst>
           </ns0:cNvPr>
@@ -22818,7 +22818,7 @@
           <ns0:cNvPr id="23" name="">
             <a:extLst>
               <a:ext uri="{FF2B5EF4-FFF2-40B4-BE49-F238E27FC236}">
-                <ns2:creationId id="{93B69110-824F-4F38-BF05-9E758B87B606}"/>
+                <ns2:creationId id="{2B3BE063-13DB-471D-95A2-CCC4C618A64C}"/>
               </a:ext>
             </a:extLst>
           </ns0:cNvPr>
@@ -22891,7 +22891,7 @@
           <ns0:cNvPr id="24" name="">
             <a:extLst>
               <a:ext uri="{FF2B5EF4-FFF2-40B4-BE49-F238E27FC236}">
-                <ns2:creationId id="{1237A80B-D305-4A22-8E63-13FA0ED627C8}"/>
+                <ns2:creationId id="{29720927-D9A2-4FBE-80A9-71C265AD6CD8}"/>
               </a:ext>
             </a:extLst>
           </ns0:cNvPr>
@@ -22964,7 +22964,7 @@
           <ns0:cNvPr id="25" name="">
             <a:extLst>
               <a:ext uri="{FF2B5EF4-FFF2-40B4-BE49-F238E27FC236}">
-                <ns2:creationId id="{69BD8792-90C4-43B1-989D-541B675A1038}"/>
+                <ns2:creationId id="{C2FDE2A0-DE8A-415B-B3B4-DF7F5496AAAB}"/>
               </a:ext>
             </a:extLst>
           </ns0:cNvPr>
@@ -23035,7 +23035,7 @@
     </ns0:spTree>
     <ns0:extLst>
       <ns0:ext uri="{BB962C8B-B14F-4D97-AF65-F5344CB8AC3E}">
-        <ns3:creationId val="131113697"/>
+        <ns3:creationId val="313166906"/>
       </ns0:ext>
     </ns0:extLst>
   </ns0:cSld>
@@ -23066,7 +23066,7 @@
           <ns0:cNvPr id="35" name="">
             <a:extLst>
               <a:ext uri="{FF2B5EF4-FFF2-40B4-BE49-F238E27FC236}">
-                <ns2:creationId id="{4B49DFD4-BC8F-4D07-A718-5FA4E0C37490}"/>
+                <ns2:creationId id="{57BA82DB-AD4C-498A-ADC2-9E4F2E629CA9}"/>
               </a:ext>
             </a:extLst>
           </ns0:cNvPr>
@@ -23139,7 +23139,7 @@
           <ns0:cNvPr id="2" name="">
             <a:extLst>
               <a:ext uri="{FF2B5EF4-FFF2-40B4-BE49-F238E27FC236}">
-                <ns2:creationId id="{18537A1E-09D6-4F6B-8DA9-6EDE1257A244}"/>
+                <ns2:creationId id="{ADB1108F-48AB-4B7B-83E1-354EC71C9D7D}"/>
               </a:ext>
             </a:extLst>
           </ns0:cNvPr>
@@ -23212,7 +23212,7 @@
           <ns0:cNvPr id="3" name="">
             <a:extLst>
               <a:ext uri="{FF2B5EF4-FFF2-40B4-BE49-F238E27FC236}">
-                <ns2:creationId id="{6BEA55BE-01F9-459C-A264-ED4662D4A0F0}"/>
+                <ns2:creationId id="{3F645517-ED52-4647-9571-D29D72AB1DF1}"/>
               </a:ext>
             </a:extLst>
           </ns0:cNvPr>
@@ -23243,7 +23243,7 @@
           <ns0:cNvPr id="4" name="">
             <a:extLst>
               <a:ext uri="{FF2B5EF4-FFF2-40B4-BE49-F238E27FC236}">
-                <ns2:creationId id="{76E62C63-53F2-4C05-8AF4-42BBDD0988ED}"/>
+                <ns2:creationId id="{1D97F4D3-02D3-4935-A7EA-923C63D29C81}"/>
               </a:ext>
             </a:extLst>
           </ns0:cNvPr>
@@ -23274,7 +23274,7 @@
           <ns0:cNvPr id="5" name="">
             <a:extLst>
               <a:ext uri="{FF2B5EF4-FFF2-40B4-BE49-F238E27FC236}">
-                <ns2:creationId id="{14B3AA8F-1E48-432E-8BA7-9BE4D61B1ACD}"/>
+                <ns2:creationId id="{8B50FB96-ACA1-47A5-88BC-7FCB1DB396A7}"/>
               </a:ext>
             </a:extLst>
           </ns0:cNvPr>
@@ -23347,7 +23347,7 @@
           <ns0:cNvPr id="6" name="">
             <a:extLst>
               <a:ext uri="{FF2B5EF4-FFF2-40B4-BE49-F238E27FC236}">
-                <ns2:creationId id="{B99097EE-396E-4310-B7E7-06F8E4627B25}"/>
+                <ns2:creationId id="{0944018D-1D70-4578-8E8D-CDAC3F71006A}"/>
               </a:ext>
             </a:extLst>
           </ns0:cNvPr>
@@ -23420,7 +23420,7 @@
           <ns0:cNvPr id="7" name="">
             <a:extLst>
               <a:ext uri="{FF2B5EF4-FFF2-40B4-BE49-F238E27FC236}">
-                <ns2:creationId id="{5790ACF0-E37E-40BA-AB17-6A5B8C44A720}"/>
+                <ns2:creationId id="{EB5D0824-2618-458B-BB26-B1AFBB9C3B43}"/>
               </a:ext>
             </a:extLst>
           </ns0:cNvPr>
@@ -23451,7 +23451,7 @@
           <ns0:cNvPr id="8" name="">
             <a:extLst>
               <a:ext uri="{FF2B5EF4-FFF2-40B4-BE49-F238E27FC236}">
-                <ns2:creationId id="{091D9F9D-C0C7-4A29-9C08-802AEDC32A69}"/>
+                <ns2:creationId id="{98A295D2-F379-4F6D-ABEE-E36F662F9C0C}"/>
               </a:ext>
             </a:extLst>
           </ns0:cNvPr>
@@ -23524,7 +23524,7 @@
           <ns0:cNvPr id="9" name="">
             <a:extLst>
               <a:ext uri="{FF2B5EF4-FFF2-40B4-BE49-F238E27FC236}">
-                <ns2:creationId id="{5DBA52E9-9BB7-4BCA-B05F-A1B2EE404A4A}"/>
+                <ns2:creationId id="{1BB7088F-3F78-47D0-A0A2-C75120C03D60}"/>
               </a:ext>
             </a:extLst>
           </ns0:cNvPr>
@@ -23555,7 +23555,7 @@
           <ns0:cNvPr id="10" name="">
             <a:extLst>
               <a:ext uri="{FF2B5EF4-FFF2-40B4-BE49-F238E27FC236}">
-                <ns2:creationId id="{97D7CC44-292A-4265-B083-5B85C42DD6CD}"/>
+                <ns2:creationId id="{747DAD91-9DF5-4867-87D0-CE3B6812BDE1}"/>
               </a:ext>
             </a:extLst>
           </ns0:cNvPr>
@@ -23628,7 +23628,7 @@
           <ns0:cNvPr id="11" name="">
             <a:extLst>
               <a:ext uri="{FF2B5EF4-FFF2-40B4-BE49-F238E27FC236}">
-                <ns2:creationId id="{EE8B04D6-B35D-4134-8BD0-D4D5FE137658}"/>
+                <ns2:creationId id="{74C57483-3A65-4335-BC92-7EC86829A7A6}"/>
               </a:ext>
             </a:extLst>
           </ns0:cNvPr>
@@ -23659,7 +23659,7 @@
           <ns0:cNvPr id="12" name="">
             <a:extLst>
               <a:ext uri="{FF2B5EF4-FFF2-40B4-BE49-F238E27FC236}">
-                <ns2:creationId id="{3EB8DB5B-E2B1-43CF-B25C-41BC5A0DAB0E}"/>
+                <ns2:creationId id="{E73A7123-E1D3-470E-A987-C2B3FA894E49}"/>
               </a:ext>
             </a:extLst>
           </ns0:cNvPr>
@@ -23732,7 +23732,7 @@
           <ns0:cNvPr id="13" name="">
             <a:extLst>
               <a:ext uri="{FF2B5EF4-FFF2-40B4-BE49-F238E27FC236}">
-                <ns2:creationId id="{7A665946-D4D4-4B70-8A3E-17A1B84760C3}"/>
+                <ns2:creationId id="{521CF2AE-A3D7-4288-92D4-A1A6CF6A6781}"/>
               </a:ext>
             </a:extLst>
           </ns0:cNvPr>
@@ -23763,7 +23763,7 @@
           <ns0:cNvPr id="14" name="">
             <a:extLst>
               <a:ext uri="{FF2B5EF4-FFF2-40B4-BE49-F238E27FC236}">
-                <ns2:creationId id="{9DBBDF94-8148-4097-A9E0-A7E485D806C9}"/>
+                <ns2:creationId id="{2686B20C-673B-4864-91BC-773B5522D105}"/>
               </a:ext>
             </a:extLst>
           </ns0:cNvPr>
@@ -23836,7 +23836,7 @@
           <ns0:cNvPr id="15" name="">
             <a:extLst>
               <a:ext uri="{FF2B5EF4-FFF2-40B4-BE49-F238E27FC236}">
-                <ns2:creationId id="{90F65361-B366-463D-B880-47F9F9487CB1}"/>
+                <ns2:creationId id="{94A661A6-CAD9-4115-B9A7-BE446093A822}"/>
               </a:ext>
             </a:extLst>
           </ns0:cNvPr>
@@ -23867,7 +23867,7 @@
           <ns0:cNvPr id="16" name="">
             <a:extLst>
               <a:ext uri="{FF2B5EF4-FFF2-40B4-BE49-F238E27FC236}">
-                <ns2:creationId id="{44622DBE-39E0-445D-838D-1D8BBC88D121}"/>
+                <ns2:creationId id="{335ADE6C-F091-4B30-ACBE-1988882431A8}"/>
               </a:ext>
             </a:extLst>
           </ns0:cNvPr>
@@ -23940,7 +23940,7 @@
           <ns0:cNvPr id="17" name="">
             <a:extLst>
               <a:ext uri="{FF2B5EF4-FFF2-40B4-BE49-F238E27FC236}">
-                <ns2:creationId id="{93A0FD15-7CFC-4795-A39B-4CF6B2C22DD2}"/>
+                <ns2:creationId id="{B9EE6D0F-87C9-4398-A7E4-A7250F3FAEBB}"/>
               </a:ext>
             </a:extLst>
           </ns0:cNvPr>
@@ -23971,7 +23971,7 @@
           <ns0:cNvPr id="18" name="">
             <a:extLst>
               <a:ext uri="{FF2B5EF4-FFF2-40B4-BE49-F238E27FC236}">
-                <ns2:creationId id="{B9F94259-6BE0-4B40-8551-DFADBDF4CF5D}"/>
+                <ns2:creationId id="{BC238BF9-D980-4879-83B2-C08CB75D7EB4}"/>
               </a:ext>
             </a:extLst>
           </ns0:cNvPr>
@@ -24044,7 +24044,7 @@
           <ns0:cNvPr id="19" name="">
             <a:extLst>
               <a:ext uri="{FF2B5EF4-FFF2-40B4-BE49-F238E27FC236}">
-                <ns2:creationId id="{5686191C-8753-4209-ABA1-892DB5997291}"/>
+                <ns2:creationId id="{C93AEAF5-0F0E-476C-8EFA-74C8C791817F}"/>
               </a:ext>
             </a:extLst>
           </ns0:cNvPr>
@@ -24075,7 +24075,7 @@
           <ns0:cNvPr id="20" name="">
             <a:extLst>
               <a:ext uri="{FF2B5EF4-FFF2-40B4-BE49-F238E27FC236}">
-                <ns2:creationId id="{CBB61258-9400-4FE3-A243-FA1B688AFCA9}"/>
+                <ns2:creationId id="{3BAE8021-46BF-4787-A65D-D729565F57A3}"/>
               </a:ext>
             </a:extLst>
           </ns0:cNvPr>
@@ -24148,7 +24148,7 @@
           <ns0:cNvPr id="21" name="">
             <a:extLst>
               <a:ext uri="{FF2B5EF4-FFF2-40B4-BE49-F238E27FC236}">
-                <ns2:creationId id="{4AE378F4-B13D-4F32-9628-5773B3F8E6A5}"/>
+                <ns2:creationId id="{C089F5D7-4280-4BF3-B18F-A681D4ADBE00}"/>
               </a:ext>
             </a:extLst>
           </ns0:cNvPr>
@@ -24221,7 +24221,7 @@
           <ns0:cNvPr id="22" name="">
             <a:extLst>
               <a:ext uri="{FF2B5EF4-FFF2-40B4-BE49-F238E27FC236}">
-                <ns2:creationId id="{AA1D7768-C6DA-4058-80CD-F33F7724F0FC}"/>
+                <ns2:creationId id="{C09020E2-855C-46FD-9514-07AD9A840180}"/>
               </a:ext>
             </a:extLst>
           </ns0:cNvPr>
@@ -24294,7 +24294,7 @@
           <ns0:cNvPr id="23" name="">
             <a:extLst>
               <a:ext uri="{FF2B5EF4-FFF2-40B4-BE49-F238E27FC236}">
-                <ns2:creationId id="{92A8A3F7-76BD-4776-BCCB-2759D073F6A3}"/>
+                <ns2:creationId id="{91F5907E-B4AA-4C1C-B987-AA173CCFEF18}"/>
               </a:ext>
             </a:extLst>
           </ns0:cNvPr>
@@ -24367,7 +24367,7 @@
           <ns0:cNvPr id="24" name="Chart">
             <a:extLst>
               <a:ext uri="{FF2B5EF4-FFF2-40B4-BE49-F238E27FC236}">
-                <ns2:creationId id="{08F5B16A-280B-4551-9FEF-9C5DF2940041}"/>
+                <ns2:creationId id="{CCF30D01-BC9D-4F8B-9766-0E9583D94AC0}"/>
               </a:ext>
             </a:extLst>
           </ns0:cNvPr>
@@ -24380,7 +24380,7 @@
         </ns0:xfrm>
         <a:graphic>
           <a:graphicData uri="http://schemas.openxmlformats.org/drawingml/2006/chart">
-            <c:chart ns4:id="R6505b03b022a4757"/>
+            <c:chart ns4:id="Re7b128bb73f34430"/>
           </a:graphicData>
         </a:graphic>
       </ns0:graphicFrame>
@@ -24389,7 +24389,7 @@
           <ns0:cNvPr id="25" name="">
             <a:extLst>
               <a:ext uri="{FF2B5EF4-FFF2-40B4-BE49-F238E27FC236}">
-                <ns2:creationId id="{BEA37AAE-5FDB-4C49-A145-41053EC14E46}"/>
+                <ns2:creationId id="{4072165C-B9EE-4EC1-81BC-57B5680D48F6}"/>
               </a:ext>
             </a:extLst>
           </ns0:cNvPr>
@@ -24462,7 +24462,7 @@
           <ns0:cNvPr id="26" name="Chart">
             <a:extLst>
               <a:ext uri="{FF2B5EF4-FFF2-40B4-BE49-F238E27FC236}">
-                <ns2:creationId id="{10507DC3-3AC9-4AA0-9979-3C2A002E5436}"/>
+                <ns2:creationId id="{3BFEE45D-6C21-4761-9577-659EB2C2E525}"/>
               </a:ext>
             </a:extLst>
           </ns0:cNvPr>
@@ -24475,7 +24475,7 @@
         </ns0:xfrm>
         <a:graphic>
           <a:graphicData uri="http://schemas.openxmlformats.org/drawingml/2006/chart">
-            <c:chart ns4:id="Re6d29434240d4a1e"/>
+            <c:chart ns4:id="R55747a77b0ec49be"/>
           </a:graphicData>
         </a:graphic>
       </ns0:graphicFrame>
@@ -24484,7 +24484,7 @@
           <ns0:cNvPr id="27" name="">
             <a:extLst>
               <a:ext uri="{FF2B5EF4-FFF2-40B4-BE49-F238E27FC236}">
-                <ns2:creationId id="{020BC782-D6A2-4C43-8EA0-9F4C014F1A9F}"/>
+                <ns2:creationId id="{5B654B6C-D138-47D3-B8FB-A11B2DE5160E}"/>
               </a:ext>
             </a:extLst>
           </ns0:cNvPr>
@@ -24557,7 +24557,7 @@
           <ns0:cNvPr id="28" name="Chart">
             <a:extLst>
               <a:ext uri="{FF2B5EF4-FFF2-40B4-BE49-F238E27FC236}">
-                <ns2:creationId id="{73BC2243-27ED-4CB3-8166-AFA9DC7061EF}"/>
+                <ns2:creationId id="{830AAD14-3883-4927-B67A-E2EEF805100E}"/>
               </a:ext>
             </a:extLst>
           </ns0:cNvPr>
@@ -24570,7 +24570,7 @@
         </ns0:xfrm>
         <a:graphic>
           <a:graphicData uri="http://schemas.openxmlformats.org/drawingml/2006/chart">
-            <c:chart ns4:id="R3745d504ddf045a3"/>
+            <c:chart ns4:id="R8c359582b1ce4dcb"/>
           </a:graphicData>
         </a:graphic>
       </ns0:graphicFrame>
@@ -24579,7 +24579,7 @@
           <ns0:cNvPr id="29" name="">
             <a:extLst>
               <a:ext uri="{FF2B5EF4-FFF2-40B4-BE49-F238E27FC236}">
-                <ns2:creationId id="{24E5D383-FF80-4D2E-A54F-7EEC46CCC53F}"/>
+                <ns2:creationId id="{4781C3E5-C966-4037-8177-8EDBDAC3C57A}"/>
               </a:ext>
             </a:extLst>
           </ns0:cNvPr>
@@ -24652,7 +24652,7 @@
           <ns0:cNvPr id="30" name="Chart">
             <a:extLst>
               <a:ext uri="{FF2B5EF4-FFF2-40B4-BE49-F238E27FC236}">
-                <ns2:creationId id="{034D32D2-4D4B-4317-A349-33D4D575FF71}"/>
+                <ns2:creationId id="{59D42D3C-621C-483C-8A91-BB3FDE1F75E8}"/>
               </a:ext>
             </a:extLst>
           </ns0:cNvPr>
@@ -24665,7 +24665,7 @@
         </ns0:xfrm>
         <a:graphic>
           <a:graphicData uri="http://schemas.openxmlformats.org/drawingml/2006/chart">
-            <c:chart ns4:id="Rdd0471f9323a4e35"/>
+            <c:chart ns4:id="Rf79bce7281f44b8f"/>
           </a:graphicData>
         </a:graphic>
       </ns0:graphicFrame>
@@ -24674,7 +24674,7 @@
           <ns0:cNvPr id="31" name="">
             <a:extLst>
               <a:ext uri="{FF2B5EF4-FFF2-40B4-BE49-F238E27FC236}">
-                <ns2:creationId id="{EC3ED0B6-87F9-474E-9F78-F17F1496DCA0}"/>
+                <ns2:creationId id="{E79E0CFA-8988-4DE4-96D8-17026D9A6F3D}"/>
               </a:ext>
             </a:extLst>
           </ns0:cNvPr>
@@ -24747,7 +24747,7 @@
           <ns0:cNvPr id="32" name="Chart">
             <a:extLst>
               <a:ext uri="{FF2B5EF4-FFF2-40B4-BE49-F238E27FC236}">
-                <ns2:creationId id="{BA938DCD-F8B9-4151-8852-1EDBB56CD2BD}"/>
+                <ns2:creationId id="{37D1C81F-EEFE-42C5-AB1B-8424F4001265}"/>
               </a:ext>
             </a:extLst>
           </ns0:cNvPr>
@@ -24760,7 +24760,7 @@
         </ns0:xfrm>
         <a:graphic>
           <a:graphicData uri="http://schemas.openxmlformats.org/drawingml/2006/chart">
-            <c:chart ns4:id="Rd0b29a38801b4047"/>
+            <c:chart ns4:id="R8573d50654e64b6e"/>
           </a:graphicData>
         </a:graphic>
       </ns0:graphicFrame>
@@ -24769,7 +24769,7 @@
           <ns0:cNvPr id="33" name="">
             <a:extLst>
               <a:ext uri="{FF2B5EF4-FFF2-40B4-BE49-F238E27FC236}">
-                <ns2:creationId id="{20908B9B-4F46-415A-8935-70BBCE9C8F60}"/>
+                <ns2:creationId id="{62C5FBF7-4A84-4EB5-A90E-872E373D7435}"/>
               </a:ext>
             </a:extLst>
           </ns0:cNvPr>
@@ -24842,7 +24842,7 @@
           <ns0:cNvPr id="34" name="Chart">
             <a:extLst>
               <a:ext uri="{FF2B5EF4-FFF2-40B4-BE49-F238E27FC236}">
-                <ns2:creationId id="{9CE54A04-CC5C-4C40-8CEE-07D51466F607}"/>
+                <ns2:creationId id="{A60D395A-FD8A-4850-A032-A10996D560F4}"/>
               </a:ext>
             </a:extLst>
           </ns0:cNvPr>
@@ -24855,14 +24855,14 @@
         </ns0:xfrm>
         <a:graphic>
           <a:graphicData uri="http://schemas.openxmlformats.org/drawingml/2006/chart">
-            <c:chart ns4:id="R26035e19fc7247f9"/>
+            <c:chart ns4:id="R0054274b2a0d4c35"/>
           </a:graphicData>
         </a:graphic>
       </ns0:graphicFrame>
     </ns0:spTree>
     <ns0:extLst>
       <ns0:ext uri="{BB962C8B-B14F-4D97-AF65-F5344CB8AC3E}">
-        <ns5:creationId val="956833371"/>
+        <ns5:creationId val="979499775"/>
       </ns0:ext>
     </ns0:extLst>
   </ns0:cSld>
@@ -24893,7 +24893,7 @@
           <ns0:cNvPr id="21" name="">
             <a:extLst>
               <a:ext uri="{FF2B5EF4-FFF2-40B4-BE49-F238E27FC236}">
-                <ns2:creationId id="{0210E5BF-DF4B-4CE8-B008-C05FB364C5A5}"/>
+                <ns2:creationId id="{8FB1E5B2-72CF-418E-8A9A-7EA501230E3B}"/>
               </a:ext>
             </a:extLst>
           </ns0:cNvPr>
@@ -24966,7 +24966,7 @@
           <ns0:cNvPr id="2" name="">
             <a:extLst>
               <a:ext uri="{FF2B5EF4-FFF2-40B4-BE49-F238E27FC236}">
-                <ns2:creationId id="{FE308CE3-909F-44AA-94DD-34AD48243D9D}"/>
+                <ns2:creationId id="{D01EC24C-B222-4318-AF80-253577AE008D}"/>
               </a:ext>
             </a:extLst>
           </ns0:cNvPr>
@@ -25039,7 +25039,7 @@
           <ns0:cNvPr id="3" name="">
             <a:extLst>
               <a:ext uri="{FF2B5EF4-FFF2-40B4-BE49-F238E27FC236}">
-                <ns2:creationId id="{0463F862-8B9F-455A-AC6A-F96AB13EEB43}"/>
+                <ns2:creationId id="{DBBC3920-8EFD-4962-8BDA-569045D15E6F}"/>
               </a:ext>
             </a:extLst>
           </ns0:cNvPr>
@@ -25070,7 +25070,7 @@
           <ns0:cNvPr id="4" name="">
             <a:extLst>
               <a:ext uri="{FF2B5EF4-FFF2-40B4-BE49-F238E27FC236}">
-                <ns2:creationId id="{BAAC0D64-8154-4B17-B34E-08FB3A98E89C}"/>
+                <ns2:creationId id="{4763F622-70ED-43F1-9987-BD2B0C3BFE80}"/>
               </a:ext>
             </a:extLst>
           </ns0:cNvPr>
@@ -25101,7 +25101,7 @@
           <ns0:cNvPr id="5" name="">
             <a:extLst>
               <a:ext uri="{FF2B5EF4-FFF2-40B4-BE49-F238E27FC236}">
-                <ns2:creationId id="{23B3C122-FA60-4603-9962-9DE4D08AEE8A}"/>
+                <ns2:creationId id="{3259B2FE-D553-4D87-8AB0-572BA0DD845A}"/>
               </a:ext>
             </a:extLst>
           </ns0:cNvPr>
@@ -25174,7 +25174,7 @@
           <ns0:cNvPr id="6" name="">
             <a:extLst>
               <a:ext uri="{FF2B5EF4-FFF2-40B4-BE49-F238E27FC236}">
-                <ns2:creationId id="{13589978-FFD8-497E-87AB-AB27378A4799}"/>
+                <ns2:creationId id="{D44F6B3B-B1EF-4A3B-A5A4-9F6B7D4CD9BC}"/>
               </a:ext>
             </a:extLst>
           </ns0:cNvPr>
@@ -25247,7 +25247,7 @@
           <ns0:cNvPr id="7" name="">
             <a:extLst>
               <a:ext uri="{FF2B5EF4-FFF2-40B4-BE49-F238E27FC236}">
-                <ns2:creationId id="{D88F25A0-09FC-47FE-8954-113BB96E0204}"/>
+                <ns2:creationId id="{F747B034-6AAD-4D32-A19D-406ABCA06B11}"/>
               </a:ext>
             </a:extLst>
           </ns0:cNvPr>
@@ -25320,7 +25320,7 @@
           <ns0:cNvPr id="8" name="">
             <a:extLst>
               <a:ext uri="{FF2B5EF4-FFF2-40B4-BE49-F238E27FC236}">
-                <ns2:creationId id="{8AFE5B69-71D9-455C-AC92-A6377BE48C8D}"/>
+                <ns2:creationId id="{3434497D-EA17-4524-AE7E-BFEED38CFDE1}"/>
               </a:ext>
             </a:extLst>
           </ns0:cNvPr>
@@ -25351,7 +25351,7 @@
           <ns0:cNvPr id="9" name="Chart">
             <a:extLst>
               <a:ext uri="{FF2B5EF4-FFF2-40B4-BE49-F238E27FC236}">
-                <ns2:creationId id="{FC208C9F-E6E1-4D12-9710-0BC6CBB43053}"/>
+                <ns2:creationId id="{D5696EEA-4B55-46F3-9BEE-ADC8CCAA11DB}"/>
               </a:ext>
             </a:extLst>
           </ns0:cNvPr>
@@ -25364,7 +25364,7 @@
         </ns0:xfrm>
         <a:graphic>
           <a:graphicData uri="http://schemas.openxmlformats.org/drawingml/2006/chart">
-            <c:chart ns4:id="Raa4668c8492e4e00"/>
+            <c:chart ns4:id="R7a2654455d0f4767"/>
           </a:graphicData>
         </a:graphic>
       </ns0:graphicFrame>
@@ -25373,7 +25373,7 @@
           <ns0:cNvPr id="10" name="">
             <a:extLst>
               <a:ext uri="{FF2B5EF4-FFF2-40B4-BE49-F238E27FC236}">
-                <ns2:creationId id="{28F98666-BDBA-4075-B5AD-A91711590037}"/>
+                <ns2:creationId id="{3FE021AE-5748-401C-B1F2-AA4A974C37EA}"/>
               </a:ext>
             </a:extLst>
           </ns0:cNvPr>
@@ -25404,7 +25404,7 @@
           <ns0:cNvPr id="11" name="">
             <a:extLst>
               <a:ext uri="{FF2B5EF4-FFF2-40B4-BE49-F238E27FC236}">
-                <ns2:creationId id="{CB12F779-F377-4F13-9428-A31033696AC1}"/>
+                <ns2:creationId id="{0751C47C-CB48-47A4-9FA7-2596243ACCBF}"/>
               </a:ext>
             </a:extLst>
           </ns0:cNvPr>
@@ -25477,7 +25477,7 @@
           <ns0:cNvPr id="12" name="">
             <a:extLst>
               <a:ext uri="{FF2B5EF4-FFF2-40B4-BE49-F238E27FC236}">
-                <ns2:creationId id="{2DF9B2C0-27BA-45A4-9E53-AA261EBBC4D7}"/>
+                <ns2:creationId id="{E50AD071-0C6D-4DAF-ACDB-41967D44ECFC}"/>
               </a:ext>
             </a:extLst>
           </ns0:cNvPr>
@@ -25508,7 +25508,7 @@
           <ns0:cNvPr id="13" name="Chart">
             <a:extLst>
               <a:ext uri="{FF2B5EF4-FFF2-40B4-BE49-F238E27FC236}">
-                <ns2:creationId id="{51F3F9B2-888C-41CC-8CEC-9E34F5A0B007}"/>
+                <ns2:creationId id="{E3AF6BFC-2183-409F-98A7-65F1D62BC279}"/>
               </a:ext>
             </a:extLst>
           </ns0:cNvPr>
@@ -25521,7 +25521,7 @@
         </ns0:xfrm>
         <a:graphic>
           <a:graphicData uri="http://schemas.openxmlformats.org/drawingml/2006/chart">
-            <c:chart ns4:id="R40c33382c55a4180"/>
+            <c:chart ns4:id="R292b1b1c3eb84f53"/>
           </a:graphicData>
         </a:graphic>
       </ns0:graphicFrame>
@@ -25530,7 +25530,7 @@
           <ns0:cNvPr id="14" name="">
             <a:extLst>
               <a:ext uri="{FF2B5EF4-FFF2-40B4-BE49-F238E27FC236}">
-                <ns2:creationId id="{F668A039-DBBC-46FA-AD16-42433E60BBE8}"/>
+                <ns2:creationId id="{9D245FB5-1ACF-465E-BCDF-6E1A8F9B07B2}"/>
               </a:ext>
             </a:extLst>
           </ns0:cNvPr>
@@ -25561,7 +25561,7 @@
           <ns0:cNvPr id="15" name="">
             <a:extLst>
               <a:ext uri="{FF2B5EF4-FFF2-40B4-BE49-F238E27FC236}">
-                <ns2:creationId id="{CBD6AC89-30C3-4AE2-A7B9-8A3DB19C0EC8}"/>
+                <ns2:creationId id="{83267AAB-C982-4CDE-A343-B71F97078D47}"/>
               </a:ext>
             </a:extLst>
           </ns0:cNvPr>
@@ -25592,7 +25592,7 @@
           <ns0:cNvPr id="16" name="">
             <a:extLst>
               <a:ext uri="{FF2B5EF4-FFF2-40B4-BE49-F238E27FC236}">
-                <ns2:creationId id="{EA00BE02-7121-43EF-BFF7-FA8E3EAF0AB4}"/>
+                <ns2:creationId id="{400BF4DE-8BF1-4BDA-9B8B-BCA9AE6B792C}"/>
               </a:ext>
             </a:extLst>
           </ns0:cNvPr>
@@ -25655,7 +25655,7 @@
                 <a:ea typeface="Arial"/>
                 <a:cs typeface="Arial"/>
               </a:rPr>
-              <a:t>Cobertura de PL, dez/25 → Ago/26: administração 100,0% → 100,0%; gestão 98,1% → 100,0%; custódia 97,1% → 99,3%.</a:t>
+              <a:t>Cobertura de PL, dez/25 → Ago/26: administração 100,0% → 100,0%; gestão 98,0% → 100,0%; custódia 97,0% → 99,3%.</a:t>
             </a:r>
           </a:p>
         </ns0:txBody>
@@ -25665,7 +25665,7 @@
           <ns0:cNvPr id="17" name="">
             <a:extLst>
               <a:ext uri="{FF2B5EF4-FFF2-40B4-BE49-F238E27FC236}">
-                <ns2:creationId id="{DE675B7D-1CFF-4E81-9A0C-E2A200AA8135}"/>
+                <ns2:creationId id="{A03DA6FF-1344-4AA2-9B47-780F9F9F9D65}"/>
               </a:ext>
             </a:extLst>
           </ns0:cNvPr>
@@ -25696,7 +25696,7 @@
           <ns0:cNvPr id="18" name="">
             <a:extLst>
               <a:ext uri="{FF2B5EF4-FFF2-40B4-BE49-F238E27FC236}">
-                <ns2:creationId id="{A65161FE-D4F9-4ADD-B7C2-5640E888C951}"/>
+                <ns2:creationId id="{A76E3E82-9DDE-4034-A6E0-4A563BE69C19}"/>
               </a:ext>
             </a:extLst>
           </ns0:cNvPr>
@@ -25769,7 +25769,7 @@
           <ns0:cNvPr id="19" name="">
             <a:extLst>
               <a:ext uri="{FF2B5EF4-FFF2-40B4-BE49-F238E27FC236}">
-                <ns2:creationId id="{57F0C5A6-41E3-45E5-84A3-44E4652E66A6}"/>
+                <ns2:creationId id="{194DB3A3-8847-473C-9067-CC36B9754C54}"/>
               </a:ext>
             </a:extLst>
           </ns0:cNvPr>
@@ -25800,7 +25800,7 @@
           <ns0:cNvPr id="20" name="">
             <a:extLst>
               <a:ext uri="{FF2B5EF4-FFF2-40B4-BE49-F238E27FC236}">
-                <ns2:creationId id="{91C44330-2DEB-4E91-99AF-C575E8A3B825}"/>
+                <ns2:creationId id="{75BA11F0-9E25-48FE-BDA0-A834AF79C096}"/>
               </a:ext>
             </a:extLst>
           </ns0:cNvPr>
@@ -25871,7 +25871,7 @@
     </ns0:spTree>
     <ns0:extLst>
       <ns0:ext uri="{BB962C8B-B14F-4D97-AF65-F5344CB8AC3E}">
-        <ns5:creationId val="1750882732"/>
+        <ns5:creationId val="123782495"/>
       </ns0:ext>
     </ns0:extLst>
   </ns0:cSld>
@@ -25902,7 +25902,7 @@
           <ns0:cNvPr id="17" name="">
             <a:extLst>
               <a:ext uri="{FF2B5EF4-FFF2-40B4-BE49-F238E27FC236}">
-                <ns2:creationId id="{7A7548AD-66B2-429A-9B9C-EF0B510DCF7D}"/>
+                <ns2:creationId id="{9AEB4670-A3D9-4FDE-A620-332C8455AC5C}"/>
               </a:ext>
             </a:extLst>
           </ns0:cNvPr>
@@ -25975,7 +25975,7 @@
           <ns0:cNvPr id="2" name="">
             <a:extLst>
               <a:ext uri="{FF2B5EF4-FFF2-40B4-BE49-F238E27FC236}">
-                <ns2:creationId id="{1F2710EA-2F7E-460B-A86C-6B4F75C542D3}"/>
+                <ns2:creationId id="{D337AABD-0C15-4BDA-843E-35C9D6C8B5A4}"/>
               </a:ext>
             </a:extLst>
           </ns0:cNvPr>
@@ -26048,7 +26048,7 @@
           <ns0:cNvPr id="3" name="">
             <a:extLst>
               <a:ext uri="{FF2B5EF4-FFF2-40B4-BE49-F238E27FC236}">
-                <ns2:creationId id="{03421AEC-55D6-4E87-BF66-CECDD10EB6BA}"/>
+                <ns2:creationId id="{3D677608-3BFB-4FEC-8A2B-3EDD9B78CD6A}"/>
               </a:ext>
             </a:extLst>
           </ns0:cNvPr>
@@ -26079,7 +26079,7 @@
           <ns0:cNvPr id="4" name="">
             <a:extLst>
               <a:ext uri="{FF2B5EF4-FFF2-40B4-BE49-F238E27FC236}">
-                <ns2:creationId id="{00D42E59-1AB2-4EF5-88B3-5763F420DEBD}"/>
+                <ns2:creationId id="{C3EDDB40-5C01-48ED-8089-D08BAA1DD0AD}"/>
               </a:ext>
             </a:extLst>
           </ns0:cNvPr>
@@ -26110,7 +26110,7 @@
           <ns0:cNvPr id="5" name="">
             <a:extLst>
               <a:ext uri="{FF2B5EF4-FFF2-40B4-BE49-F238E27FC236}">
-                <ns2:creationId id="{FD562494-FF0B-4481-8765-788A85115799}"/>
+                <ns2:creationId id="{FE3F0DBC-9FA6-48D4-8C19-83636DB75C45}"/>
               </a:ext>
             </a:extLst>
           </ns0:cNvPr>
@@ -26183,7 +26183,7 @@
           <ns0:cNvPr id="6" name="">
             <a:extLst>
               <a:ext uri="{FF2B5EF4-FFF2-40B4-BE49-F238E27FC236}">
-                <ns2:creationId id="{80FA2815-1925-4A69-A260-C75AAB60A84B}"/>
+                <ns2:creationId id="{C147702A-241B-4448-9F89-C0ECD548D9D1}"/>
               </a:ext>
             </a:extLst>
           </ns0:cNvPr>
@@ -26256,7 +26256,7 @@
           <ns0:cNvPr id="7" name="">
             <a:extLst>
               <a:ext uri="{FF2B5EF4-FFF2-40B4-BE49-F238E27FC236}">
-                <ns2:creationId id="{58386E7B-F2D0-493D-B4EC-02A2D71A09D6}"/>
+                <ns2:creationId id="{6DFDE0B9-AD23-4054-82E9-CCE4FF09247A}"/>
               </a:ext>
             </a:extLst>
           </ns0:cNvPr>
@@ -26329,7 +26329,7 @@
           <ns0:cNvPr id="8" name="">
             <a:extLst>
               <a:ext uri="{FF2B5EF4-FFF2-40B4-BE49-F238E27FC236}">
-                <ns2:creationId id="{8EADD67D-F2BD-4671-8AE7-2F403736BF3D}"/>
+                <ns2:creationId id="{2F00B5F8-A882-4A17-8FAD-A46C5EB9542C}"/>
               </a:ext>
             </a:extLst>
           </ns0:cNvPr>
@@ -26360,7 +26360,7 @@
           <ns0:cNvPr id="9" name="Chart">
             <a:extLst>
               <a:ext uri="{FF2B5EF4-FFF2-40B4-BE49-F238E27FC236}">
-                <ns2:creationId id="{20A034E2-F3C5-41B4-847C-F8CCE5B9F10E}"/>
+                <ns2:creationId id="{D85D249B-ECCD-4016-87F2-37579971747C}"/>
               </a:ext>
             </a:extLst>
           </ns0:cNvPr>
@@ -26373,7 +26373,7 @@
         </ns0:xfrm>
         <a:graphic>
           <a:graphicData uri="http://schemas.openxmlformats.org/drawingml/2006/chart">
-            <c:chart ns4:id="R9244f9814f69458d"/>
+            <c:chart ns4:id="Rc598b04d4da64514"/>
           </a:graphicData>
         </a:graphic>
       </ns0:graphicFrame>
@@ -26382,7 +26382,7 @@
           <ns0:cNvPr id="10" name="">
             <a:extLst>
               <a:ext uri="{FF2B5EF4-FFF2-40B4-BE49-F238E27FC236}">
-                <ns2:creationId id="{A40517A4-7125-4679-B6BC-9405C82DCA8C}"/>
+                <ns2:creationId id="{12FE8E38-D28E-4F4F-8337-28B55FA6C197}"/>
               </a:ext>
             </a:extLst>
           </ns0:cNvPr>
@@ -26455,7 +26455,7 @@
           <ns0:cNvPr id="11" name="">
             <a:extLst>
               <a:ext uri="{FF2B5EF4-FFF2-40B4-BE49-F238E27FC236}">
-                <ns2:creationId id="{8F97093A-161C-4B24-A974-B6E7CDD6E005}"/>
+                <ns2:creationId id="{D1FE1894-1737-48C5-9C9C-711E1EDEA6BF}"/>
               </a:ext>
             </a:extLst>
           </ns0:cNvPr>
@@ -26486,7 +26486,7 @@
           <ns0:cNvPr id="12" name="Chart">
             <a:extLst>
               <a:ext uri="{FF2B5EF4-FFF2-40B4-BE49-F238E27FC236}">
-                <ns2:creationId id="{EBBCA7B1-5569-4CBF-8C13-3A940E9A3D8F}"/>
+                <ns2:creationId id="{23263725-FF8C-4A06-B3A1-E9DDB2F9F8D2}"/>
               </a:ext>
             </a:extLst>
           </ns0:cNvPr>
@@ -26499,7 +26499,7 @@
         </ns0:xfrm>
         <a:graphic>
           <a:graphicData uri="http://schemas.openxmlformats.org/drawingml/2006/chart">
-            <c:chart ns4:id="Rb11b9cc868ab40a1"/>
+            <c:chart ns4:id="Ra8aa9b4b79cd430c"/>
           </a:graphicData>
         </a:graphic>
       </ns0:graphicFrame>
@@ -26508,7 +26508,7 @@
           <ns0:cNvPr id="13" name="">
             <a:extLst>
               <a:ext uri="{FF2B5EF4-FFF2-40B4-BE49-F238E27FC236}">
-                <ns2:creationId id="{C3BFBF1F-6FB0-446A-BCD7-E3B7EA81F9EA}"/>
+                <ns2:creationId id="{3F49FDC0-504F-4036-902C-25FAB1E3D9FE}"/>
               </a:ext>
             </a:extLst>
           </ns0:cNvPr>
@@ -26581,7 +26581,7 @@
           <ns0:cNvPr id="14" name="">
             <a:extLst>
               <a:ext uri="{FF2B5EF4-FFF2-40B4-BE49-F238E27FC236}">
-                <ns2:creationId id="{8FC89927-0689-43E7-B91E-4FA5C23F90C0}"/>
+                <ns2:creationId id="{93EF77BF-5F26-4311-AE06-B475D340EDFD}"/>
               </a:ext>
             </a:extLst>
           </ns0:cNvPr>
@@ -26612,7 +26612,7 @@
           <ns0:cNvPr id="15" name="Chart">
             <a:extLst>
               <a:ext uri="{FF2B5EF4-FFF2-40B4-BE49-F238E27FC236}">
-                <ns2:creationId id="{22584D43-4EB9-475E-B52F-543AC568CC96}"/>
+                <ns2:creationId id="{06517584-48B6-4B9D-9409-D354468F6504}"/>
               </a:ext>
             </a:extLst>
           </ns0:cNvPr>
@@ -26625,7 +26625,7 @@
         </ns0:xfrm>
         <a:graphic>
           <a:graphicData uri="http://schemas.openxmlformats.org/drawingml/2006/chart">
-            <c:chart ns4:id="Rc6be9a6c2f814bb6"/>
+            <c:chart ns4:id="R6f39bb6db2f34fb7"/>
           </a:graphicData>
         </a:graphic>
       </ns0:graphicFrame>
@@ -26634,7 +26634,7 @@
           <ns0:cNvPr id="16" name="">
             <a:extLst>
               <a:ext uri="{FF2B5EF4-FFF2-40B4-BE49-F238E27FC236}">
-                <ns2:creationId id="{8A4B7DA4-F0FB-4956-AF67-84AFC2142310}"/>
+                <ns2:creationId id="{381F5F3D-913B-427F-976F-3A92A88E3C5C}"/>
               </a:ext>
             </a:extLst>
           </ns0:cNvPr>
@@ -26705,7 +26705,7 @@
     </ns0:spTree>
     <ns0:extLst>
       <ns0:ext uri="{BB962C8B-B14F-4D97-AF65-F5344CB8AC3E}">
-        <ns5:creationId val="2021987922"/>
+        <ns5:creationId val="148703339"/>
       </ns0:ext>
     </ns0:extLst>
   </ns0:cSld>
@@ -26736,7 +26736,7 @@
           <ns0:cNvPr id="26" name="">
             <a:extLst>
               <a:ext uri="{FF2B5EF4-FFF2-40B4-BE49-F238E27FC236}">
-                <ns2:creationId id="{C7617F3C-4EDE-4BFF-9302-4EB157503AD0}"/>
+                <ns2:creationId id="{A5DD1060-4EA6-4234-BC71-528693D7AC98}"/>
               </a:ext>
             </a:extLst>
           </ns0:cNvPr>
@@ -26809,7 +26809,7 @@
           <ns0:cNvPr id="2" name="">
             <a:extLst>
               <a:ext uri="{FF2B5EF4-FFF2-40B4-BE49-F238E27FC236}">
-                <ns2:creationId id="{316207D3-A5AD-46AB-BA2D-5E9B7BA53478}"/>
+                <ns2:creationId id="{259BA6BB-FDD5-4C08-BF95-F8D80924FFA9}"/>
               </a:ext>
             </a:extLst>
           </ns0:cNvPr>
@@ -26882,7 +26882,7 @@
           <ns0:cNvPr id="3" name="">
             <a:extLst>
               <a:ext uri="{FF2B5EF4-FFF2-40B4-BE49-F238E27FC236}">
-                <ns2:creationId id="{042C6CC7-AB21-4936-B570-F56B24EDC089}"/>
+                <ns2:creationId id="{5E52AF65-7539-4821-B1E6-32B1CB159A74}"/>
               </a:ext>
             </a:extLst>
           </ns0:cNvPr>
@@ -26913,7 +26913,7 @@
           <ns0:cNvPr id="4" name="">
             <a:extLst>
               <a:ext uri="{FF2B5EF4-FFF2-40B4-BE49-F238E27FC236}">
-                <ns2:creationId id="{6418E0A2-F03E-48DF-AD7E-3795DB07C227}"/>
+                <ns2:creationId id="{67E0D998-CA65-43DE-97E9-66ADFDE5B1DB}"/>
               </a:ext>
             </a:extLst>
           </ns0:cNvPr>
@@ -26944,7 +26944,7 @@
           <ns0:cNvPr id="5" name="">
             <a:extLst>
               <a:ext uri="{FF2B5EF4-FFF2-40B4-BE49-F238E27FC236}">
-                <ns2:creationId id="{593F6B76-E9DA-4551-B14C-FDCF0DB0C642}"/>
+                <ns2:creationId id="{B6360606-A973-4684-99BE-5A65BAC946C2}"/>
               </a:ext>
             </a:extLst>
           </ns0:cNvPr>
@@ -27017,7 +27017,7 @@
           <ns0:cNvPr id="6" name="">
             <a:extLst>
               <a:ext uri="{FF2B5EF4-FFF2-40B4-BE49-F238E27FC236}">
-                <ns2:creationId id="{49970957-A4EE-4BB4-807E-B7611E2D9987}"/>
+                <ns2:creationId id="{9FA97C08-018B-4ECB-8771-45DE3BBCE30D}"/>
               </a:ext>
             </a:extLst>
           </ns0:cNvPr>
@@ -27090,7 +27090,7 @@
           <ns0:cNvPr id="7" name="">
             <a:extLst>
               <a:ext uri="{FF2B5EF4-FFF2-40B4-BE49-F238E27FC236}">
-                <ns2:creationId id="{D4996471-F2CC-4A91-BF39-5E7BEAE39001}"/>
+                <ns2:creationId id="{2BBB55F2-9C4F-4BD4-9D22-9D0870BC732F}"/>
               </a:ext>
             </a:extLst>
           </ns0:cNvPr>
@@ -27121,7 +27121,7 @@
           <ns0:cNvPr id="8" name="">
             <a:extLst>
               <a:ext uri="{FF2B5EF4-FFF2-40B4-BE49-F238E27FC236}">
-                <ns2:creationId id="{3E3E13FB-110E-47C1-A750-15EE0A5DC2A0}"/>
+                <ns2:creationId id="{79410E09-BC3E-4603-8BBA-4E85407F9B54}"/>
               </a:ext>
             </a:extLst>
           </ns0:cNvPr>
@@ -27194,7 +27194,7 @@
           <ns0:cNvPr id="9" name="">
             <a:extLst>
               <a:ext uri="{FF2B5EF4-FFF2-40B4-BE49-F238E27FC236}">
-                <ns2:creationId id="{C4418EEB-6EE7-4804-8655-0EC6B22CAB51}"/>
+                <ns2:creationId id="{16360A2A-3D11-4336-943B-E9054BA946F2}"/>
               </a:ext>
             </a:extLst>
           </ns0:cNvPr>
@@ -27225,7 +27225,7 @@
           <ns0:cNvPr id="10" name="">
             <a:extLst>
               <a:ext uri="{FF2B5EF4-FFF2-40B4-BE49-F238E27FC236}">
-                <ns2:creationId id="{B22C1A01-A760-49FB-845C-0D102FC34956}"/>
+                <ns2:creationId id="{CA80E8F9-BE28-42CB-9262-4CB212C6C93A}"/>
               </a:ext>
             </a:extLst>
           </ns0:cNvPr>
@@ -27298,7 +27298,7 @@
           <ns0:cNvPr id="11" name="">
             <a:extLst>
               <a:ext uri="{FF2B5EF4-FFF2-40B4-BE49-F238E27FC236}">
-                <ns2:creationId id="{2A31BA48-9036-4F22-800C-957B2A533F4E}"/>
+                <ns2:creationId id="{AF771EAA-4973-4177-8AA9-94A7BEC6749B}"/>
               </a:ext>
             </a:extLst>
           </ns0:cNvPr>
@@ -27371,7 +27371,7 @@
           <ns0:cNvPr id="12" name="">
             <a:extLst>
               <a:ext uri="{FF2B5EF4-FFF2-40B4-BE49-F238E27FC236}">
-                <ns2:creationId id="{8A8EEF99-7BF7-4AE4-86B4-D8872DA790BD}"/>
+                <ns2:creationId id="{1FE9430B-C110-4A02-9336-F8BB58D28235}"/>
               </a:ext>
             </a:extLst>
           </ns0:cNvPr>
@@ -27402,7 +27402,7 @@
           <ns0:cNvPr id="13" name="Chart">
             <a:extLst>
               <a:ext uri="{FF2B5EF4-FFF2-40B4-BE49-F238E27FC236}">
-                <ns2:creationId id="{63CC2431-C691-4E6D-A1A3-14ABAB35757D}"/>
+                <ns2:creationId id="{A44E673B-C2F3-4C89-B1AB-AF020A3131B0}"/>
               </a:ext>
             </a:extLst>
           </ns0:cNvPr>
@@ -27415,7 +27415,7 @@
         </ns0:xfrm>
         <a:graphic>
           <a:graphicData uri="http://schemas.openxmlformats.org/drawingml/2006/chart">
-            <c:chart ns4:id="R519a66e45bc6470d"/>
+            <c:chart ns4:id="R3a5b1e910d6743f3"/>
           </a:graphicData>
         </a:graphic>
       </ns0:graphicFrame>
@@ -27424,7 +27424,7 @@
           <ns0:cNvPr id="14" name="">
             <a:extLst>
               <a:ext uri="{FF2B5EF4-FFF2-40B4-BE49-F238E27FC236}">
-                <ns2:creationId id="{E708CC03-D778-40F3-8867-18CED71F56F7}"/>
+                <ns2:creationId id="{14AFB9BB-9ECF-4AB6-A5A0-BC0DA296E218}"/>
               </a:ext>
             </a:extLst>
           </ns0:cNvPr>
@@ -27497,7 +27497,7 @@
           <ns0:cNvPr id="15" name="">
             <a:extLst>
               <a:ext uri="{FF2B5EF4-FFF2-40B4-BE49-F238E27FC236}">
-                <ns2:creationId id="{8021B44E-16FA-422A-A87B-C7AD774C85AC}"/>
+                <ns2:creationId id="{881BEB84-9905-4581-B3B2-272341628C62}"/>
               </a:ext>
             </a:extLst>
           </ns0:cNvPr>
@@ -27528,7 +27528,7 @@
           <ns0:cNvPr id="16" name="Chart">
             <a:extLst>
               <a:ext uri="{FF2B5EF4-FFF2-40B4-BE49-F238E27FC236}">
-                <ns2:creationId id="{DBB7596F-DC56-4552-A8B3-5F0966861FDD}"/>
+                <ns2:creationId id="{DED894E7-A87E-4073-B62A-B2B8B4E7D952}"/>
               </a:ext>
             </a:extLst>
           </ns0:cNvPr>
@@ -27541,7 +27541,7 @@
         </ns0:xfrm>
         <a:graphic>
           <a:graphicData uri="http://schemas.openxmlformats.org/drawingml/2006/chart">
-            <c:chart ns4:id="R8ca47764c9574c14"/>
+            <c:chart ns4:id="Rdd54c746a7f349aa"/>
           </a:graphicData>
         </a:graphic>
       </ns0:graphicFrame>
@@ -27550,7 +27550,7 @@
           <ns0:cNvPr id="17" name="">
             <a:extLst>
               <a:ext uri="{FF2B5EF4-FFF2-40B4-BE49-F238E27FC236}">
-                <ns2:creationId id="{13E0571B-60C6-490C-A20D-8A295F99E70E}"/>
+                <ns2:creationId id="{AC0A64FE-272D-421A-A470-6BB9E43370F9}"/>
               </a:ext>
             </a:extLst>
           </ns0:cNvPr>
@@ -27623,7 +27623,7 @@
           <ns0:cNvPr id="18" name="">
             <a:extLst>
               <a:ext uri="{FF2B5EF4-FFF2-40B4-BE49-F238E27FC236}">
-                <ns2:creationId id="{F401D153-2D4B-4890-B540-E23902644298}"/>
+                <ns2:creationId id="{73F4898F-59B0-4F09-B210-DA6461C96FE4}"/>
               </a:ext>
             </a:extLst>
           </ns0:cNvPr>
@@ -27654,7 +27654,7 @@
           <ns0:cNvPr id="19" name="Chart">
             <a:extLst>
               <a:ext uri="{FF2B5EF4-FFF2-40B4-BE49-F238E27FC236}">
-                <ns2:creationId id="{7DBF70CA-DFA3-4497-A048-A4336C63A4E6}"/>
+                <ns2:creationId id="{3BBF6140-7F26-491A-82C5-04B9204DB173}"/>
               </a:ext>
             </a:extLst>
           </ns0:cNvPr>
@@ -27667,7 +27667,7 @@
         </ns0:xfrm>
         <a:graphic>
           <a:graphicData uri="http://schemas.openxmlformats.org/drawingml/2006/chart">
-            <c:chart ns4:id="Rdc0cd18fb5144ec6"/>
+            <c:chart ns4:id="R7025f88795784574"/>
           </a:graphicData>
         </a:graphic>
       </ns0:graphicFrame>
@@ -27676,7 +27676,7 @@
           <ns0:cNvPr id="20" name="">
             <a:extLst>
               <a:ext uri="{FF2B5EF4-FFF2-40B4-BE49-F238E27FC236}">
-                <ns2:creationId id="{F117F458-F55D-4C2B-A64E-A59347353810}"/>
+                <ns2:creationId id="{CD934F44-C82E-4D91-846A-346037482C77}"/>
               </a:ext>
             </a:extLst>
           </ns0:cNvPr>
@@ -27749,7 +27749,7 @@
           <ns0:cNvPr id="21" name="">
             <a:extLst>
               <a:ext uri="{FF2B5EF4-FFF2-40B4-BE49-F238E27FC236}">
-                <ns2:creationId id="{7BAFD8B8-930F-4970-B434-D040412C03CA}"/>
+                <ns2:creationId id="{90AC6836-894B-4FC4-9D0B-6F5FFECBAD12}"/>
               </a:ext>
             </a:extLst>
           </ns0:cNvPr>
@@ -27822,7 +27822,7 @@
           <ns0:cNvPr id="22" name="">
             <a:extLst>
               <a:ext uri="{FF2B5EF4-FFF2-40B4-BE49-F238E27FC236}">
-                <ns2:creationId id="{2015AD1B-6149-443E-BE10-FA8FFF30271C}"/>
+                <ns2:creationId id="{851D35B1-AB3E-4496-B449-AAFC689B164B}"/>
               </a:ext>
             </a:extLst>
           </ns0:cNvPr>
@@ -27853,7 +27853,7 @@
           <ns0:cNvPr id="23" name="Chart">
             <a:extLst>
               <a:ext uri="{FF2B5EF4-FFF2-40B4-BE49-F238E27FC236}">
-                <ns2:creationId id="{E0237ACA-EE94-4357-B92D-0247724D9228}"/>
+                <ns2:creationId id="{78324CB2-4AC3-4CE2-B86C-889138F3D7BE}"/>
               </a:ext>
             </a:extLst>
           </ns0:cNvPr>
@@ -27866,7 +27866,7 @@
         </ns0:xfrm>
         <a:graphic>
           <a:graphicData uri="http://schemas.openxmlformats.org/drawingml/2006/chart">
-            <c:chart ns4:id="R95571c662a1f4c8c"/>
+            <c:chart ns4:id="R252c8006f48f4a32"/>
           </a:graphicData>
         </a:graphic>
       </ns0:graphicFrame>
@@ -27875,7 +27875,7 @@
           <ns0:cNvPr id="24" name="">
             <a:extLst>
               <a:ext uri="{FF2B5EF4-FFF2-40B4-BE49-F238E27FC236}">
-                <ns2:creationId id="{EE48D42C-5D91-4A50-96F5-B2EF689B90FB}"/>
+                <ns2:creationId id="{C0CB92B9-3052-49FA-8872-CCEF98BDBBE6}"/>
               </a:ext>
             </a:extLst>
           </ns0:cNvPr>
@@ -27948,7 +27948,7 @@
           <ns0:cNvPr id="25" name="">
             <a:extLst>
               <a:ext uri="{FF2B5EF4-FFF2-40B4-BE49-F238E27FC236}">
-                <ns2:creationId id="{F92FCEA6-87CA-4684-A016-4DBA61CAF006}"/>
+                <ns2:creationId id="{8B581C57-8DAC-43AE-AE2D-32B62E0374B7}"/>
               </a:ext>
             </a:extLst>
           </ns0:cNvPr>
@@ -28019,7 +28019,7 @@
     </ns0:spTree>
     <ns0:extLst>
       <ns0:ext uri="{BB962C8B-B14F-4D97-AF65-F5344CB8AC3E}">
-        <ns5:creationId val="110904620"/>
+        <ns5:creationId val="658472784"/>
       </ns0:ext>
     </ns0:extLst>
   </ns0:cSld>
@@ -28050,7 +28050,7 @@
           <ns0:cNvPr id="27" name="">
             <a:extLst>
               <a:ext uri="{FF2B5EF4-FFF2-40B4-BE49-F238E27FC236}">
-                <ns2:creationId id="{5CB2D901-88D4-4AD4-8515-E1EBD4F5604B}"/>
+                <ns2:creationId id="{16B0D8D7-DB7B-43D4-8AFD-930E4B54DB3F}"/>
               </a:ext>
             </a:extLst>
           </ns0:cNvPr>
@@ -28123,7 +28123,7 @@
           <ns0:cNvPr id="2" name="">
             <a:extLst>
               <a:ext uri="{FF2B5EF4-FFF2-40B4-BE49-F238E27FC236}">
-                <ns2:creationId id="{4C9059DC-640A-488C-A8C9-30AC833B3F0C}"/>
+                <ns2:creationId id="{154BC4A6-3D17-41F5-97D9-E1FC8DA32E36}"/>
               </a:ext>
             </a:extLst>
           </ns0:cNvPr>
@@ -28196,7 +28196,7 @@
           <ns0:cNvPr id="3" name="">
             <a:extLst>
               <a:ext uri="{FF2B5EF4-FFF2-40B4-BE49-F238E27FC236}">
-                <ns2:creationId id="{1E1A4C61-A245-498D-8112-075D97E0E447}"/>
+                <ns2:creationId id="{54AA6236-9AC9-43BD-91FF-C4A2A61485AF}"/>
               </a:ext>
             </a:extLst>
           </ns0:cNvPr>
@@ -28227,7 +28227,7 @@
           <ns0:cNvPr id="4" name="">
             <a:extLst>
               <a:ext uri="{FF2B5EF4-FFF2-40B4-BE49-F238E27FC236}">
-                <ns2:creationId id="{AFE426D0-C664-4529-AC67-934E19F0115A}"/>
+                <ns2:creationId id="{14FA0459-CEAA-4BEF-83B6-6518031D27E4}"/>
               </a:ext>
             </a:extLst>
           </ns0:cNvPr>
@@ -28258,7 +28258,7 @@
           <ns0:cNvPr id="5" name="">
             <a:extLst>
               <a:ext uri="{FF2B5EF4-FFF2-40B4-BE49-F238E27FC236}">
-                <ns2:creationId id="{82100ADB-3325-4B47-B44E-EE83323D575D}"/>
+                <ns2:creationId id="{EA413DF6-7CBB-45D9-AE04-26768D0A62F4}"/>
               </a:ext>
             </a:extLst>
           </ns0:cNvPr>
@@ -28331,7 +28331,7 @@
           <ns0:cNvPr id="6" name="">
             <a:extLst>
               <a:ext uri="{FF2B5EF4-FFF2-40B4-BE49-F238E27FC236}">
-                <ns2:creationId id="{8AE5907D-74A4-4803-B8BA-1B33A6899E1F}"/>
+                <ns2:creationId id="{312BE477-8794-4333-B47F-38B1DD105153}"/>
               </a:ext>
             </a:extLst>
           </ns0:cNvPr>
@@ -28404,7 +28404,7 @@
           <ns0:cNvPr id="7" name="">
             <a:extLst>
               <a:ext uri="{FF2B5EF4-FFF2-40B4-BE49-F238E27FC236}">
-                <ns2:creationId id="{98F007D6-772C-4364-BFE9-C16343F5715B}"/>
+                <ns2:creationId id="{22945C52-177D-4515-8FD2-3A121A5FABF0}"/>
               </a:ext>
             </a:extLst>
           </ns0:cNvPr>
@@ -28477,7 +28477,7 @@
           <ns0:cNvPr id="8" name="">
             <a:extLst>
               <a:ext uri="{FF2B5EF4-FFF2-40B4-BE49-F238E27FC236}">
-                <ns2:creationId id="{4A350CFD-3034-4C03-A1D0-A9140097F82A}"/>
+                <ns2:creationId id="{1E2D2800-FC28-4C84-AB8A-0B2ECA975B04}"/>
               </a:ext>
             </a:extLst>
           </ns0:cNvPr>
@@ -28508,7 +28508,7 @@
           <ns0:cNvPr id="9" name="Chart">
             <a:extLst>
               <a:ext uri="{FF2B5EF4-FFF2-40B4-BE49-F238E27FC236}">
-                <ns2:creationId id="{F8FB601E-9257-4923-9388-97E5DD7658C8}"/>
+                <ns2:creationId id="{E0CA19DE-866B-413A-B1BC-8BD561ECBE73}"/>
               </a:ext>
             </a:extLst>
           </ns0:cNvPr>
@@ -28521,7 +28521,7 @@
         </ns0:xfrm>
         <a:graphic>
           <a:graphicData uri="http://schemas.openxmlformats.org/drawingml/2006/chart">
-            <c:chart ns4:id="R14443294571c4481"/>
+            <c:chart ns4:id="Rbe72fb3964d349d0"/>
           </a:graphicData>
         </a:graphic>
       </ns0:graphicFrame>
@@ -28530,7 +28530,7 @@
           <ns0:cNvPr id="10" name="">
             <a:extLst>
               <a:ext uri="{FF2B5EF4-FFF2-40B4-BE49-F238E27FC236}">
-                <ns2:creationId id="{31606FB6-F41B-44DF-9CA6-CDE58B431B4C}"/>
+                <ns2:creationId id="{BB1D62AC-2E8A-4436-8AE0-227216A9097B}"/>
               </a:ext>
             </a:extLst>
           </ns0:cNvPr>
@@ -28603,7 +28603,7 @@
           <ns0:cNvPr id="11" name="">
             <a:extLst>
               <a:ext uri="{FF2B5EF4-FFF2-40B4-BE49-F238E27FC236}">
-                <ns2:creationId id="{6405D2EA-E437-475C-8D1F-69421B9E3941}"/>
+                <ns2:creationId id="{78B457F5-53C4-488C-9540-2BE7110C79C3}"/>
               </a:ext>
             </a:extLst>
           </ns0:cNvPr>
@@ -28676,7 +28676,7 @@
           <ns0:cNvPr id="12" name="">
             <a:extLst>
               <a:ext uri="{FF2B5EF4-FFF2-40B4-BE49-F238E27FC236}">
-                <ns2:creationId id="{EF3896FB-F995-4615-9885-E503FA2168BC}"/>
+                <ns2:creationId id="{FD3D63D1-B569-43D0-96CF-CCE17D645CEB}"/>
               </a:ext>
             </a:extLst>
           </ns0:cNvPr>
@@ -28707,7 +28707,7 @@
           <ns0:cNvPr id="13" name="Chart">
             <a:extLst>
               <a:ext uri="{FF2B5EF4-FFF2-40B4-BE49-F238E27FC236}">
-                <ns2:creationId id="{6E346C15-6FFD-46E2-AC22-D87C2BF7DCF4}"/>
+                <ns2:creationId id="{0EECA0D9-C58F-448F-BF64-F66A1F598E42}"/>
               </a:ext>
             </a:extLst>
           </ns0:cNvPr>
@@ -28720,7 +28720,7 @@
         </ns0:xfrm>
         <a:graphic>
           <a:graphicData uri="http://schemas.openxmlformats.org/drawingml/2006/chart">
-            <c:chart ns4:id="R5ee6cd80e6f042e6"/>
+            <c:chart ns4:id="Rf9be76dcb5d14afb"/>
           </a:graphicData>
         </a:graphic>
       </ns0:graphicFrame>
@@ -28729,7 +28729,7 @@
           <ns0:cNvPr id="14" name="">
             <a:extLst>
               <a:ext uri="{FF2B5EF4-FFF2-40B4-BE49-F238E27FC236}">
-                <ns2:creationId id="{6307B30F-BEFE-4D65-BBA1-D4F5CD114E9E}"/>
+                <ns2:creationId id="{C9ED6B45-6A22-4DB2-B084-99F8186F4EE3}"/>
               </a:ext>
             </a:extLst>
           </ns0:cNvPr>
@@ -28760,7 +28760,7 @@
           <ns0:cNvPr id="15" name="">
             <a:extLst>
               <a:ext uri="{FF2B5EF4-FFF2-40B4-BE49-F238E27FC236}">
-                <ns2:creationId id="{A4042F64-CD35-42D2-9FEA-9397BEB18687}"/>
+                <ns2:creationId id="{ADA73CF0-3B77-4AF8-BF8D-466D3A7683D5}"/>
               </a:ext>
             </a:extLst>
           </ns0:cNvPr>
@@ -28833,7 +28833,7 @@
           <ns0:cNvPr id="16" name="">
             <a:extLst>
               <a:ext uri="{FF2B5EF4-FFF2-40B4-BE49-F238E27FC236}">
-                <ns2:creationId id="{3E310183-CAA2-4B7B-9326-1472E7251890}"/>
+                <ns2:creationId id="{9E3D7FEA-9680-43D0-8B5D-643E1B00763F}"/>
               </a:ext>
             </a:extLst>
           </ns0:cNvPr>
@@ -28864,7 +28864,7 @@
           <ns0:cNvPr id="17" name="">
             <a:extLst>
               <a:ext uri="{FF2B5EF4-FFF2-40B4-BE49-F238E27FC236}">
-                <ns2:creationId id="{B1AD6366-B5FF-4652-8909-5EB3D2F8257A}"/>
+                <ns2:creationId id="{E87EED36-EDAF-459B-BF14-2252394D66BF}"/>
               </a:ext>
             </a:extLst>
           </ns0:cNvPr>
@@ -28937,7 +28937,7 @@
           <ns0:cNvPr id="18" name="">
             <a:extLst>
               <a:ext uri="{FF2B5EF4-FFF2-40B4-BE49-F238E27FC236}">
-                <ns2:creationId id="{DE526878-484C-4F68-9DE8-C57C3B6C95F0}"/>
+                <ns2:creationId id="{49BB9779-1428-4ED0-8E03-5C9BFC2EB39A}"/>
               </a:ext>
             </a:extLst>
           </ns0:cNvPr>
@@ -28968,7 +28968,7 @@
           <ns0:cNvPr id="19" name="">
             <a:extLst>
               <a:ext uri="{FF2B5EF4-FFF2-40B4-BE49-F238E27FC236}">
-                <ns2:creationId id="{C0F5F92D-634E-483F-BF4F-9437961E1A97}"/>
+                <ns2:creationId id="{229DC3DF-4F95-4D0C-914E-93C69026DB5E}"/>
               </a:ext>
             </a:extLst>
           </ns0:cNvPr>
@@ -29041,7 +29041,7 @@
           <ns0:cNvPr id="20" name="">
             <a:extLst>
               <a:ext uri="{FF2B5EF4-FFF2-40B4-BE49-F238E27FC236}">
-                <ns2:creationId id="{A0EA5A06-6F10-41CD-9E70-4F05334B6B39}"/>
+                <ns2:creationId id="{A4EE2259-8B47-4FC3-A7E3-8E8ADB13AA29}"/>
               </a:ext>
             </a:extLst>
           </ns0:cNvPr>
@@ -29072,7 +29072,7 @@
           <ns0:cNvPr id="21" name="">
             <a:extLst>
               <a:ext uri="{FF2B5EF4-FFF2-40B4-BE49-F238E27FC236}">
-                <ns2:creationId id="{E41206B1-186B-4E0B-B2DD-6DB67A3950D6}"/>
+                <ns2:creationId id="{1DCA437F-4B35-4D68-BE08-FBA443F393F2}"/>
               </a:ext>
             </a:extLst>
           </ns0:cNvPr>
@@ -29145,7 +29145,7 @@
           <ns0:cNvPr id="22" name="">
             <a:extLst>
               <a:ext uri="{FF2B5EF4-FFF2-40B4-BE49-F238E27FC236}">
-                <ns2:creationId id="{649DC4E2-048E-44DC-9622-47DCE14BA0DC}"/>
+                <ns2:creationId id="{27901D2F-CF1E-4F48-B358-D6DD03EC83E7}"/>
               </a:ext>
             </a:extLst>
           </ns0:cNvPr>
@@ -29176,7 +29176,7 @@
           <ns0:cNvPr id="23" name="">
             <a:extLst>
               <a:ext uri="{FF2B5EF4-FFF2-40B4-BE49-F238E27FC236}">
-                <ns2:creationId id="{63038963-9D93-4996-8F72-C21026216139}"/>
+                <ns2:creationId id="{667C7C6F-0DD7-46BF-B369-1576799F470E}"/>
               </a:ext>
             </a:extLst>
           </ns0:cNvPr>
@@ -29249,7 +29249,7 @@
           <ns0:cNvPr id="24" name="">
             <a:extLst>
               <a:ext uri="{FF2B5EF4-FFF2-40B4-BE49-F238E27FC236}">
-                <ns2:creationId id="{B003E904-BD40-42B8-B72F-F3934D13B83E}"/>
+                <ns2:creationId id="{9E730F30-B9B3-4688-AB24-C139D67CE579}"/>
               </a:ext>
             </a:extLst>
           </ns0:cNvPr>
@@ -29322,7 +29322,7 @@
           <ns0:cNvPr id="25" name="">
             <a:extLst>
               <a:ext uri="{FF2B5EF4-FFF2-40B4-BE49-F238E27FC236}">
-                <ns2:creationId id="{1B8DD82A-F7A1-419C-9D07-26D4636F7CB7}"/>
+                <ns2:creationId id="{6AC360CE-0942-4DC6-92A5-378A33FB705B}"/>
               </a:ext>
             </a:extLst>
           </ns0:cNvPr>
@@ -29395,7 +29395,7 @@
           <ns0:cNvPr id="26" name="">
             <a:extLst>
               <a:ext uri="{FF2B5EF4-FFF2-40B4-BE49-F238E27FC236}">
-                <ns2:creationId id="{56D69EBC-280C-4AD0-A69F-AB275C86F7F0}"/>
+                <ns2:creationId id="{2A42547D-A310-470B-8072-26AD669319C5}"/>
               </a:ext>
             </a:extLst>
           </ns0:cNvPr>
@@ -29466,7 +29466,7 @@
     </ns0:spTree>
     <ns0:extLst>
       <ns0:ext uri="{BB962C8B-B14F-4D97-AF65-F5344CB8AC3E}">
-        <ns5:creationId val="887584441"/>
+        <ns5:creationId val="986213283"/>
       </ns0:ext>
     </ns0:extLst>
   </ns0:cSld>
@@ -29497,7 +29497,7 @@
           <ns0:cNvPr id="16" name="">
             <a:extLst>
               <a:ext uri="{FF2B5EF4-FFF2-40B4-BE49-F238E27FC236}">
-                <ns2:creationId id="{DCA6698B-E3D9-486D-95FB-AA37F240DEA0}"/>
+                <ns2:creationId id="{99ED8EBB-9BA0-4272-AD5B-CDAE5430B9E2}"/>
               </a:ext>
             </a:extLst>
           </ns0:cNvPr>
@@ -29570,7 +29570,7 @@
           <ns0:cNvPr id="2" name="">
             <a:extLst>
               <a:ext uri="{FF2B5EF4-FFF2-40B4-BE49-F238E27FC236}">
-                <ns2:creationId id="{00895CB0-9DAE-412E-B7B7-06BEBF072CEA}"/>
+                <ns2:creationId id="{C21DD23A-C83C-4C01-A4B2-7F82148CD3DC}"/>
               </a:ext>
             </a:extLst>
           </ns0:cNvPr>
@@ -29643,7 +29643,7 @@
           <ns0:cNvPr id="3" name="">
             <a:extLst>
               <a:ext uri="{FF2B5EF4-FFF2-40B4-BE49-F238E27FC236}">
-                <ns2:creationId id="{68935E79-9AF9-45D2-828D-715B2D7C7757}"/>
+                <ns2:creationId id="{009848E7-F1CE-4114-81CA-935B11C4542C}"/>
               </a:ext>
             </a:extLst>
           </ns0:cNvPr>
@@ -29674,7 +29674,7 @@
           <ns0:cNvPr id="4" name="">
             <a:extLst>
               <a:ext uri="{FF2B5EF4-FFF2-40B4-BE49-F238E27FC236}">
-                <ns2:creationId id="{91B9F4AD-96EA-4CA8-A283-4B21BD253D01}"/>
+                <ns2:creationId id="{CE1C91E0-6586-4A2A-94A4-A27B080A5B0A}"/>
               </a:ext>
             </a:extLst>
           </ns0:cNvPr>
@@ -29705,7 +29705,7 @@
           <ns0:cNvPr id="5" name="">
             <a:extLst>
               <a:ext uri="{FF2B5EF4-FFF2-40B4-BE49-F238E27FC236}">
-                <ns2:creationId id="{38270CC0-72CD-4690-9051-05113EEDF4F2}"/>
+                <ns2:creationId id="{212BF934-860F-444A-80B5-2F803ED21C14}"/>
               </a:ext>
             </a:extLst>
           </ns0:cNvPr>
@@ -29768,7 +29768,7 @@
                 <a:ea typeface="Arial"/>
                 <a:cs typeface="Arial"/>
               </a:rPr>
-              <a:t>Fontes: CVM/SRE (8/out/26), jan–ago/26; ANBIMA, jan–ago/26. Perímetros e método no XLSX.</a:t>
+              <a:t>Fontes: CVM/SRE (10/out/26), jan–ago/26; ANBIMA, jan–ago/26. Perímetros e método no XLSX.</a:t>
             </a:r>
           </a:p>
         </ns0:txBody>
@@ -29778,7 +29778,7 @@
           <ns0:cNvPr id="6" name="">
             <a:extLst>
               <a:ext uri="{FF2B5EF4-FFF2-40B4-BE49-F238E27FC236}">
-                <ns2:creationId id="{D8780F84-D2ED-4CDE-B767-C4FD049478CF}"/>
+                <ns2:creationId id="{6B86E20D-099E-4331-9F62-6311843BFC79}"/>
               </a:ext>
             </a:extLst>
           </ns0:cNvPr>
@@ -29851,7 +29851,7 @@
           <ns0:cNvPr id="7" name="">
             <a:extLst>
               <a:ext uri="{FF2B5EF4-FFF2-40B4-BE49-F238E27FC236}">
-                <ns2:creationId id="{056A1D40-39CC-4E7F-AB99-ABEBB561965C}"/>
+                <ns2:creationId id="{C72588C1-E702-4BCC-AC3F-211C8AB740C5}"/>
               </a:ext>
             </a:extLst>
           </ns0:cNvPr>
@@ -29924,7 +29924,7 @@
           <ns0:cNvPr id="8" name="">
             <a:extLst>
               <a:ext uri="{FF2B5EF4-FFF2-40B4-BE49-F238E27FC236}">
-                <ns2:creationId id="{40D7F451-15AE-4C4C-8BD9-AD07FC51354A}"/>
+                <ns2:creationId id="{FCCFE667-DDBC-4582-B39B-CC1CAB1ED0EF}"/>
               </a:ext>
             </a:extLst>
           </ns0:cNvPr>
@@ -29955,7 +29955,7 @@
           <ns0:cNvPr id="9" name="Chart">
             <a:extLst>
               <a:ext uri="{FF2B5EF4-FFF2-40B4-BE49-F238E27FC236}">
-                <ns2:creationId id="{560645EE-D908-4AD1-8D5E-ECB83DF9BEA3}"/>
+                <ns2:creationId id="{0AEC75E4-6EBD-4029-B5A7-CC01B0C76E29}"/>
               </a:ext>
             </a:extLst>
           </ns0:cNvPr>
@@ -29968,7 +29968,7 @@
         </ns0:xfrm>
         <a:graphic>
           <a:graphicData uri="http://schemas.openxmlformats.org/drawingml/2006/chart">
-            <c:chart ns4:id="Rc9c0ab00fa4c4a3f"/>
+            <c:chart ns4:id="R0b6e91791a3d47e4"/>
           </a:graphicData>
         </a:graphic>
       </ns0:graphicFrame>
@@ -29977,7 +29977,7 @@
           <ns0:cNvPr id="10" name="">
             <a:extLst>
               <a:ext uri="{FF2B5EF4-FFF2-40B4-BE49-F238E27FC236}">
-                <ns2:creationId id="{2391637F-1E2E-4805-B2BF-C7F96FFEEA06}"/>
+                <ns2:creationId id="{0AE587FC-03A3-45DE-98BB-4DBB14B51564}"/>
               </a:ext>
             </a:extLst>
           </ns0:cNvPr>
@@ -30050,7 +30050,7 @@
           <ns0:cNvPr id="11" name="">
             <a:extLst>
               <a:ext uri="{FF2B5EF4-FFF2-40B4-BE49-F238E27FC236}">
-                <ns2:creationId id="{86A63907-A793-4A20-850E-762FBA2827B9}"/>
+                <ns2:creationId id="{62F09490-6ABE-4944-BAC9-B659B61BA3FD}"/>
               </a:ext>
             </a:extLst>
           </ns0:cNvPr>
@@ -30081,7 +30081,7 @@
           <ns0:cNvPr id="12" name="Chart">
             <a:extLst>
               <a:ext uri="{FF2B5EF4-FFF2-40B4-BE49-F238E27FC236}">
-                <ns2:creationId id="{BFD9BA2C-3C71-4949-AAE1-05C06C3E31E5}"/>
+                <ns2:creationId id="{CEB8A3A2-5E06-47BE-BC7B-CA4A51CD10CA}"/>
               </a:ext>
             </a:extLst>
           </ns0:cNvPr>
@@ -30094,7 +30094,7 @@
         </ns0:xfrm>
         <a:graphic>
           <a:graphicData uri="http://schemas.openxmlformats.org/drawingml/2006/chart">
-            <c:chart ns4:id="R349e717244f7426d"/>
+            <c:chart ns4:id="R7c1e9f1efe8e44e9"/>
           </a:graphicData>
         </a:graphic>
       </ns0:graphicFrame>
@@ -30103,7 +30103,7 @@
           <ns0:cNvPr id="13" name="">
             <a:extLst>
               <a:ext uri="{FF2B5EF4-FFF2-40B4-BE49-F238E27FC236}">
-                <ns2:creationId id="{67B609C7-75B2-4814-95A2-B0616FD13A86}"/>
+                <ns2:creationId id="{729F54D7-9AB3-404F-8109-AD2B17D4B6F6}"/>
               </a:ext>
             </a:extLst>
           </ns0:cNvPr>
@@ -30176,7 +30176,7 @@
           <ns0:cNvPr id="14" name="">
             <a:extLst>
               <a:ext uri="{FF2B5EF4-FFF2-40B4-BE49-F238E27FC236}">
-                <ns2:creationId id="{5307012C-56CB-4401-8FA0-512D22CF43D7}"/>
+                <ns2:creationId id="{2F3FD6A1-60F7-4D76-AD25-74979EF3696C}"/>
               </a:ext>
             </a:extLst>
           </ns0:cNvPr>
@@ -30207,7 +30207,7 @@
           <ns0:cNvPr id="15" name="">
             <a:extLst>
               <a:ext uri="{FF2B5EF4-FFF2-40B4-BE49-F238E27FC236}">
-                <ns2:creationId id="{8E6E5601-38D3-4CD7-AEBF-3E95D37F6601}"/>
+                <ns2:creationId id="{D17B9090-A99D-4E3E-9D5B-948040090B02}"/>
               </a:ext>
             </a:extLst>
           </ns0:cNvPr>
@@ -30815,7 +30815,7 @@
     </ns0:spTree>
     <ns0:extLst>
       <ns0:ext uri="{BB962C8B-B14F-4D97-AF65-F5344CB8AC3E}">
-        <ns5:creationId val="87249372"/>
+        <ns5:creationId val="951836660"/>
       </ns0:ext>
     </ns0:extLst>
   </ns0:cSld>
@@ -30846,7 +30846,7 @@
           <ns0:cNvPr id="21" name="">
             <a:extLst>
               <a:ext uri="{FF2B5EF4-FFF2-40B4-BE49-F238E27FC236}">
-                <ns2:creationId id="{8789BC8A-D0CB-4C95-BE43-E923C550F6E0}"/>
+                <ns2:creationId id="{19C66082-757E-4E0E-A073-E2BBE8948FD8}"/>
               </a:ext>
             </a:extLst>
           </ns0:cNvPr>
@@ -30919,7 +30919,7 @@
           <ns0:cNvPr id="2" name="">
             <a:extLst>
               <a:ext uri="{FF2B5EF4-FFF2-40B4-BE49-F238E27FC236}">
-                <ns2:creationId id="{093214F1-3482-41F3-9065-19E1B002A3C6}"/>
+                <ns2:creationId id="{B88DF006-619E-4022-B4A8-3173BACF782B}"/>
               </a:ext>
             </a:extLst>
           </ns0:cNvPr>
@@ -30992,7 +30992,7 @@
           <ns0:cNvPr id="3" name="">
             <a:extLst>
               <a:ext uri="{FF2B5EF4-FFF2-40B4-BE49-F238E27FC236}">
-                <ns2:creationId id="{D405D6C5-605B-46D3-AD3A-25F65F270F94}"/>
+                <ns2:creationId id="{D9A8C500-CB93-4F01-B65C-741650CB6902}"/>
               </a:ext>
             </a:extLst>
           </ns0:cNvPr>
@@ -31023,7 +31023,7 @@
           <ns0:cNvPr id="4" name="">
             <a:extLst>
               <a:ext uri="{FF2B5EF4-FFF2-40B4-BE49-F238E27FC236}">
-                <ns2:creationId id="{CDC84023-21CB-40FB-B04A-EFE3BA4D7993}"/>
+                <ns2:creationId id="{0A6A9381-7320-4E4E-A185-6AC4968CDCBE}"/>
               </a:ext>
             </a:extLst>
           </ns0:cNvPr>
@@ -31054,7 +31054,7 @@
           <ns0:cNvPr id="5" name="">
             <a:extLst>
               <a:ext uri="{FF2B5EF4-FFF2-40B4-BE49-F238E27FC236}">
-                <ns2:creationId id="{DF6B48EF-3CA1-42F0-9AAB-F2822D224E12}"/>
+                <ns2:creationId id="{0C5749B3-ABC0-4602-BD60-EC66B7FE91C5}"/>
               </a:ext>
             </a:extLst>
           </ns0:cNvPr>
@@ -31127,7 +31127,7 @@
           <ns0:cNvPr id="6" name="">
             <a:extLst>
               <a:ext uri="{FF2B5EF4-FFF2-40B4-BE49-F238E27FC236}">
-                <ns2:creationId id="{4FAE54C5-C199-4C82-82B0-8F1D9FD4B9AA}"/>
+                <ns2:creationId id="{83773D98-959D-465B-B206-3137283DD7EF}"/>
               </a:ext>
             </a:extLst>
           </ns0:cNvPr>
@@ -31200,7 +31200,7 @@
           <ns0:cNvPr id="7" name="">
             <a:extLst>
               <a:ext uri="{FF2B5EF4-FFF2-40B4-BE49-F238E27FC236}">
-                <ns2:creationId id="{FAC3CB8A-A200-4AD1-A153-8FBC51400BBE}"/>
+                <ns2:creationId id="{7D2CA8DA-EFDA-4423-84A3-86ED2823CD92}"/>
               </a:ext>
             </a:extLst>
           </ns0:cNvPr>
@@ -31273,7 +31273,7 @@
           <ns0:cNvPr id="8" name="">
             <a:extLst>
               <a:ext uri="{FF2B5EF4-FFF2-40B4-BE49-F238E27FC236}">
-                <ns2:creationId id="{E90518AC-E37F-4A3D-88B5-3D7369F32B6C}"/>
+                <ns2:creationId id="{53EF3903-76E6-4024-8DB9-0D56882B8898}"/>
               </a:ext>
             </a:extLst>
           </ns0:cNvPr>
@@ -31304,7 +31304,7 @@
           <ns0:cNvPr id="9" name="Chart">
             <a:extLst>
               <a:ext uri="{FF2B5EF4-FFF2-40B4-BE49-F238E27FC236}">
-                <ns2:creationId id="{AD642CB6-57F8-492B-B0E9-FAA3F8A185C0}"/>
+                <ns2:creationId id="{86210207-CACF-408A-8DA6-E8918A5D1C0D}"/>
               </a:ext>
             </a:extLst>
           </ns0:cNvPr>
@@ -31317,7 +31317,7 @@
         </ns0:xfrm>
         <a:graphic>
           <a:graphicData uri="http://schemas.openxmlformats.org/drawingml/2006/chart">
-            <c:chart ns4:id="R883979df7eb74067"/>
+            <c:chart ns4:id="Rc83bb282478b4c3e"/>
           </a:graphicData>
         </a:graphic>
       </ns0:graphicFrame>
@@ -31326,7 +31326,7 @@
           <ns0:cNvPr id="10" name="">
             <a:extLst>
               <a:ext uri="{FF2B5EF4-FFF2-40B4-BE49-F238E27FC236}">
-                <ns2:creationId id="{DFEE7558-F318-4D24-B1A8-07B345D978F1}"/>
+                <ns2:creationId id="{FD511724-845C-4091-A10A-60F71B60620D}"/>
               </a:ext>
             </a:extLst>
           </ns0:cNvPr>
@@ -31399,7 +31399,7 @@
           <ns0:cNvPr id="11" name="">
             <a:extLst>
               <a:ext uri="{FF2B5EF4-FFF2-40B4-BE49-F238E27FC236}">
-                <ns2:creationId id="{064DE93D-2751-447E-80F1-7000243F814B}"/>
+                <ns2:creationId id="{EEF8DC64-6224-4E4D-BDCB-0B604FCBB23B}"/>
               </a:ext>
             </a:extLst>
           </ns0:cNvPr>
@@ -31430,7 +31430,7 @@
           <ns0:cNvPr id="12" name="Chart">
             <a:extLst>
               <a:ext uri="{FF2B5EF4-FFF2-40B4-BE49-F238E27FC236}">
-                <ns2:creationId id="{9EB336DD-6739-4D29-AAAB-4F894DF93B3F}"/>
+                <ns2:creationId id="{9E21373E-3F43-4101-B459-DC818B67D596}"/>
               </a:ext>
             </a:extLst>
           </ns0:cNvPr>
@@ -31443,7 +31443,7 @@
         </ns0:xfrm>
         <a:graphic>
           <a:graphicData uri="http://schemas.openxmlformats.org/drawingml/2006/chart">
-            <c:chart ns4:id="R520a01d8221e424f"/>
+            <c:chart ns4:id="Re49074663fdf478a"/>
           </a:graphicData>
         </a:graphic>
       </ns0:graphicFrame>
@@ -31452,7 +31452,7 @@
           <ns0:cNvPr id="13" name="">
             <a:extLst>
               <a:ext uri="{FF2B5EF4-FFF2-40B4-BE49-F238E27FC236}">
-                <ns2:creationId id="{21B1A727-DC60-494D-9C35-852451DF95A4}"/>
+                <ns2:creationId id="{D0BCE0EC-EFF2-4DA1-B2DC-8DBCD3383ADE}"/>
               </a:ext>
             </a:extLst>
           </ns0:cNvPr>
@@ -31483,7 +31483,7 @@
           <ns0:cNvPr id="14" name="">
             <a:extLst>
               <a:ext uri="{FF2B5EF4-FFF2-40B4-BE49-F238E27FC236}">
-                <ns2:creationId id="{C04D6A10-5106-486D-93B7-9ECDE94C938B}"/>
+                <ns2:creationId id="{778A4415-9599-488B-8F18-A8390441E592}"/>
               </a:ext>
             </a:extLst>
           </ns0:cNvPr>
@@ -31556,7 +31556,7 @@
           <ns0:cNvPr id="15" name="">
             <a:extLst>
               <a:ext uri="{FF2B5EF4-FFF2-40B4-BE49-F238E27FC236}">
-                <ns2:creationId id="{A85D6BBC-68A3-4C33-A8DA-DD82B5DA12C7}"/>
+                <ns2:creationId id="{B319E8A0-4FC0-4C47-9525-352F83D07780}"/>
               </a:ext>
             </a:extLst>
           </ns0:cNvPr>
@@ -31587,7 +31587,7 @@
           <ns0:cNvPr id="16" name="">
             <a:extLst>
               <a:ext uri="{FF2B5EF4-FFF2-40B4-BE49-F238E27FC236}">
-                <ns2:creationId id="{8C1EB5DC-DED3-46B4-93FB-F47850E8E72E}"/>
+                <ns2:creationId id="{D04AF188-7D1D-41AB-A38A-2314AF98F0A1}"/>
               </a:ext>
             </a:extLst>
           </ns0:cNvPr>
@@ -31660,7 +31660,7 @@
           <ns0:cNvPr id="17" name="">
             <a:extLst>
               <a:ext uri="{FF2B5EF4-FFF2-40B4-BE49-F238E27FC236}">
-                <ns2:creationId id="{5872AD95-8358-4B6C-AD69-537C0C6D4667}"/>
+                <ns2:creationId id="{F9C3463B-0296-4C4F-ADAC-D48643851EFC}"/>
               </a:ext>
             </a:extLst>
           </ns0:cNvPr>
@@ -31691,7 +31691,7 @@
           <ns0:cNvPr id="18" name="">
             <a:extLst>
               <a:ext uri="{FF2B5EF4-FFF2-40B4-BE49-F238E27FC236}">
-                <ns2:creationId id="{46EBBB59-730E-4A58-8E4C-A31535959398}"/>
+                <ns2:creationId id="{AF0CDEE2-DE84-4F06-8D25-38EBC561E97C}"/>
               </a:ext>
             </a:extLst>
           </ns0:cNvPr>
@@ -31764,7 +31764,7 @@
           <ns0:cNvPr id="19" name="">
             <a:extLst>
               <a:ext uri="{FF2B5EF4-FFF2-40B4-BE49-F238E27FC236}">
-                <ns2:creationId id="{C29EFCB7-3708-428E-9C89-1B284D23AF8B}"/>
+                <ns2:creationId id="{F0B320E7-920F-4821-98EF-0454FF7E6C2E}"/>
               </a:ext>
             </a:extLst>
           </ns0:cNvPr>
@@ -31795,7 +31795,7 @@
           <ns0:cNvPr id="20" name="">
             <a:extLst>
               <a:ext uri="{FF2B5EF4-FFF2-40B4-BE49-F238E27FC236}">
-                <ns2:creationId id="{8594A1F6-ED08-40EA-A76F-444EE619026A}"/>
+                <ns2:creationId id="{9825AB4B-0A0D-4692-8630-E7ED29ED4643}"/>
               </a:ext>
             </a:extLst>
           </ns0:cNvPr>
@@ -31866,7 +31866,7 @@
     </ns0:spTree>
     <ns0:extLst>
       <ns0:ext uri="{BB962C8B-B14F-4D97-AF65-F5344CB8AC3E}">
-        <ns5:creationId val="1745931698"/>
+        <ns5:creationId val="445547825"/>
       </ns0:ext>
     </ns0:extLst>
   </ns0:cSld>
@@ -31897,7 +31897,7 @@
           <ns0:cNvPr id="28" name="">
             <a:extLst>
               <a:ext uri="{FF2B5EF4-FFF2-40B4-BE49-F238E27FC236}">
-                <ns2:creationId id="{4D1FC875-3719-4D4C-853F-C413D9F59AB7}"/>
+                <ns2:creationId id="{7159E4DE-95E5-4F82-9C32-C53F1132B7F3}"/>
               </a:ext>
             </a:extLst>
           </ns0:cNvPr>
@@ -31970,7 +31970,7 @@
           <ns0:cNvPr id="2" name="">
             <a:extLst>
               <a:ext uri="{FF2B5EF4-FFF2-40B4-BE49-F238E27FC236}">
-                <ns2:creationId id="{E03EA6C9-2F69-4DFF-BD33-9BDC4B20C585}"/>
+                <ns2:creationId id="{4ACCB5E9-73B2-4052-B3B9-6F9C42DDC8FF}"/>
               </a:ext>
             </a:extLst>
           </ns0:cNvPr>
@@ -32043,7 +32043,7 @@
           <ns0:cNvPr id="3" name="">
             <a:extLst>
               <a:ext uri="{FF2B5EF4-FFF2-40B4-BE49-F238E27FC236}">
-                <ns2:creationId id="{3E245BC1-68A2-418D-97F1-BBC03C40C81A}"/>
+                <ns2:creationId id="{9571D124-7D8D-4D5A-ADB8-BC0D66ED568B}"/>
               </a:ext>
             </a:extLst>
           </ns0:cNvPr>
@@ -32074,7 +32074,7 @@
           <ns0:cNvPr id="4" name="">
             <a:extLst>
               <a:ext uri="{FF2B5EF4-FFF2-40B4-BE49-F238E27FC236}">
-                <ns2:creationId id="{19FDC3A9-9F31-4BE7-82D0-9860EDA71997}"/>
+                <ns2:creationId id="{BA09D3DA-B4E2-4D39-807C-32A1C5AD4190}"/>
               </a:ext>
             </a:extLst>
           </ns0:cNvPr>
@@ -32105,7 +32105,7 @@
           <ns0:cNvPr id="5" name="">
             <a:extLst>
               <a:ext uri="{FF2B5EF4-FFF2-40B4-BE49-F238E27FC236}">
-                <ns2:creationId id="{EB7284A7-244E-40BB-8031-7E53FB915BD6}"/>
+                <ns2:creationId id="{808E70D6-0747-4FAF-935C-90BBD7D2207C}"/>
               </a:ext>
             </a:extLst>
           </ns0:cNvPr>
@@ -32178,7 +32178,7 @@
           <ns0:cNvPr id="6" name="">
             <a:extLst>
               <a:ext uri="{FF2B5EF4-FFF2-40B4-BE49-F238E27FC236}">
-                <ns2:creationId id="{0D8CD2DB-997E-42D9-80D7-FA15E9C28056}"/>
+                <ns2:creationId id="{B7253D29-3A59-4A33-91E1-540E8821AC57}"/>
               </a:ext>
             </a:extLst>
           </ns0:cNvPr>
@@ -32251,7 +32251,7 @@
           <ns0:cNvPr id="7" name="">
             <a:extLst>
               <a:ext uri="{FF2B5EF4-FFF2-40B4-BE49-F238E27FC236}">
-                <ns2:creationId id="{DAE1871C-4F84-4DFE-9D5A-AFDB095529C2}"/>
+                <ns2:creationId id="{2C609979-47FB-4046-B1C8-AE98012142B2}"/>
               </a:ext>
             </a:extLst>
           </ns0:cNvPr>
@@ -32324,7 +32324,7 @@
           <ns0:cNvPr id="8" name="">
             <a:extLst>
               <a:ext uri="{FF2B5EF4-FFF2-40B4-BE49-F238E27FC236}">
-                <ns2:creationId id="{5627BBBC-2196-4D06-8535-E1C3BEDB066E}"/>
+                <ns2:creationId id="{53E60C1C-44CC-42E1-B6D1-9E2823B250AD}"/>
               </a:ext>
             </a:extLst>
           </ns0:cNvPr>
@@ -32355,7 +32355,7 @@
           <ns0:cNvPr id="9" name="Chart">
             <a:extLst>
               <a:ext uri="{FF2B5EF4-FFF2-40B4-BE49-F238E27FC236}">
-                <ns2:creationId id="{C231139F-7391-4BD4-A6A6-008DC7D622A1}"/>
+                <ns2:creationId id="{F21F8FB1-CB35-450B-8BBA-69FD08DCC526}"/>
               </a:ext>
             </a:extLst>
           </ns0:cNvPr>
@@ -32368,7 +32368,7 @@
         </ns0:xfrm>
         <a:graphic>
           <a:graphicData uri="http://schemas.openxmlformats.org/drawingml/2006/chart">
-            <c:chart ns4:id="R8e8e049c3f544572"/>
+            <c:chart ns4:id="Rb3ba798ef4434513"/>
           </a:graphicData>
         </a:graphic>
       </ns0:graphicFrame>
@@ -32377,7 +32377,7 @@
           <ns0:cNvPr id="10" name="">
             <a:extLst>
               <a:ext uri="{FF2B5EF4-FFF2-40B4-BE49-F238E27FC236}">
-                <ns2:creationId id="{88A00F43-7525-4767-BA01-81793DB01ED7}"/>
+                <ns2:creationId id="{EC93F50E-CAB0-4ED5-9C7E-156EC8C37832}"/>
               </a:ext>
             </a:extLst>
           </ns0:cNvPr>
@@ -32450,7 +32450,7 @@
           <ns0:cNvPr id="11" name="">
             <a:extLst>
               <a:ext uri="{FF2B5EF4-FFF2-40B4-BE49-F238E27FC236}">
-                <ns2:creationId id="{2FCB65F3-6F81-4F2E-8954-28A6359F7105}"/>
+                <ns2:creationId id="{A93BCFF1-A7CD-4E6F-8D9B-703F6CC50D71}"/>
               </a:ext>
             </a:extLst>
           </ns0:cNvPr>
@@ -32481,7 +32481,7 @@
           <ns0:cNvPr id="12" name="Chart">
             <a:extLst>
               <a:ext uri="{FF2B5EF4-FFF2-40B4-BE49-F238E27FC236}">
-                <ns2:creationId id="{176D3613-9297-4FA4-AF8D-84AF468C02C6}"/>
+                <ns2:creationId id="{B5D0D2EF-6ACD-45D7-8BD8-ADA0B168D4AB}"/>
               </a:ext>
             </a:extLst>
           </ns0:cNvPr>
@@ -32494,7 +32494,7 @@
         </ns0:xfrm>
         <a:graphic>
           <a:graphicData uri="http://schemas.openxmlformats.org/drawingml/2006/chart">
-            <c:chart ns4:id="R66e304399e8c4721"/>
+            <c:chart ns4:id="R40494fea2c244141"/>
           </a:graphicData>
         </a:graphic>
       </ns0:graphicFrame>
@@ -32503,7 +32503,7 @@
           <ns0:cNvPr id="13" name="">
             <a:extLst>
               <a:ext uri="{FF2B5EF4-FFF2-40B4-BE49-F238E27FC236}">
-                <ns2:creationId id="{C39082B7-3671-4249-BFC2-9994E6AA6F08}"/>
+                <ns2:creationId id="{E28B5D04-CC3C-4AB8-A1F9-DF42413D7741}"/>
               </a:ext>
             </a:extLst>
           </ns0:cNvPr>
@@ -32534,7 +32534,7 @@
           <ns0:cNvPr id="14" name="">
             <a:extLst>
               <a:ext uri="{FF2B5EF4-FFF2-40B4-BE49-F238E27FC236}">
-                <ns2:creationId id="{DFD31DF3-A591-4605-9A6B-74007C4A6B69}"/>
+                <ns2:creationId id="{56D9D213-8DB1-4A10-8844-00B20BFCA710}"/>
               </a:ext>
             </a:extLst>
           </ns0:cNvPr>
@@ -32607,7 +32607,7 @@
           <ns0:cNvPr id="15" name="">
             <a:extLst>
               <a:ext uri="{FF2B5EF4-FFF2-40B4-BE49-F238E27FC236}">
-                <ns2:creationId id="{8728D336-B33B-4C07-A697-23408A40370B}"/>
+                <ns2:creationId id="{79E5529D-442A-4BEE-BEFB-E56631BF9098}"/>
               </a:ext>
             </a:extLst>
           </ns0:cNvPr>
@@ -32638,7 +32638,7 @@
           <ns0:cNvPr id="16" name="">
             <a:extLst>
               <a:ext uri="{FF2B5EF4-FFF2-40B4-BE49-F238E27FC236}">
-                <ns2:creationId id="{4EDBA5DF-D3AD-4148-9A13-1DD46B5516A2}"/>
+                <ns2:creationId id="{BC600600-2B87-4348-A398-F04E745C8907}"/>
               </a:ext>
             </a:extLst>
           </ns0:cNvPr>
@@ -32711,7 +32711,7 @@
           <ns0:cNvPr id="17" name="">
             <a:extLst>
               <a:ext uri="{FF2B5EF4-FFF2-40B4-BE49-F238E27FC236}">
-                <ns2:creationId id="{09057394-D3AF-4A24-9874-501A7C01F9BC}"/>
+                <ns2:creationId id="{3ACB2F79-6ABC-4478-81D9-CB7E71885FE7}"/>
               </a:ext>
             </a:extLst>
           </ns0:cNvPr>
@@ -32742,7 +32742,7 @@
           <ns0:cNvPr id="18" name="">
             <a:extLst>
               <a:ext uri="{FF2B5EF4-FFF2-40B4-BE49-F238E27FC236}">
-                <ns2:creationId id="{0E95C2A2-3B14-4489-BC7B-F956061F2529}"/>
+                <ns2:creationId id="{43802F47-DF2D-4D8B-BAB1-C9E9936DFD9D}"/>
               </a:ext>
             </a:extLst>
           </ns0:cNvPr>
@@ -32815,7 +32815,7 @@
           <ns0:cNvPr id="19" name="">
             <a:extLst>
               <a:ext uri="{FF2B5EF4-FFF2-40B4-BE49-F238E27FC236}">
-                <ns2:creationId id="{C4163588-720C-41B7-9045-A0F5C75FDAF2}"/>
+                <ns2:creationId id="{40AD2383-01FB-40BC-9649-229DEFBB2E72}"/>
               </a:ext>
             </a:extLst>
           </ns0:cNvPr>
@@ -32846,7 +32846,7 @@
           <ns0:cNvPr id="20" name="">
             <a:extLst>
               <a:ext uri="{FF2B5EF4-FFF2-40B4-BE49-F238E27FC236}">
-                <ns2:creationId id="{BA99EC95-05D0-4067-B16F-B9EC5D22A4C8}"/>
+                <ns2:creationId id="{7E0A4F0D-7593-46B1-8462-2E38E0ED3256}"/>
               </a:ext>
             </a:extLst>
           </ns0:cNvPr>
@@ -32919,7 +32919,7 @@
           <ns0:cNvPr id="21" name="">
             <a:extLst>
               <a:ext uri="{FF2B5EF4-FFF2-40B4-BE49-F238E27FC236}">
-                <ns2:creationId id="{2195AA48-D000-408B-9A83-78FBAD614627}"/>
+                <ns2:creationId id="{3FCE68CF-5222-49B7-99A2-6C05F6D88156}"/>
               </a:ext>
             </a:extLst>
           </ns0:cNvPr>
@@ -32950,7 +32950,7 @@
           <ns0:cNvPr id="22" name="">
             <a:extLst>
               <a:ext uri="{FF2B5EF4-FFF2-40B4-BE49-F238E27FC236}">
-                <ns2:creationId id="{8AEF45AB-056B-4B3B-8C9E-BCA70DD76E5B}"/>
+                <ns2:creationId id="{81D21297-F661-4EE9-8BD6-D9CCC60E7559}"/>
               </a:ext>
             </a:extLst>
           </ns0:cNvPr>
@@ -33023,7 +33023,7 @@
           <ns0:cNvPr id="23" name="">
             <a:extLst>
               <a:ext uri="{FF2B5EF4-FFF2-40B4-BE49-F238E27FC236}">
-                <ns2:creationId id="{ACE87D71-D3A3-4030-9D3C-414299C1F135}"/>
+                <ns2:creationId id="{1F30F462-12EE-4EE5-BD86-AF4BFD29ED7F}"/>
               </a:ext>
             </a:extLst>
           </ns0:cNvPr>
@@ -33054,7 +33054,7 @@
           <ns0:cNvPr id="24" name="">
             <a:extLst>
               <a:ext uri="{FF2B5EF4-FFF2-40B4-BE49-F238E27FC236}">
-                <ns2:creationId id="{A4A8B5A3-C56E-4D22-BC6E-F969AE2C3458}"/>
+                <ns2:creationId id="{1723094A-64FA-450D-8B2B-38E6E9BE6273}"/>
               </a:ext>
             </a:extLst>
           </ns0:cNvPr>
@@ -33127,7 +33127,7 @@
           <ns0:cNvPr id="25" name="">
             <a:extLst>
               <a:ext uri="{FF2B5EF4-FFF2-40B4-BE49-F238E27FC236}">
-                <ns2:creationId id="{5665639D-F56E-41E0-814D-6DEA8E3251C1}"/>
+                <ns2:creationId id="{1F094109-B9D7-4FCB-87F3-0CDA740FF01C}"/>
               </a:ext>
             </a:extLst>
           </ns0:cNvPr>
@@ -33158,7 +33158,7 @@
           <ns0:cNvPr id="26" name="">
             <a:extLst>
               <a:ext uri="{FF2B5EF4-FFF2-40B4-BE49-F238E27FC236}">
-                <ns2:creationId id="{DAAFB444-ECE1-4D87-802D-83AB4158A68F}"/>
+                <ns2:creationId id="{CFD9CA3F-22A9-45C3-80E4-8C11822CEF74}"/>
               </a:ext>
             </a:extLst>
           </ns0:cNvPr>
@@ -33231,7 +33231,7 @@
           <ns0:cNvPr id="27" name="">
             <a:extLst>
               <a:ext uri="{FF2B5EF4-FFF2-40B4-BE49-F238E27FC236}">
-                <ns2:creationId id="{BC56FF29-34AE-4D60-AA0E-54933ECA46DF}"/>
+                <ns2:creationId id="{A1899E6C-853F-4509-A035-8EF66F230797}"/>
               </a:ext>
             </a:extLst>
           </ns0:cNvPr>
@@ -33302,7 +33302,7 @@
     </ns0:spTree>
     <ns0:extLst>
       <ns0:ext uri="{BB962C8B-B14F-4D97-AF65-F5344CB8AC3E}">
-        <ns5:creationId val="1876517381"/>
+        <ns5:creationId val="1573984511"/>
       </ns0:ext>
     </ns0:extLst>
   </ns0:cSld>
@@ -33333,7 +33333,7 @@
           <ns0:cNvPr id="18" name="">
             <a:extLst>
               <a:ext uri="{FF2B5EF4-FFF2-40B4-BE49-F238E27FC236}">
-                <ns2:creationId id="{4FC2B6AA-4F20-4140-BB9E-778405C750FE}"/>
+                <ns2:creationId id="{AB0AA5AB-B1E9-4952-9052-A8C8D421EC34}"/>
               </a:ext>
             </a:extLst>
           </ns0:cNvPr>
@@ -33406,7 +33406,7 @@
           <ns0:cNvPr id="2" name="">
             <a:extLst>
               <a:ext uri="{FF2B5EF4-FFF2-40B4-BE49-F238E27FC236}">
-                <ns2:creationId id="{F0417F2F-8227-4BA7-BA72-411204543119}"/>
+                <ns2:creationId id="{38B44457-1CD8-41B1-933E-A784E7560AB0}"/>
               </a:ext>
             </a:extLst>
           </ns0:cNvPr>
@@ -33479,7 +33479,7 @@
           <ns0:cNvPr id="3" name="">
             <a:extLst>
               <a:ext uri="{FF2B5EF4-FFF2-40B4-BE49-F238E27FC236}">
-                <ns2:creationId id="{4477968F-7EA9-4901-B5A3-6212E0F36706}"/>
+                <ns2:creationId id="{B3A393EF-B6E4-4C3F-897B-EF57EAAE1754}"/>
               </a:ext>
             </a:extLst>
           </ns0:cNvPr>
@@ -33510,7 +33510,7 @@
           <ns0:cNvPr id="4" name="">
             <a:extLst>
               <a:ext uri="{FF2B5EF4-FFF2-40B4-BE49-F238E27FC236}">
-                <ns2:creationId id="{2571C72A-F29A-490C-9A76-9255C42F404A}"/>
+                <ns2:creationId id="{30A7EA1F-8B68-4CC8-B737-4C38F24BCF5F}"/>
               </a:ext>
             </a:extLst>
           </ns0:cNvPr>
@@ -33541,7 +33541,7 @@
           <ns0:cNvPr id="5" name="">
             <a:extLst>
               <a:ext uri="{FF2B5EF4-FFF2-40B4-BE49-F238E27FC236}">
-                <ns2:creationId id="{1A9A597E-D563-4CC5-A068-E6CE618D9E94}"/>
+                <ns2:creationId id="{FC4E8AE1-AA64-4582-915E-A3141BCDB5DB}"/>
               </a:ext>
             </a:extLst>
           </ns0:cNvPr>
@@ -33614,7 +33614,7 @@
           <ns0:cNvPr id="6" name="">
             <a:extLst>
               <a:ext uri="{FF2B5EF4-FFF2-40B4-BE49-F238E27FC236}">
-                <ns2:creationId id="{D85E746F-E78D-4979-BBA0-7287356852F2}"/>
+                <ns2:creationId id="{980844FA-62EB-49DD-A61C-31F3F18321E2}"/>
               </a:ext>
             </a:extLst>
           </ns0:cNvPr>
@@ -33687,7 +33687,7 @@
           <ns0:cNvPr id="7" name="">
             <a:extLst>
               <a:ext uri="{FF2B5EF4-FFF2-40B4-BE49-F238E27FC236}">
-                <ns2:creationId id="{4C912AB6-8487-4D50-8551-224E7C90460B}"/>
+                <ns2:creationId id="{D682D8FE-5154-41DC-A35D-9D09C006719A}"/>
               </a:ext>
             </a:extLst>
           </ns0:cNvPr>
@@ -33760,7 +33760,7 @@
           <ns0:cNvPr id="8" name="">
             <a:extLst>
               <a:ext uri="{FF2B5EF4-FFF2-40B4-BE49-F238E27FC236}">
-                <ns2:creationId id="{412EF0D3-4941-4D9F-B526-99421F948957}"/>
+                <ns2:creationId id="{6BBCFF97-75E5-4ACB-8DB3-FFCBA7792005}"/>
               </a:ext>
             </a:extLst>
           </ns0:cNvPr>
@@ -33791,7 +33791,7 @@
           <ns0:cNvPr id="9" name="Chart">
             <a:extLst>
               <a:ext uri="{FF2B5EF4-FFF2-40B4-BE49-F238E27FC236}">
-                <ns2:creationId id="{EF7F45D3-0705-4D41-9AD0-9B839B2E5549}"/>
+                <ns2:creationId id="{575FEFCB-B5AC-43A0-A6DA-20DEFA3636A3}"/>
               </a:ext>
             </a:extLst>
           </ns0:cNvPr>
@@ -33804,7 +33804,7 @@
         </ns0:xfrm>
         <a:graphic>
           <a:graphicData uri="http://schemas.openxmlformats.org/drawingml/2006/chart">
-            <c:chart ns4:id="Red6902bfb444454b"/>
+            <c:chart ns4:id="R53343c745c91416f"/>
           </a:graphicData>
         </a:graphic>
       </ns0:graphicFrame>
@@ -33813,7 +33813,7 @@
           <ns0:cNvPr id="10" name="">
             <a:extLst>
               <a:ext uri="{FF2B5EF4-FFF2-40B4-BE49-F238E27FC236}">
-                <ns2:creationId id="{018A36C7-3697-4B46-875F-6873C8687433}"/>
+                <ns2:creationId id="{3209B62B-17C4-46B4-A239-F30514850F61}"/>
               </a:ext>
             </a:extLst>
           </ns0:cNvPr>
@@ -33886,7 +33886,7 @@
           <ns0:cNvPr id="11" name="">
             <a:extLst>
               <a:ext uri="{FF2B5EF4-FFF2-40B4-BE49-F238E27FC236}">
-                <ns2:creationId id="{D777C424-22A0-4374-A8EA-B05D225D9949}"/>
+                <ns2:creationId id="{EFFDECA0-93D1-4290-A9F5-4238FA45315B}"/>
               </a:ext>
             </a:extLst>
           </ns0:cNvPr>
@@ -33917,7 +33917,7 @@
           <ns0:cNvPr id="12" name="Chart">
             <a:extLst>
               <a:ext uri="{FF2B5EF4-FFF2-40B4-BE49-F238E27FC236}">
-                <ns2:creationId id="{B52D4ECB-40DB-412A-B6B4-67A617BCF040}"/>
+                <ns2:creationId id="{E2CE5126-8656-4E1C-B695-922311C92481}"/>
               </a:ext>
             </a:extLst>
           </ns0:cNvPr>
@@ -33930,7 +33930,7 @@
         </ns0:xfrm>
         <a:graphic>
           <a:graphicData uri="http://schemas.openxmlformats.org/drawingml/2006/chart">
-            <c:chart ns4:id="Rdd543e66e2f7471f"/>
+            <c:chart ns4:id="R240942d0f0d24ee6"/>
           </a:graphicData>
         </a:graphic>
       </ns0:graphicFrame>
@@ -33939,7 +33939,7 @@
           <ns0:cNvPr id="13" name="">
             <a:extLst>
               <a:ext uri="{FF2B5EF4-FFF2-40B4-BE49-F238E27FC236}">
-                <ns2:creationId id="{034E2D96-FB7D-40E7-8BB6-9F6D47EDE749}"/>
+                <ns2:creationId id="{5846B82C-FF72-4564-82B9-5B592188D62C}"/>
               </a:ext>
             </a:extLst>
           </ns0:cNvPr>
@@ -33970,7 +33970,7 @@
           <ns0:cNvPr id="14" name="">
             <a:extLst>
               <a:ext uri="{FF2B5EF4-FFF2-40B4-BE49-F238E27FC236}">
-                <ns2:creationId id="{9B2C05E3-0686-4A63-BE01-3D5504B12246}"/>
+                <ns2:creationId id="{4ACC07F0-6242-427B-B74E-9B474DF1F5E6}"/>
               </a:ext>
             </a:extLst>
           </ns0:cNvPr>
@@ -34043,7 +34043,7 @@
           <ns0:cNvPr id="15" name="">
             <a:extLst>
               <a:ext uri="{FF2B5EF4-FFF2-40B4-BE49-F238E27FC236}">
-                <ns2:creationId id="{38C98B73-214E-47B0-B2AA-CE6956D053F6}"/>
+                <ns2:creationId id="{F373C33E-7D36-486E-AC73-13103F54CCE5}"/>
               </a:ext>
             </a:extLst>
           </ns0:cNvPr>
@@ -34074,7 +34074,7 @@
           <ns0:cNvPr id="16" name="">
             <a:extLst>
               <a:ext uri="{FF2B5EF4-FFF2-40B4-BE49-F238E27FC236}">
-                <ns2:creationId id="{4F47D324-787B-4363-9D52-5B37E1E676C2}"/>
+                <ns2:creationId id="{B63395B0-592F-4548-B985-EE0E60169438}"/>
               </a:ext>
             </a:extLst>
           </ns0:cNvPr>
@@ -34147,7 +34147,7 @@
           <ns0:cNvPr id="17" name="">
             <a:extLst>
               <a:ext uri="{FF2B5EF4-FFF2-40B4-BE49-F238E27FC236}">
-                <ns2:creationId id="{16CD6869-B44A-4A93-A976-C2648C14BD00}"/>
+                <ns2:creationId id="{5D5DB103-0C18-437D-9423-B6FE1E0624DF}"/>
               </a:ext>
             </a:extLst>
           </ns0:cNvPr>
@@ -34218,7 +34218,7 @@
     </ns0:spTree>
     <ns0:extLst>
       <ns0:ext uri="{BB962C8B-B14F-4D97-AF65-F5344CB8AC3E}">
-        <ns5:creationId val="1193199745"/>
+        <ns5:creationId val="416965566"/>
       </ns0:ext>
     </ns0:extLst>
   </ns0:cSld>
@@ -34249,7 +34249,7 @@
           <ns0:cNvPr id="19" name="">
             <a:extLst>
               <a:ext uri="{FF2B5EF4-FFF2-40B4-BE49-F238E27FC236}">
-                <ns2:creationId id="{8DF2D685-50E9-4DDE-BD66-BF4B983757DC}"/>
+                <ns2:creationId id="{6CE2D4F0-F24D-494D-9319-22C5A17FDA99}"/>
               </a:ext>
             </a:extLst>
           </ns0:cNvPr>
@@ -34322,7 +34322,7 @@
           <ns0:cNvPr id="2" name="">
             <a:extLst>
               <a:ext uri="{FF2B5EF4-FFF2-40B4-BE49-F238E27FC236}">
-                <ns2:creationId id="{93824A1F-2CA9-46C0-968F-8C5AA689B9EE}"/>
+                <ns2:creationId id="{DD598683-825D-4371-AA6D-F3BFB06D21CF}"/>
               </a:ext>
             </a:extLst>
           </ns0:cNvPr>
@@ -34395,7 +34395,7 @@
           <ns0:cNvPr id="3" name="">
             <a:extLst>
               <a:ext uri="{FF2B5EF4-FFF2-40B4-BE49-F238E27FC236}">
-                <ns2:creationId id="{832B94F7-5B73-4B14-B058-B56EF9AB34DF}"/>
+                <ns2:creationId id="{7383ABBD-A7F9-42D2-A715-57F182A16488}"/>
               </a:ext>
             </a:extLst>
           </ns0:cNvPr>
@@ -34426,7 +34426,7 @@
           <ns0:cNvPr id="4" name="">
             <a:extLst>
               <a:ext uri="{FF2B5EF4-FFF2-40B4-BE49-F238E27FC236}">
-                <ns2:creationId id="{AD9E5116-EADD-44E2-9F9E-7506F5ED2143}"/>
+                <ns2:creationId id="{E6EF692B-F7EA-42E4-8FC9-C977EE87F0EC}"/>
               </a:ext>
             </a:extLst>
           </ns0:cNvPr>
@@ -34457,7 +34457,7 @@
           <ns0:cNvPr id="5" name="">
             <a:extLst>
               <a:ext uri="{FF2B5EF4-FFF2-40B4-BE49-F238E27FC236}">
-                <ns2:creationId id="{64F1EE96-C8BF-4FBD-9E1D-C63ED065F55B}"/>
+                <ns2:creationId id="{4724DB25-431B-4956-B07E-10EB0745827B}"/>
               </a:ext>
             </a:extLst>
           </ns0:cNvPr>
@@ -34530,7 +34530,7 @@
           <ns0:cNvPr id="6" name="">
             <a:extLst>
               <a:ext uri="{FF2B5EF4-FFF2-40B4-BE49-F238E27FC236}">
-                <ns2:creationId id="{416D4806-553A-49C4-A486-1BCD58D164D7}"/>
+                <ns2:creationId id="{392E2780-8911-4F7C-9F45-E06BEA3A13D8}"/>
               </a:ext>
             </a:extLst>
           </ns0:cNvPr>
@@ -34603,7 +34603,7 @@
           <ns0:cNvPr id="7" name="">
             <a:extLst>
               <a:ext uri="{FF2B5EF4-FFF2-40B4-BE49-F238E27FC236}">
-                <ns2:creationId id="{48981B29-B2CE-460F-BADD-536B75D0A425}"/>
+                <ns2:creationId id="{EC0B0EFF-0301-4654-B1BD-081EDDE3EBEE}"/>
               </a:ext>
             </a:extLst>
           </ns0:cNvPr>
@@ -34676,7 +34676,7 @@
           <ns0:cNvPr id="8" name="">
             <a:extLst>
               <a:ext uri="{FF2B5EF4-FFF2-40B4-BE49-F238E27FC236}">
-                <ns2:creationId id="{195B133A-90FF-43DD-B559-CD6D8C8DE29E}"/>
+                <ns2:creationId id="{809DEB11-19A7-424C-9068-F1F8BB32A318}"/>
               </a:ext>
             </a:extLst>
           </ns0:cNvPr>
@@ -34707,7 +34707,7 @@
           <ns0:cNvPr id="9" name="Chart">
             <a:extLst>
               <a:ext uri="{FF2B5EF4-FFF2-40B4-BE49-F238E27FC236}">
-                <ns2:creationId id="{B2E3F8E5-5D32-4A8D-825C-386B178F6FF5}"/>
+                <ns2:creationId id="{5CB8A07F-2079-413F-94EF-FB7964ED9628}"/>
               </a:ext>
             </a:extLst>
           </ns0:cNvPr>
@@ -34720,7 +34720,7 @@
         </ns0:xfrm>
         <a:graphic>
           <a:graphicData uri="http://schemas.openxmlformats.org/drawingml/2006/chart">
-            <c:chart ns4:id="Rff9ceba655b64b99"/>
+            <c:chart ns4:id="Rc7409d8a400f44e6"/>
           </a:graphicData>
         </a:graphic>
       </ns0:graphicFrame>
@@ -34729,7 +34729,7 @@
           <ns0:cNvPr id="10" name="">
             <a:extLst>
               <a:ext uri="{FF2B5EF4-FFF2-40B4-BE49-F238E27FC236}">
-                <ns2:creationId id="{45DCDBFF-763D-4364-B52F-D63554874468}"/>
+                <ns2:creationId id="{ED4CFAB9-766A-4530-A982-B599D6D2876E}"/>
               </a:ext>
             </a:extLst>
           </ns0:cNvPr>
@@ -34802,7 +34802,7 @@
           <ns0:cNvPr id="11" name="">
             <a:extLst>
               <a:ext uri="{FF2B5EF4-FFF2-40B4-BE49-F238E27FC236}">
-                <ns2:creationId id="{D849D32C-7247-4F71-A580-50C227EE2F81}"/>
+                <ns2:creationId id="{AC31D224-12F9-4D49-8470-CDDEB5835964}"/>
               </a:ext>
             </a:extLst>
           </ns0:cNvPr>
@@ -34833,7 +34833,7 @@
           <ns0:cNvPr id="12" name="Chart">
             <a:extLst>
               <a:ext uri="{FF2B5EF4-FFF2-40B4-BE49-F238E27FC236}">
-                <ns2:creationId id="{9D298DE6-86AB-4C3C-9C78-FE79366DEC26}"/>
+                <ns2:creationId id="{86D0437E-3BC8-464B-85F1-98B1DB8DCCCD}"/>
               </a:ext>
             </a:extLst>
           </ns0:cNvPr>
@@ -34846,7 +34846,7 @@
         </ns0:xfrm>
         <a:graphic>
           <a:graphicData uri="http://schemas.openxmlformats.org/drawingml/2006/chart">
-            <c:chart ns4:id="R99902a3bdf6f4d5a"/>
+            <c:chart ns4:id="R8daf4a8955c04a93"/>
           </a:graphicData>
         </a:graphic>
       </ns0:graphicFrame>
@@ -34855,7 +34855,7 @@
           <ns0:cNvPr id="13" name="">
             <a:extLst>
               <a:ext uri="{FF2B5EF4-FFF2-40B4-BE49-F238E27FC236}">
-                <ns2:creationId id="{E449C16C-6267-4337-B19D-FCC3E172BE25}"/>
+                <ns2:creationId id="{DB3AD0D4-4421-402C-9C7A-FE0542FC3D65}"/>
               </a:ext>
             </a:extLst>
           </ns0:cNvPr>
@@ -34886,7 +34886,7 @@
           <ns0:cNvPr id="14" name="">
             <a:extLst>
               <a:ext uri="{FF2B5EF4-FFF2-40B4-BE49-F238E27FC236}">
-                <ns2:creationId id="{6B4D1994-EDB8-4741-A054-1770E0008CBF}"/>
+                <ns2:creationId id="{78A86EB7-4052-4061-B663-0F34122616CA}"/>
               </a:ext>
             </a:extLst>
           </ns0:cNvPr>
@@ -34959,7 +34959,7 @@
           <ns0:cNvPr id="15" name="">
             <a:extLst>
               <a:ext uri="{FF2B5EF4-FFF2-40B4-BE49-F238E27FC236}">
-                <ns2:creationId id="{73613B20-FE03-42CA-ACB4-7955F36D7209}"/>
+                <ns2:creationId id="{8EBDC0E6-573B-45AD-BF15-9412C9FA28C3}"/>
               </a:ext>
             </a:extLst>
           </ns0:cNvPr>
@@ -34990,7 +34990,7 @@
           <ns0:cNvPr id="16" name="">
             <a:extLst>
               <a:ext uri="{FF2B5EF4-FFF2-40B4-BE49-F238E27FC236}">
-                <ns2:creationId id="{B8B5C0FE-B4A9-4B06-BC67-C50BA45D4A12}"/>
+                <ns2:creationId id="{F99D5312-ECAF-4073-BCF7-489EC46523E8}"/>
               </a:ext>
             </a:extLst>
           </ns0:cNvPr>
@@ -35063,7 +35063,7 @@
           <ns0:cNvPr id="17" name="">
             <a:extLst>
               <a:ext uri="{FF2B5EF4-FFF2-40B4-BE49-F238E27FC236}">
-                <ns2:creationId id="{DD5B4B55-2B5C-4428-BC9C-3E85E3A0A521}"/>
+                <ns2:creationId id="{00D61D0F-93AD-4A70-B6CD-3A48769877B9}"/>
               </a:ext>
             </a:extLst>
           </ns0:cNvPr>
@@ -35094,7 +35094,7 @@
           <ns0:cNvPr id="18" name="">
             <a:extLst>
               <a:ext uri="{FF2B5EF4-FFF2-40B4-BE49-F238E27FC236}">
-                <ns2:creationId id="{4FDDF959-550E-4AB3-B194-C8F8EA9713E2}"/>
+                <ns2:creationId id="{07C199BA-6977-4B79-BB12-1FB71B22AE4D}"/>
               </a:ext>
             </a:extLst>
           </ns0:cNvPr>
@@ -35165,7 +35165,7 @@
     </ns0:spTree>
     <ns0:extLst>
       <ns0:ext uri="{BB962C8B-B14F-4D97-AF65-F5344CB8AC3E}">
-        <ns5:creationId val="125351519"/>
+        <ns5:creationId val="65104781"/>
       </ns0:ext>
     </ns0:extLst>
   </ns0:cSld>
@@ -35196,7 +35196,7 @@
           <ns0:cNvPr id="21" name="">
             <a:extLst>
               <a:ext uri="{FF2B5EF4-FFF2-40B4-BE49-F238E27FC236}">
-                <ns2:creationId id="{68F2FCF6-31B5-4ABB-987B-55341F685803}"/>
+                <ns2:creationId id="{97194FD0-E227-4CCD-907E-7E6ECA2AE4A7}"/>
               </a:ext>
             </a:extLst>
           </ns0:cNvPr>
@@ -35269,7 +35269,7 @@
           <ns0:cNvPr id="2" name="">
             <a:extLst>
               <a:ext uri="{FF2B5EF4-FFF2-40B4-BE49-F238E27FC236}">
-                <ns2:creationId id="{F9D1313A-0A89-4443-95F5-3601A543775D}"/>
+                <ns2:creationId id="{9AC4C68D-88D3-4A48-AF45-3F9D5BBB093C}"/>
               </a:ext>
             </a:extLst>
           </ns0:cNvPr>
@@ -35342,7 +35342,7 @@
           <ns0:cNvPr id="3" name="">
             <a:extLst>
               <a:ext uri="{FF2B5EF4-FFF2-40B4-BE49-F238E27FC236}">
-                <ns2:creationId id="{56E6CBC0-6A7E-44D7-A38E-061EBA8DF1D5}"/>
+                <ns2:creationId id="{8C65867E-4237-4C18-9A5A-20CB4E4C1B9C}"/>
               </a:ext>
             </a:extLst>
           </ns0:cNvPr>
@@ -35373,7 +35373,7 @@
           <ns0:cNvPr id="4" name="">
             <a:extLst>
               <a:ext uri="{FF2B5EF4-FFF2-40B4-BE49-F238E27FC236}">
-                <ns2:creationId id="{96F22546-3289-419E-AD37-065082F2546C}"/>
+                <ns2:creationId id="{749FD81C-C151-47DA-A793-66A339235B71}"/>
               </a:ext>
             </a:extLst>
           </ns0:cNvPr>
@@ -35404,7 +35404,7 @@
           <ns0:cNvPr id="5" name="">
             <a:extLst>
               <a:ext uri="{FF2B5EF4-FFF2-40B4-BE49-F238E27FC236}">
-                <ns2:creationId id="{287541E8-007A-427F-BCA8-A7C46D0DBC91}"/>
+                <ns2:creationId id="{08348A7F-6D6B-4DD9-83A3-04C1B9E41884}"/>
               </a:ext>
             </a:extLst>
           </ns0:cNvPr>
@@ -35467,7 +35467,7 @@
                 <a:ea typeface="Arial"/>
                 <a:cs typeface="Arial"/>
               </a:rPr>
-              <a:t>Fonte: CVM/SRE, snapshot 8/out/26. Primárias encerradas, jan–ago/26; volume registrado.</a:t>
+              <a:t>Fonte: CVM/SRE, snapshot 10/out/26. Primárias encerradas, jan–ago/26; volume registrado.</a:t>
             </a:r>
           </a:p>
         </ns0:txBody>
@@ -35477,7 +35477,7 @@
           <ns0:cNvPr id="6" name="">
             <a:extLst>
               <a:ext uri="{FF2B5EF4-FFF2-40B4-BE49-F238E27FC236}">
-                <ns2:creationId id="{2D9ECE92-D644-419C-A7CD-E4C6F70CBA87}"/>
+                <ns2:creationId id="{C4CCB026-AB4F-4A6D-99FA-289EFEF1E8BE}"/>
               </a:ext>
             </a:extLst>
           </ns0:cNvPr>
@@ -35550,7 +35550,7 @@
           <ns0:cNvPr id="7" name="">
             <a:extLst>
               <a:ext uri="{FF2B5EF4-FFF2-40B4-BE49-F238E27FC236}">
-                <ns2:creationId id="{C7A24613-D1EF-462E-8D11-FA0684B36977}"/>
+                <ns2:creationId id="{C3F6EDFD-93A7-40D4-B588-DD257500F082}"/>
               </a:ext>
             </a:extLst>
           </ns0:cNvPr>
@@ -35623,7 +35623,7 @@
           <ns0:cNvPr id="8" name="">
             <a:extLst>
               <a:ext uri="{FF2B5EF4-FFF2-40B4-BE49-F238E27FC236}">
-                <ns2:creationId id="{1FE059F0-CE08-41BF-AE22-131E6CBFED1A}"/>
+                <ns2:creationId id="{2E602004-BE70-4524-B10F-17104EA45DDB}"/>
               </a:ext>
             </a:extLst>
           </ns0:cNvPr>
@@ -35654,7 +35654,7 @@
           <ns0:cNvPr id="9" name="Chart">
             <a:extLst>
               <a:ext uri="{FF2B5EF4-FFF2-40B4-BE49-F238E27FC236}">
-                <ns2:creationId id="{EEF1F989-0F9A-4CFD-8407-89480AE7C5D8}"/>
+                <ns2:creationId id="{AB274CBC-F65B-4ED8-9B2E-9FF00B8F06EF}"/>
               </a:ext>
             </a:extLst>
           </ns0:cNvPr>
@@ -35667,7 +35667,7 @@
         </ns0:xfrm>
         <a:graphic>
           <a:graphicData uri="http://schemas.openxmlformats.org/drawingml/2006/chart">
-            <c:chart ns4:id="R700fdb5dd10e4bfe"/>
+            <c:chart ns4:id="R6148424bd3ae48fe"/>
           </a:graphicData>
         </a:graphic>
       </ns0:graphicFrame>
@@ -35676,7 +35676,7 @@
           <ns0:cNvPr id="10" name="">
             <a:extLst>
               <a:ext uri="{FF2B5EF4-FFF2-40B4-BE49-F238E27FC236}">
-                <ns2:creationId id="{681B259F-0907-4187-A4E5-365398C65F62}"/>
+                <ns2:creationId id="{1F41B73C-A863-450C-B6C4-96083496732F}"/>
               </a:ext>
             </a:extLst>
           </ns0:cNvPr>
@@ -35749,7 +35749,7 @@
           <ns0:cNvPr id="11" name="">
             <a:extLst>
               <a:ext uri="{FF2B5EF4-FFF2-40B4-BE49-F238E27FC236}">
-                <ns2:creationId id="{8748B32D-CBF3-4FDF-9E4D-E4741675B729}"/>
+                <ns2:creationId id="{A635D1CA-4A15-465B-9651-9B8BB3DA88F8}"/>
               </a:ext>
             </a:extLst>
           </ns0:cNvPr>
@@ -35780,7 +35780,7 @@
           <ns0:cNvPr id="12" name="Chart">
             <a:extLst>
               <a:ext uri="{FF2B5EF4-FFF2-40B4-BE49-F238E27FC236}">
-                <ns2:creationId id="{5B4219D5-3191-402E-B899-591A54F635E3}"/>
+                <ns2:creationId id="{C4F0C20F-FFE0-4F15-8A1E-47513CB5892F}"/>
               </a:ext>
             </a:extLst>
           </ns0:cNvPr>
@@ -35793,7 +35793,7 @@
         </ns0:xfrm>
         <a:graphic>
           <a:graphicData uri="http://schemas.openxmlformats.org/drawingml/2006/chart">
-            <c:chart ns4:id="R92a092dd332d40e4"/>
+            <c:chart ns4:id="R7a73e7b9a4ca4492"/>
           </a:graphicData>
         </a:graphic>
       </ns0:graphicFrame>
@@ -35802,7 +35802,7 @@
           <ns0:cNvPr id="13" name="">
             <a:extLst>
               <a:ext uri="{FF2B5EF4-FFF2-40B4-BE49-F238E27FC236}">
-                <ns2:creationId id="{036887EC-E50B-4C77-9EC0-5CA0A93CA376}"/>
+                <ns2:creationId id="{F05ED0E3-E878-4283-A001-031B2E9D6947}"/>
               </a:ext>
             </a:extLst>
           </ns0:cNvPr>
@@ -35833,7 +35833,7 @@
           <ns0:cNvPr id="14" name="">
             <a:extLst>
               <a:ext uri="{FF2B5EF4-FFF2-40B4-BE49-F238E27FC236}">
-                <ns2:creationId id="{17E6996E-B312-4AD3-80D2-C87E6CCDC325}"/>
+                <ns2:creationId id="{8D35E9BC-5003-4144-8F95-8183DD09E0D0}"/>
               </a:ext>
             </a:extLst>
           </ns0:cNvPr>
@@ -35906,7 +35906,7 @@
           <ns0:cNvPr id="15" name="">
             <a:extLst>
               <a:ext uri="{FF2B5EF4-FFF2-40B4-BE49-F238E27FC236}">
-                <ns2:creationId id="{950F1CE8-04A6-4A36-94C2-B2C1DAB94DF7}"/>
+                <ns2:creationId id="{D131A626-7069-479B-A515-C6CEA68AC5CF}"/>
               </a:ext>
             </a:extLst>
           </ns0:cNvPr>
@@ -35937,7 +35937,7 @@
           <ns0:cNvPr id="16" name="">
             <a:extLst>
               <a:ext uri="{FF2B5EF4-FFF2-40B4-BE49-F238E27FC236}">
-                <ns2:creationId id="{F8242012-6A74-4757-8DCF-419F44A983EE}"/>
+                <ns2:creationId id="{0294EAD9-12C8-4746-B2A1-C9263C9C46DE}"/>
               </a:ext>
             </a:extLst>
           </ns0:cNvPr>
@@ -36010,7 +36010,7 @@
           <ns0:cNvPr id="17" name="">
             <a:extLst>
               <a:ext uri="{FF2B5EF4-FFF2-40B4-BE49-F238E27FC236}">
-                <ns2:creationId id="{AC417A42-FDA7-4866-8472-7F43B39A0DFD}"/>
+                <ns2:creationId id="{EA407789-C7BF-4292-A363-8FDD21478A6E}"/>
               </a:ext>
             </a:extLst>
           </ns0:cNvPr>
@@ -36041,7 +36041,7 @@
           <ns0:cNvPr id="18" name="">
             <a:extLst>
               <a:ext uri="{FF2B5EF4-FFF2-40B4-BE49-F238E27FC236}">
-                <ns2:creationId id="{ADD2CF2A-3226-4913-BF8F-AF08E6F990FF}"/>
+                <ns2:creationId id="{50374AD0-0766-4B59-A0AF-2BA4CB94BCC5}"/>
               </a:ext>
             </a:extLst>
           </ns0:cNvPr>
@@ -36114,7 +36114,7 @@
           <ns0:cNvPr id="19" name="">
             <a:extLst>
               <a:ext uri="{FF2B5EF4-FFF2-40B4-BE49-F238E27FC236}">
-                <ns2:creationId id="{F36D8F1E-851F-408D-B780-0D59C88EF5C0}"/>
+                <ns2:creationId id="{EAC96018-890B-49B3-AFC8-0F043CDDADD9}"/>
               </a:ext>
             </a:extLst>
           </ns0:cNvPr>
@@ -37293,7 +37293,7 @@
           <ns0:cNvPr id="20" name="">
             <a:extLst>
               <a:ext uri="{FF2B5EF4-FFF2-40B4-BE49-F238E27FC236}">
-                <ns2:creationId id="{5C163A61-FB27-4499-B596-99CD85FF93B1}"/>
+                <ns2:creationId id="{D6DA4DE6-8814-4FC6-A5A0-2EB7869BE901}"/>
               </a:ext>
             </a:extLst>
           </ns0:cNvPr>
@@ -37364,7 +37364,7 @@
     </ns0:spTree>
     <ns0:extLst>
       <ns0:ext uri="{BB962C8B-B14F-4D97-AF65-F5344CB8AC3E}">
-        <ns5:creationId val="1733738317"/>
+        <ns5:creationId val="1125199023"/>
       </ns0:ext>
     </ns0:extLst>
   </ns0:cSld>
@@ -37395,7 +37395,7 @@
           <ns0:cNvPr id="31" name="">
             <a:extLst>
               <a:ext uri="{FF2B5EF4-FFF2-40B4-BE49-F238E27FC236}">
-                <ns2:creationId id="{404F1718-3BC2-4B88-A152-E510E4AEEDAF}"/>
+                <ns2:creationId id="{5EF9692D-6F4E-4A38-A203-1B882021C6B6}"/>
               </a:ext>
             </a:extLst>
           </ns0:cNvPr>
@@ -37468,7 +37468,7 @@
           <ns0:cNvPr id="2" name="">
             <a:extLst>
               <a:ext uri="{FF2B5EF4-FFF2-40B4-BE49-F238E27FC236}">
-                <ns2:creationId id="{A179D922-3A48-40D1-882E-30A71E845DB8}"/>
+                <ns2:creationId id="{75CD0703-4911-4A0A-B708-3FB1418D73FF}"/>
               </a:ext>
             </a:extLst>
           </ns0:cNvPr>
@@ -37541,7 +37541,7 @@
           <ns0:cNvPr id="3" name="">
             <a:extLst>
               <a:ext uri="{FF2B5EF4-FFF2-40B4-BE49-F238E27FC236}">
-                <ns2:creationId id="{63F87F8B-68FC-4FC2-8F88-871AC9C577E9}"/>
+                <ns2:creationId id="{67F15791-4F1A-4FBA-B089-64CCDF87F3C3}"/>
               </a:ext>
             </a:extLst>
           </ns0:cNvPr>
@@ -37572,7 +37572,7 @@
           <ns0:cNvPr id="4" name="">
             <a:extLst>
               <a:ext uri="{FF2B5EF4-FFF2-40B4-BE49-F238E27FC236}">
-                <ns2:creationId id="{129A3AEA-4951-4C8E-BA72-AA5FB7CBA4DC}"/>
+                <ns2:creationId id="{E9BA5BA5-F0D6-4648-8196-66FE5D7E5176}"/>
               </a:ext>
             </a:extLst>
           </ns0:cNvPr>
@@ -37603,7 +37603,7 @@
           <ns0:cNvPr id="5" name="">
             <a:extLst>
               <a:ext uri="{FF2B5EF4-FFF2-40B4-BE49-F238E27FC236}">
-                <ns2:creationId id="{E45D96DF-8C50-4A94-AE3F-26634EFEEE66}"/>
+                <ns2:creationId id="{741507AD-BE41-4EC8-B879-62DD29D536F8}"/>
               </a:ext>
             </a:extLst>
           </ns0:cNvPr>
@@ -37666,7 +37666,7 @@
                 <a:ea typeface="Arial"/>
                 <a:cs typeface="Arial"/>
               </a:rPr>
-              <a:t>Fonte: CVM/SRE, snapshot 8/out/26. Primárias encerradas, jan–ago/26; volume registrado.</a:t>
+              <a:t>Fonte: CVM/SRE, snapshot 10/out/26. Primárias encerradas, jan–ago/26; volume registrado.</a:t>
             </a:r>
           </a:p>
         </ns0:txBody>
@@ -37676,7 +37676,7 @@
           <ns0:cNvPr id="6" name="">
             <a:extLst>
               <a:ext uri="{FF2B5EF4-FFF2-40B4-BE49-F238E27FC236}">
-                <ns2:creationId id="{8060DBE6-A170-4CD7-89D5-21692877DD05}"/>
+                <ns2:creationId id="{6DF81132-D55B-4DC3-B0D6-119D9F4680D2}"/>
               </a:ext>
             </a:extLst>
           </ns0:cNvPr>
@@ -37749,7 +37749,7 @@
           <ns0:cNvPr id="7" name="">
             <a:extLst>
               <a:ext uri="{FF2B5EF4-FFF2-40B4-BE49-F238E27FC236}">
-                <ns2:creationId id="{377E21B9-213A-44B9-BDD9-3CA58DD7F64D}"/>
+                <ns2:creationId id="{F24B9589-556E-4CFC-A73C-016CB894C970}"/>
               </a:ext>
             </a:extLst>
           </ns0:cNvPr>
@@ -37822,7 +37822,7 @@
           <ns0:cNvPr id="8" name="">
             <a:extLst>
               <a:ext uri="{FF2B5EF4-FFF2-40B4-BE49-F238E27FC236}">
-                <ns2:creationId id="{CFBD159F-4C69-4818-B3C4-A8458BC2DE52}"/>
+                <ns2:creationId id="{4BFA260E-4D56-4E32-BB0C-51A123234381}"/>
               </a:ext>
             </a:extLst>
           </ns0:cNvPr>
@@ -37853,7 +37853,7 @@
           <ns0:cNvPr id="9" name="Chart">
             <a:extLst>
               <a:ext uri="{FF2B5EF4-FFF2-40B4-BE49-F238E27FC236}">
-                <ns2:creationId id="{957D18CC-B529-4149-A696-709633C72D23}"/>
+                <ns2:creationId id="{7099FA28-EE7B-4D50-AE4F-FD2D2D543B9E}"/>
               </a:ext>
             </a:extLst>
           </ns0:cNvPr>
@@ -37866,7 +37866,7 @@
         </ns0:xfrm>
         <a:graphic>
           <a:graphicData uri="http://schemas.openxmlformats.org/drawingml/2006/chart">
-            <c:chart ns4:id="R35477c08c8ac4477"/>
+            <c:chart ns4:id="Rb5ee1e44aee341b0"/>
           </a:graphicData>
         </a:graphic>
       </ns0:graphicFrame>
@@ -37875,7 +37875,7 @@
           <ns0:cNvPr id="10" name="">
             <a:extLst>
               <a:ext uri="{FF2B5EF4-FFF2-40B4-BE49-F238E27FC236}">
-                <ns2:creationId id="{A07CBC15-4AB3-471B-B51B-BB25DC1E6A5B}"/>
+                <ns2:creationId id="{F972FD5E-DF7A-452F-8176-060DCD71E486}"/>
               </a:ext>
             </a:extLst>
           </ns0:cNvPr>
@@ -37948,7 +37948,7 @@
           <ns0:cNvPr id="11" name="">
             <a:extLst>
               <a:ext uri="{FF2B5EF4-FFF2-40B4-BE49-F238E27FC236}">
-                <ns2:creationId id="{11260762-20E5-4FF1-9C47-D502E7E5309E}"/>
+                <ns2:creationId id="{1E27E855-A31E-4270-BAE5-42F7347A674E}"/>
               </a:ext>
             </a:extLst>
           </ns0:cNvPr>
@@ -37979,7 +37979,7 @@
           <ns0:cNvPr id="12" name="Chart">
             <a:extLst>
               <a:ext uri="{FF2B5EF4-FFF2-40B4-BE49-F238E27FC236}">
-                <ns2:creationId id="{E81A9896-FE2F-489E-A3BE-525C98BFFDB6}"/>
+                <ns2:creationId id="{787D3E0D-5072-4FE4-BF65-F5D4C61D9CB2}"/>
               </a:ext>
             </a:extLst>
           </ns0:cNvPr>
@@ -37992,7 +37992,7 @@
         </ns0:xfrm>
         <a:graphic>
           <a:graphicData uri="http://schemas.openxmlformats.org/drawingml/2006/chart">
-            <c:chart ns4:id="R40af07843fc0489a"/>
+            <c:chart ns4:id="Ra3651446f72949f0"/>
           </a:graphicData>
         </a:graphic>
       </ns0:graphicFrame>
@@ -38001,7 +38001,7 @@
           <ns0:cNvPr id="13" name="">
             <a:extLst>
               <a:ext uri="{FF2B5EF4-FFF2-40B4-BE49-F238E27FC236}">
-                <ns2:creationId id="{F9B9F390-4CC4-4B60-BCF4-30E4EE1B4B09}"/>
+                <ns2:creationId id="{BD2E23A8-91AF-4C88-BD19-DA9E3ADD5C6F}"/>
               </a:ext>
             </a:extLst>
           </ns0:cNvPr>
@@ -38074,7 +38074,7 @@
           <ns0:cNvPr id="14" name="">
             <a:extLst>
               <a:ext uri="{FF2B5EF4-FFF2-40B4-BE49-F238E27FC236}">
-                <ns2:creationId id="{C6F9E88A-1E95-49F1-99FD-82A19F693020}"/>
+                <ns2:creationId id="{5F68E048-4EB8-402E-ADB9-FBA62DBF4574}"/>
               </a:ext>
             </a:extLst>
           </ns0:cNvPr>
@@ -38105,7 +38105,7 @@
           <ns0:cNvPr id="15" name="Chart">
             <a:extLst>
               <a:ext uri="{FF2B5EF4-FFF2-40B4-BE49-F238E27FC236}">
-                <ns2:creationId id="{9C7CE1A0-86A4-4C50-AFC2-8E21816C5BF7}"/>
+                <ns2:creationId id="{906A2E0F-C19C-4AF0-B84C-F288281DAFA7}"/>
               </a:ext>
             </a:extLst>
           </ns0:cNvPr>
@@ -38118,7 +38118,7 @@
         </ns0:xfrm>
         <a:graphic>
           <a:graphicData uri="http://schemas.openxmlformats.org/drawingml/2006/chart">
-            <c:chart ns4:id="R513703b73cd84959"/>
+            <c:chart ns4:id="R33750771483b47f3"/>
           </a:graphicData>
         </a:graphic>
       </ns0:graphicFrame>
@@ -38127,7 +38127,7 @@
           <ns0:cNvPr id="16" name="">
             <a:extLst>
               <a:ext uri="{FF2B5EF4-FFF2-40B4-BE49-F238E27FC236}">
-                <ns2:creationId id="{C80BF549-915E-4822-94E8-F95C03042231}"/>
+                <ns2:creationId id="{32C053C5-867F-4BC1-93D0-0B523A1BAA8C}"/>
               </a:ext>
             </a:extLst>
           </ns0:cNvPr>
@@ -38158,7 +38158,7 @@
           <ns0:cNvPr id="17" name="">
             <a:extLst>
               <a:ext uri="{FF2B5EF4-FFF2-40B4-BE49-F238E27FC236}">
-                <ns2:creationId id="{254A6B25-495E-465D-8D7A-ABDFF41307ED}"/>
+                <ns2:creationId id="{0BC5DB2F-FEA4-4BD9-90F7-CC88FB804C50}"/>
               </a:ext>
             </a:extLst>
           </ns0:cNvPr>
@@ -38231,7 +38231,7 @@
           <ns0:cNvPr id="18" name="">
             <a:extLst>
               <a:ext uri="{FF2B5EF4-FFF2-40B4-BE49-F238E27FC236}">
-                <ns2:creationId id="{F6D3A178-F0DA-4E70-B09C-715849CA83EE}"/>
+                <ns2:creationId id="{639274AA-F883-4827-931B-E09F549B4E9F}"/>
               </a:ext>
             </a:extLst>
           </ns0:cNvPr>
@@ -38262,7 +38262,7 @@
           <ns0:cNvPr id="19" name="">
             <a:extLst>
               <a:ext uri="{FF2B5EF4-FFF2-40B4-BE49-F238E27FC236}">
-                <ns2:creationId id="{519571D6-2201-4CF8-89D6-EC4E715AE29B}"/>
+                <ns2:creationId id="{37255634-6DC8-4D3D-A02B-0631B73ABFE9}"/>
               </a:ext>
             </a:extLst>
           </ns0:cNvPr>
@@ -38335,7 +38335,7 @@
           <ns0:cNvPr id="20" name="">
             <a:extLst>
               <a:ext uri="{FF2B5EF4-FFF2-40B4-BE49-F238E27FC236}">
-                <ns2:creationId id="{EFA76F27-3CC8-4BAB-AD7E-603E56D8B495}"/>
+                <ns2:creationId id="{4E9E09A0-259E-42C9-918A-81A54B06CCEF}"/>
               </a:ext>
             </a:extLst>
           </ns0:cNvPr>
@@ -38366,7 +38366,7 @@
           <ns0:cNvPr id="21" name="">
             <a:extLst>
               <a:ext uri="{FF2B5EF4-FFF2-40B4-BE49-F238E27FC236}">
-                <ns2:creationId id="{C62698EC-53FC-4C4D-A026-94F33CB45D77}"/>
+                <ns2:creationId id="{5B085228-C75F-4815-BBC6-F1C11D1D0CDC}"/>
               </a:ext>
             </a:extLst>
           </ns0:cNvPr>
@@ -38439,7 +38439,7 @@
           <ns0:cNvPr id="22" name="">
             <a:extLst>
               <a:ext uri="{FF2B5EF4-FFF2-40B4-BE49-F238E27FC236}">
-                <ns2:creationId id="{90CF6BEC-3A1D-427C-8E1C-1D68B327D99B}"/>
+                <ns2:creationId id="{C7988CB3-C4B5-4B86-B43E-C9A90A4DCED2}"/>
               </a:ext>
             </a:extLst>
           </ns0:cNvPr>
@@ -38512,7 +38512,7 @@
           <ns0:cNvPr id="23" name="">
             <a:extLst>
               <a:ext uri="{FF2B5EF4-FFF2-40B4-BE49-F238E27FC236}">
-                <ns2:creationId id="{AEA31795-633A-4A13-A7D5-8DE5B5712E26}"/>
+                <ns2:creationId id="{A3F154A2-B3BC-440A-A218-32FCF9AED72E}"/>
               </a:ext>
             </a:extLst>
           </ns0:cNvPr>
@@ -38585,7 +38585,7 @@
           <ns0:cNvPr id="24" name="">
             <a:extLst>
               <a:ext uri="{FF2B5EF4-FFF2-40B4-BE49-F238E27FC236}">
-                <ns2:creationId id="{2444D199-B798-4D64-8E94-A7DB5846D578}"/>
+                <ns2:creationId id="{8023484D-1F99-420F-8066-6B781E75004E}"/>
               </a:ext>
             </a:extLst>
           </ns0:cNvPr>
@@ -38658,7 +38658,7 @@
           <ns0:cNvPr id="25" name="">
             <a:extLst>
               <a:ext uri="{FF2B5EF4-FFF2-40B4-BE49-F238E27FC236}">
-                <ns2:creationId id="{D38B10DF-9E05-4F3A-88CD-7DE52755DBDC}"/>
+                <ns2:creationId id="{71037761-0D6F-4F97-BDDD-8E39165AF2C9}"/>
               </a:ext>
             </a:extLst>
           </ns0:cNvPr>
@@ -38689,7 +38689,7 @@
           <ns0:cNvPr id="26" name="">
             <a:extLst>
               <a:ext uri="{FF2B5EF4-FFF2-40B4-BE49-F238E27FC236}">
-                <ns2:creationId id="{2DD8C78E-D58C-4B3D-AD08-16A444EE869F}"/>
+                <ns2:creationId id="{C2C2F19E-5D26-4DBD-871E-1E9FDC1B2FF5}"/>
               </a:ext>
             </a:extLst>
           </ns0:cNvPr>
@@ -38762,7 +38762,7 @@
           <ns0:cNvPr id="27" name="">
             <a:extLst>
               <a:ext uri="{FF2B5EF4-FFF2-40B4-BE49-F238E27FC236}">
-                <ns2:creationId id="{77D3A77B-57DC-45E3-88FD-ECB54E99A517}"/>
+                <ns2:creationId id="{16D90A22-BFD2-486E-8CEA-26EE62399C0E}"/>
               </a:ext>
             </a:extLst>
           </ns0:cNvPr>
@@ -38835,7 +38835,7 @@
           <ns0:cNvPr id="28" name="">
             <a:extLst>
               <a:ext uri="{FF2B5EF4-FFF2-40B4-BE49-F238E27FC236}">
-                <ns2:creationId id="{CF7F9C01-3CF2-45DE-9BED-8D8C4D056DDF}"/>
+                <ns2:creationId id="{F9F174E3-772B-45ED-8474-155C7828DEFC}"/>
               </a:ext>
             </a:extLst>
           </ns0:cNvPr>
@@ -38866,7 +38866,7 @@
           <ns0:cNvPr id="29" name="">
             <a:extLst>
               <a:ext uri="{FF2B5EF4-FFF2-40B4-BE49-F238E27FC236}">
-                <ns2:creationId id="{1770D7A2-4D71-4288-9A34-9D2EBD24D69A}"/>
+                <ns2:creationId id="{71B50436-6FC6-42F1-B8C2-E222F761B26D}"/>
               </a:ext>
             </a:extLst>
           </ns0:cNvPr>
@@ -38939,7 +38939,7 @@
           <ns0:cNvPr id="30" name="">
             <a:extLst>
               <a:ext uri="{FF2B5EF4-FFF2-40B4-BE49-F238E27FC236}">
-                <ns2:creationId id="{56F82467-A13B-43E6-BFF6-E32ACCBD2883}"/>
+                <ns2:creationId id="{5DAF9D7F-B251-452E-BC8F-3012280D38E7}"/>
               </a:ext>
             </a:extLst>
           </ns0:cNvPr>
@@ -39010,7 +39010,7 @@
     </ns0:spTree>
     <ns0:extLst>
       <ns0:ext uri="{BB962C8B-B14F-4D97-AF65-F5344CB8AC3E}">
-        <ns5:creationId val="1682169864"/>
+        <ns5:creationId val="654978255"/>
       </ns0:ext>
     </ns0:extLst>
   </ns0:cSld>

</xml_diff>